<commit_message>
Label figures as IL18 transcript (pro-IL-18) to state the equivalence
Figure legends now read '% cells IL18 transcript+', colour scales carry
'IL18 transcript (pro-IL-18)', and deck captions name the measured quantity.
Clarifies that the axes measure the IL18 transcript, which is the pro-IL-18
transcript signal (pro vs mature is a protein-level distinction).

Co-Authored-By: Claude Opus 4.8 <noreply@anthropic.com>
Claude-Session: https://claude.ai/code/session_017TbtQvXEFqesh7AxtExDwE
</commit_message>
<xml_diff>
--- a/il18_lung/IL18_lung_celltype.pptx
+++ b/il18_lung/IL18_lung_celltype.pptx
@@ -3668,7 +3668,7 @@
                 <a:ea typeface="Microsoft YaHei" pitchFamily="34" charset="-122"/>
                 <a:cs typeface="Microsoft YaHei" pitchFamily="34" charset="-120"/>
               </a:rPr>
-              <a:t>点大小=供体中位阳性比例；颜色=数据集内排序（1=最高）。空心点=环境 RNA 未校正的上皮类，不用于结论。</a:t>
+              <a:t>测量对象：IL18 转录本（pro-IL-18）。点大小=供体中位阳性比例；颜色=数据集内排序（1=最高）。空心点=环境 RNA 未校正的上皮类，不用于结论。</a:t>
             </a:r>
             <a:endParaRPr lang="en-US" sz="1050" dirty="0"/>
           </a:p>
@@ -3834,7 +3834,7 @@
                 <a:ea typeface="Microsoft YaHei" pitchFamily="34" charset="-122"/>
                 <a:cs typeface="Microsoft YaHei" pitchFamily="34" charset="-120"/>
               </a:rPr>
-              <a:t>肺泡巨噬细胞在静息、流感、细菌、LPS 全部条件下均排名第一。带 * 为自行注释的 LPS 数据集。流感仅示 d42。</a:t>
+              <a:t>测量对象：IL18 转录本（pro-IL-18）。肺泡巨噬细胞在静息、流感、细菌、LPS 全部条件下均排名第一。带 * 为自行注释的 LPS 数据集。流感仅示 d42。</a:t>
             </a:r>
             <a:endParaRPr lang="en-US" sz="1050" dirty="0"/>
           </a:p>

</xml_diff>

<commit_message>
Deck: strip to 8 plain slides; keep data sources and key explanations
Removes decorative cards, accent numbers, bullet dots, dark fills and kicker
labels, and the redundant flu-timecourse and closing slides. Keeps the
pro-IL-18 declaration, method, ambient-correction and zero-value explanations,
and adds an explicit database-source list.

Co-Authored-By: Claude Opus 4.8 <noreply@anthropic.com>
Claude-Session: https://claude.ai/code/session_017TbtQvXEFqesh7AxtExDwE
</commit_message>
<xml_diff>
--- a/il18_lung/IL18_lung_celltype.pptx
+++ b/il18_lung/IL18_lung_celltype.pptx
@@ -13,11 +13,9 @@
     <p:sldId id="261" r:id="rId7"/>
     <p:sldId id="262" r:id="rId8"/>
     <p:sldId id="263" r:id="rId9"/>
-    <p:sldId id="264" r:id="rId10"/>
-    <p:sldId id="265" r:id="rId11"/>
   </p:sldIdLst>
   <p:notesMasterIdLst>
-    <p:notesMasterId r:id="rId12"/>
+    <p:notesMasterId r:id="rId10"/>
   </p:notesMasterIdLst>
   <p:sldSz cx="12192000" cy="6858000"/>
   <p:notesSz cx="6858000" cy="12192000"/>
@@ -553,94 +551,6 @@
 </p:notes>
 </file>
 
-<file path=ppt/notesSlides/notesSlide10.xml><?xml version="1.0" encoding="utf-8"?>
-<p:notes xmlns:a="http://schemas.openxmlformats.org/drawingml/2006/main" xmlns:r="http://schemas.openxmlformats.org/officeDocument/2006/relationships" xmlns:p="http://schemas.openxmlformats.org/presentationml/2006/main">
-  <p:cSld>
-    <p:spTree>
-      <p:nvGrpSpPr>
-        <p:cNvPr id="1" name=""/>
-        <p:cNvGrpSpPr/>
-        <p:nvPr/>
-      </p:nvGrpSpPr>
-      <p:grpSpPr>
-        <a:xfrm>
-          <a:off x="0" y="0"/>
-          <a:ext cx="0" cy="0"/>
-          <a:chOff x="0" y="0"/>
-          <a:chExt cx="0" cy="0"/>
-        </a:xfrm>
-      </p:grpSpPr>
-      <p:sp>
-        <p:nvSpPr>
-          <p:cNvPr id="2" name="Slide Image Placeholder 1"/>
-          <p:cNvSpPr>
-            <a:spLocks noGrp="1" noRot="1" noChangeAspect="1"/>
-          </p:cNvSpPr>
-          <p:nvPr>
-            <p:ph type="sldImg"/>
-          </p:nvPr>
-        </p:nvSpPr>
-        <p:spPr/>
-      </p:sp>
-      <p:sp>
-        <p:nvSpPr>
-          <p:cNvPr id="3" name="Notes Placeholder 2"/>
-          <p:cNvSpPr>
-            <a:spLocks noGrp="1"/>
-          </p:cNvSpPr>
-          <p:nvPr>
-            <p:ph type="body" idx="1"/>
-          </p:nvPr>
-        </p:nvSpPr>
-        <p:spPr/>
-        <p:txBody>
-          <a:bodyPr/>
-          <a:lstStyle/>
-          <a:p>
-            <a:r>
-              <a:rPr lang="en-US" dirty="0"/>
-              <a:t/>
-            </a:r>
-            <a:endParaRPr lang="en-US" dirty="0"/>
-          </a:p>
-        </p:txBody>
-      </p:sp>
-      <p:sp>
-        <p:nvSpPr>
-          <p:cNvPr id="4" name="Slide Number Placeholder 3"/>
-          <p:cNvSpPr>
-            <a:spLocks noGrp="1"/>
-          </p:cNvSpPr>
-          <p:nvPr>
-            <p:ph type="sldNum" sz="quarter" idx="10"/>
-          </p:nvPr>
-        </p:nvSpPr>
-        <p:spPr/>
-        <p:txBody>
-          <a:bodyPr/>
-          <a:lstStyle/>
-          <a:p>
-            <a:fld id="{F7021451-1387-4CA6-816F-3879F97B5CBC}" type="slidenum">
-              <a:rPr lang="en-US"/>
-              <a:t>10</a:t>
-            </a:fld>
-            <a:endParaRPr lang="en-US"/>
-          </a:p>
-        </p:txBody>
-      </p:sp>
-    </p:spTree>
-    <p:extLst>
-      <p:ext uri="{BB962C8B-B14F-4D97-AF65-F5344CB8AC3E}">
-        <p14:creationId xmlns:p14="http://schemas.microsoft.com/office/powerpoint/2010/main" val="1024086991"/>
-      </p:ext>
-    </p:extLst>
-  </p:cSld>
-  <p:clrMapOvr>
-    <a:masterClrMapping/>
-  </p:clrMapOvr>
-</p:notes>
-</file>
-
 <file path=ppt/notesSlides/notesSlide2.xml><?xml version="1.0" encoding="utf-8"?>
 <p:notes xmlns:a="http://schemas.openxmlformats.org/drawingml/2006/main" xmlns:r="http://schemas.openxmlformats.org/officeDocument/2006/relationships" xmlns:p="http://schemas.openxmlformats.org/presentationml/2006/main">
   <p:cSld>
@@ -1239,94 +1149,6 @@
             <a:fld id="{F7021451-1387-4CA6-816F-3879F97B5CBC}" type="slidenum">
               <a:rPr lang="en-US"/>
               <a:t>8</a:t>
-            </a:fld>
-            <a:endParaRPr lang="en-US"/>
-          </a:p>
-        </p:txBody>
-      </p:sp>
-    </p:spTree>
-    <p:extLst>
-      <p:ext uri="{BB962C8B-B14F-4D97-AF65-F5344CB8AC3E}">
-        <p14:creationId xmlns:p14="http://schemas.microsoft.com/office/powerpoint/2010/main" val="1024086991"/>
-      </p:ext>
-    </p:extLst>
-  </p:cSld>
-  <p:clrMapOvr>
-    <a:masterClrMapping/>
-  </p:clrMapOvr>
-</p:notes>
-</file>
-
-<file path=ppt/notesSlides/notesSlide9.xml><?xml version="1.0" encoding="utf-8"?>
-<p:notes xmlns:a="http://schemas.openxmlformats.org/drawingml/2006/main" xmlns:r="http://schemas.openxmlformats.org/officeDocument/2006/relationships" xmlns:p="http://schemas.openxmlformats.org/presentationml/2006/main">
-  <p:cSld>
-    <p:spTree>
-      <p:nvGrpSpPr>
-        <p:cNvPr id="1" name=""/>
-        <p:cNvGrpSpPr/>
-        <p:nvPr/>
-      </p:nvGrpSpPr>
-      <p:grpSpPr>
-        <a:xfrm>
-          <a:off x="0" y="0"/>
-          <a:ext cx="0" cy="0"/>
-          <a:chOff x="0" y="0"/>
-          <a:chExt cx="0" cy="0"/>
-        </a:xfrm>
-      </p:grpSpPr>
-      <p:sp>
-        <p:nvSpPr>
-          <p:cNvPr id="2" name="Slide Image Placeholder 1"/>
-          <p:cNvSpPr>
-            <a:spLocks noGrp="1" noRot="1" noChangeAspect="1"/>
-          </p:cNvSpPr>
-          <p:nvPr>
-            <p:ph type="sldImg"/>
-          </p:nvPr>
-        </p:nvSpPr>
-        <p:spPr/>
-      </p:sp>
-      <p:sp>
-        <p:nvSpPr>
-          <p:cNvPr id="3" name="Notes Placeholder 2"/>
-          <p:cNvSpPr>
-            <a:spLocks noGrp="1"/>
-          </p:cNvSpPr>
-          <p:nvPr>
-            <p:ph type="body" idx="1"/>
-          </p:nvPr>
-        </p:nvSpPr>
-        <p:spPr/>
-        <p:txBody>
-          <a:bodyPr/>
-          <a:lstStyle/>
-          <a:p>
-            <a:r>
-              <a:rPr lang="en-US" dirty="0"/>
-              <a:t/>
-            </a:r>
-            <a:endParaRPr lang="en-US" dirty="0"/>
-          </a:p>
-        </p:txBody>
-      </p:sp>
-      <p:sp>
-        <p:nvSpPr>
-          <p:cNvPr id="4" name="Slide Number Placeholder 3"/>
-          <p:cNvSpPr>
-            <a:spLocks noGrp="1"/>
-          </p:cNvSpPr>
-          <p:nvPr>
-            <p:ph type="sldNum" sz="quarter" idx="10"/>
-          </p:nvPr>
-        </p:nvSpPr>
-        <p:spPr/>
-        <p:txBody>
-          <a:bodyPr/>
-          <a:lstStyle/>
-          <a:p>
-            <a:fld id="{F7021451-1387-4CA6-816F-3879F97B5CBC}" type="slidenum">
-              <a:rPr lang="en-US"/>
-              <a:t>9</a:t>
             </a:fld>
             <a:endParaRPr lang="en-US"/>
           </a:p>
@@ -1655,13 +1477,6 @@
 <file path=ppt/slides/slide1.xml><?xml version="1.0" encoding="utf-8"?>
 <p:sld xmlns:a="http://schemas.openxmlformats.org/drawingml/2006/main" xmlns:r="http://schemas.openxmlformats.org/officeDocument/2006/relationships" xmlns:p="http://schemas.openxmlformats.org/presentationml/2006/main">
   <p:cSld name="Slide 1">
-    <p:bg>
-      <p:bgPr>
-        <a:solidFill>
-          <a:srgbClr val="16233E"/>
-        </a:solidFill>
-      </p:bgPr>
-    </p:bg>
     <p:spTree>
       <p:nvGrpSpPr>
         <p:cNvPr id="1" name=""/>
@@ -1684,8 +1499,8 @@
         </p:nvSpPr>
         <p:spPr>
           <a:xfrm>
-            <a:off x="822960" y="2148840"/>
-            <a:ext cx="10515600" cy="822960"/>
+            <a:off x="640080" y="2057400"/>
+            <a:ext cx="10972800" cy="822960"/>
           </a:xfrm>
           <a:prstGeom prst="rect">
             <a:avLst/>
@@ -1701,17 +1516,17 @@
               <a:buNone/>
             </a:pPr>
             <a:r>
-              <a:rPr lang="en-US" sz="4000" b="1" dirty="0">
+              <a:rPr lang="en-US" sz="3400" b="1" dirty="0">
                 <a:solidFill>
-                  <a:srgbClr val="FFFFFF"/>
+                  <a:srgbClr val="1A1A1A"/>
                 </a:solidFill>
                 <a:latin typeface="Microsoft YaHei" pitchFamily="34" charset="0"/>
                 <a:ea typeface="Microsoft YaHei" pitchFamily="34" charset="-122"/>
                 <a:cs typeface="Microsoft YaHei" pitchFamily="34" charset="-120"/>
               </a:rPr>
-              <a:t>肺内 pro-IL-18 转录的细胞类型谱</a:t>
-            </a:r>
-            <a:endParaRPr lang="en-US" sz="4000" dirty="0"/>
+              <a:t>肺内 IL18 转录（pro-IL-18）的细胞类型谱</a:t>
+            </a:r>
+            <a:endParaRPr lang="en-US" sz="3400" dirty="0"/>
           </a:p>
         </p:txBody>
       </p:sp>
@@ -1723,8 +1538,8 @@
         </p:nvSpPr>
         <p:spPr>
           <a:xfrm>
-            <a:off x="822960" y="3063240"/>
-            <a:ext cx="10515600" cy="457200"/>
+            <a:off x="640080" y="2926080"/>
+            <a:ext cx="10972800" cy="457200"/>
           </a:xfrm>
           <a:prstGeom prst="rect">
             <a:avLst/>
@@ -1740,17 +1555,17 @@
               <a:buNone/>
             </a:pPr>
             <a:r>
-              <a:rPr lang="en-US" sz="1800" dirty="0">
+              <a:rPr lang="en-US" sz="1600" dirty="0">
                 <a:solidFill>
-                  <a:srgbClr val="C7D0E0"/>
+                  <a:srgbClr val="6B6B6B"/>
                 </a:solidFill>
                 <a:latin typeface="Microsoft YaHei" pitchFamily="34" charset="0"/>
                 <a:ea typeface="Microsoft YaHei" pitchFamily="34" charset="-122"/>
                 <a:cs typeface="Microsoft YaHei" pitchFamily="34" charset="-120"/>
               </a:rPr>
-              <a:t>人与小鼠 · 静息与病原感染 · 单细胞转录组 + 分选 bulk 交叉验证</a:t>
-            </a:r>
-            <a:endParaRPr lang="en-US" sz="1800" dirty="0"/>
+              <a:t>人与小鼠 · 静息与病原感染 · 单细胞转录组，并以分选 bulk（DICE、ImmGen）交叉验证零值</a:t>
+            </a:r>
+            <a:endParaRPr lang="en-US" sz="1600" dirty="0"/>
           </a:p>
         </p:txBody>
       </p:sp>
@@ -1762,171 +1577,8 @@
         </p:nvSpPr>
         <p:spPr>
           <a:xfrm>
-            <a:off x="822960" y="5120640"/>
-            <a:ext cx="10515600" cy="365760"/>
-          </a:xfrm>
-          <a:prstGeom prst="rect">
-            <a:avLst/>
-          </a:prstGeom>
-          <a:noFill/>
-          <a:ln/>
-        </p:spPr>
-        <p:txBody>
-          <a:bodyPr wrap="square" rtlCol="0" anchor="ctr"/>
-          <a:lstStyle/>
-          <a:p>
-            <a:pPr indent="0" marL="0">
-              <a:buNone/>
-            </a:pPr>
-            <a:r>
-              <a:rPr lang="en-US" sz="1300" dirty="0">
-                <a:solidFill>
-                  <a:srgbClr val="9FB0CC"/>
-                </a:solidFill>
-                <a:latin typeface="Microsoft YaHei" pitchFamily="34" charset="0"/>
-                <a:ea typeface="Microsoft YaHei" pitchFamily="34" charset="-122"/>
-                <a:cs typeface="Microsoft YaHei" pitchFamily="34" charset="-120"/>
-              </a:rPr>
-              <a:t>24 个单细胞数据集（人 17 · 小鼠 7） </a:t>
-            </a:r>
-            <a:pPr indent="0" marL="0">
-              <a:buNone/>
-            </a:pPr>
-            <a:r>
-              <a:rPr lang="en-US" sz="1300" dirty="0">
-                <a:solidFill>
-                  <a:srgbClr val="9FB0CC"/>
-                </a:solidFill>
-                <a:latin typeface="Microsoft YaHei" pitchFamily="34" charset="0"/>
-                <a:ea typeface="Microsoft YaHei" pitchFamily="34" charset="-122"/>
-                <a:cs typeface="Microsoft YaHei" pitchFamily="34" charset="-120"/>
-              </a:rPr>
-              <a:t>·  CELLxGENE Census LTS 2025-11-08  ·  以供体为统计单位</a:t>
-            </a:r>
-            <a:endParaRPr lang="en-US" sz="1300" dirty="0"/>
-          </a:p>
-        </p:txBody>
-      </p:sp>
-      <p:sp>
-        <p:nvSpPr>
-          <p:cNvPr id="5" name="Text 3"/>
-          <p:cNvSpPr txBox="1"/>
-          <p:nvPr/>
-        </p:nvSpPr>
-        <p:spPr>
-          <a:xfrm>
-            <a:off x="822960" y="5532120"/>
-            <a:ext cx="10515600" cy="365760"/>
-          </a:xfrm>
-          <a:prstGeom prst="rect">
-            <a:avLst/>
-          </a:prstGeom>
-          <a:noFill/>
-          <a:ln/>
-        </p:spPr>
-        <p:txBody>
-          <a:bodyPr wrap="square" rtlCol="0" anchor="ctr"/>
-          <a:lstStyle/>
-          <a:p>
-            <a:pPr indent="0" marL="0">
-              <a:buNone/>
-            </a:pPr>
-            <a:r>
-              <a:rPr lang="en-US" sz="1200" i="1" dirty="0">
-                <a:solidFill>
-                  <a:srgbClr val="7F8DA8"/>
-                </a:solidFill>
-                <a:latin typeface="Microsoft YaHei" pitchFamily="34" charset="0"/>
-                <a:ea typeface="Microsoft YaHei" pitchFamily="34" charset="-122"/>
-                <a:cs typeface="Microsoft YaHei" pitchFamily="34" charset="-120"/>
-              </a:rPr>
-              <a:t>本分析为 IL18 转录本丰度（= pro-IL-18 转录信号），不等价于前体蛋白储量</a:t>
-            </a:r>
-            <a:endParaRPr lang="en-US" sz="1200" dirty="0"/>
-          </a:p>
-        </p:txBody>
-      </p:sp>
-    </p:spTree>
-  </p:cSld>
-  <p:clrMapOvr>
-    <a:masterClrMapping/>
-  </p:clrMapOvr>
-</p:sld>
-</file>
-
-<file path=ppt/slides/slide10.xml><?xml version="1.0" encoding="utf-8"?>
-<p:sld xmlns:a="http://schemas.openxmlformats.org/drawingml/2006/main" xmlns:r="http://schemas.openxmlformats.org/officeDocument/2006/relationships" xmlns:p="http://schemas.openxmlformats.org/presentationml/2006/main">
-  <p:cSld name="Slide 10">
-    <p:bg>
-      <p:bgPr>
-        <a:solidFill>
-          <a:srgbClr val="16233E"/>
-        </a:solidFill>
-      </p:bgPr>
-    </p:bg>
-    <p:spTree>
-      <p:nvGrpSpPr>
-        <p:cNvPr id="1" name=""/>
-        <p:cNvGrpSpPr/>
-        <p:nvPr/>
-      </p:nvGrpSpPr>
-      <p:grpSpPr>
-        <a:xfrm>
-          <a:off x="0" y="0"/>
-          <a:ext cx="0" cy="0"/>
-          <a:chOff x="0" y="0"/>
-          <a:chExt cx="0" cy="0"/>
-        </a:xfrm>
-      </p:grpSpPr>
-      <p:sp>
-        <p:nvSpPr>
-          <p:cNvPr id="2" name="Text 0"/>
-          <p:cNvSpPr txBox="1"/>
-          <p:nvPr/>
-        </p:nvSpPr>
-        <p:spPr>
-          <a:xfrm>
-            <a:off x="822960" y="1371600"/>
-            <a:ext cx="10058400" cy="365760"/>
-          </a:xfrm>
-          <a:prstGeom prst="rect">
-            <a:avLst/>
-          </a:prstGeom>
-          <a:noFill/>
-          <a:ln/>
-        </p:spPr>
-        <p:txBody>
-          <a:bodyPr wrap="square" rtlCol="0" anchor="ctr"/>
-          <a:lstStyle/>
-          <a:p>
-            <a:pPr indent="0" marL="0">
-              <a:buNone/>
-            </a:pPr>
-            <a:r>
-              <a:rPr lang="en-US" sz="1300" b="1" spc="200" kern="0" dirty="0">
-                <a:solidFill>
-                  <a:srgbClr val="8FA0BF"/>
-                </a:solidFill>
-                <a:latin typeface="Microsoft YaHei" pitchFamily="34" charset="0"/>
-                <a:ea typeface="Microsoft YaHei" pitchFamily="34" charset="-122"/>
-                <a:cs typeface="Microsoft YaHei" pitchFamily="34" charset="-120"/>
-              </a:rPr>
-              <a:t>一句话</a:t>
-            </a:r>
-            <a:endParaRPr lang="en-US" sz="1300" dirty="0"/>
-          </a:p>
-        </p:txBody>
-      </p:sp>
-      <p:sp>
-        <p:nvSpPr>
-          <p:cNvPr id="3" name="Text 1"/>
-          <p:cNvSpPr txBox="1"/>
-          <p:nvPr/>
-        </p:nvSpPr>
-        <p:spPr>
-          <a:xfrm>
-            <a:off x="822960" y="1828800"/>
-            <a:ext cx="10515600" cy="1463040"/>
+            <a:off x="640080" y="4297680"/>
+            <a:ext cx="10972800" cy="914400"/>
           </a:xfrm>
           <a:prstGeom prst="rect">
             <a:avLst/>
@@ -1945,19 +1597,16 @@
               <a:buNone/>
             </a:pPr>
             <a:r>
-              <a:rPr lang="en-US" sz="2400" b="1" dirty="0">
+              <a:rPr lang="en-US" sz="1300" b="1" dirty="0">
                 <a:solidFill>
-                  <a:srgbClr val="FFFFFF"/>
+                  <a:srgbClr val="1A1A1A"/>
                 </a:solidFill>
                 <a:latin typeface="Microsoft YaHei" pitchFamily="34" charset="0"/>
                 <a:ea typeface="Microsoft YaHei" pitchFamily="34" charset="-122"/>
                 <a:cs typeface="Microsoft YaHei" pitchFamily="34" charset="-120"/>
               </a:rPr>
-              <a:t>肺内 IL18 主要由髓系细胞转录——肺泡巨噬细胞、树突状细胞、单核来源巨噬细胞；</a:t>
-            </a:r>
-            <a:endParaRPr lang="en-US" sz="2400" dirty="0"/>
-          </a:p>
-          <a:p>
+              <a:t>测量对象：IL18 转录本，即 pro-IL-18 的转录信号。</a:t>
+            </a:r>
             <a:pPr indent="0" marL="0">
               <a:lnSpc>
                 <a:spcPct val="125000"/>
@@ -1965,30 +1614,30 @@
               <a:buNone/>
             </a:pPr>
             <a:r>
-              <a:rPr lang="en-US" sz="2400" b="1" dirty="0">
+              <a:rPr lang="en-US" sz="1300" dirty="0">
                 <a:solidFill>
-                  <a:srgbClr val="FFFFFF"/>
+                  <a:srgbClr val="1A1A1A"/>
                 </a:solidFill>
                 <a:latin typeface="Microsoft YaHei" pitchFamily="34" charset="0"/>
                 <a:ea typeface="Microsoft YaHei" pitchFamily="34" charset="-122"/>
                 <a:cs typeface="Microsoft YaHei" pitchFamily="34" charset="-120"/>
               </a:rPr>
-              <a:t>上皮（AT1、气道）确有转录；感染不改变这一格局。</a:t>
-            </a:r>
-            <a:endParaRPr lang="en-US" sz="2400" dirty="0"/>
-          </a:p>
-        </p:txBody>
-      </p:sp>
-      <p:sp>
-        <p:nvSpPr>
-          <p:cNvPr id="4" name="Text 2"/>
+              <a:t>成熟 IL-18 由 caspase 切割前体产生，pro/成熟之分属蛋白层面，转录层面无法区分。本分析为转录本丰度，不等价于前体蛋白储量。</a:t>
+            </a:r>
+            <a:endParaRPr lang="en-US" sz="1300" dirty="0"/>
+          </a:p>
+        </p:txBody>
+      </p:sp>
+      <p:sp>
+        <p:nvSpPr>
+          <p:cNvPr id="5" name="Text 3"/>
           <p:cNvSpPr txBox="1"/>
           <p:nvPr/>
         </p:nvSpPr>
         <p:spPr>
           <a:xfrm>
-            <a:off x="822960" y="4114800"/>
-            <a:ext cx="10058400" cy="365760"/>
+            <a:off x="640080" y="5577840"/>
+            <a:ext cx="10972800" cy="365760"/>
           </a:xfrm>
           <a:prstGeom prst="rect">
             <a:avLst/>
@@ -2004,134 +1653,17 @@
               <a:buNone/>
             </a:pPr>
             <a:r>
-              <a:rPr lang="en-US" sz="1300" b="1" spc="200" kern="0" dirty="0">
+              <a:rPr lang="en-US" sz="1250" dirty="0">
                 <a:solidFill>
-                  <a:srgbClr val="8FA0BF"/>
+                  <a:srgbClr val="9AA0A6"/>
                 </a:solidFill>
                 <a:latin typeface="Microsoft YaHei" pitchFamily="34" charset="0"/>
                 <a:ea typeface="Microsoft YaHei" pitchFamily="34" charset="-122"/>
                 <a:cs typeface="Microsoft YaHei" pitchFamily="34" charset="-120"/>
               </a:rPr>
-              <a:t>交付物</a:t>
-            </a:r>
-            <a:endParaRPr lang="en-US" sz="1300" dirty="0"/>
-          </a:p>
-        </p:txBody>
-      </p:sp>
-      <p:sp>
-        <p:nvSpPr>
-          <p:cNvPr id="5" name="Text 3"/>
-          <p:cNvSpPr txBox="1"/>
-          <p:nvPr/>
-        </p:nvSpPr>
-        <p:spPr>
-          <a:xfrm>
-            <a:off x="822960" y="4526280"/>
-            <a:ext cx="10515600" cy="1463040"/>
-          </a:xfrm>
-          <a:prstGeom prst="rect">
-            <a:avLst/>
-          </a:prstGeom>
-          <a:noFill/>
-          <a:ln/>
-        </p:spPr>
-        <p:txBody>
-          <a:bodyPr wrap="square" rtlCol="0" anchor="ctr"/>
-          <a:lstStyle/>
-          <a:p>
-            <a:pPr indent="0" marL="0">
-              <a:lnSpc>
-                <a:spcPct val="130000"/>
-              </a:lnSpc>
-              <a:buNone/>
-            </a:pPr>
-            <a:r>
-              <a:rPr lang="en-US" sz="1400" dirty="0">
-                <a:solidFill>
-                  <a:srgbClr val="C7D0E0"/>
-                </a:solidFill>
-                <a:latin typeface="Microsoft YaHei" pitchFamily="34" charset="0"/>
-                <a:ea typeface="Microsoft YaHei" pitchFamily="34" charset="-122"/>
-                <a:cs typeface="Microsoft YaHei" pitchFamily="34" charset="-120"/>
-              </a:rPr>
-              <a:t>census_scan.tsv · datasets.yaml · celltype_map.tsv · il18_celltype_table.tsv
-</a:t>
-            </a:r>
-            <a:pPr indent="0" marL="0">
-              <a:lnSpc>
-                <a:spcPct val="130000"/>
-              </a:lnSpc>
-              <a:buNone/>
-            </a:pPr>
-            <a:r>
-              <a:rPr lang="en-US" sz="1400" dirty="0">
-                <a:solidFill>
-                  <a:srgbClr val="C7D0E0"/>
-                </a:solidFill>
-                <a:latin typeface="Microsoft YaHei" pitchFamily="34" charset="0"/>
-                <a:ea typeface="Microsoft YaHei" pitchFamily="34" charset="-122"/>
-                <a:cs typeface="Microsoft YaHei" pitchFamily="34" charset="-120"/>
-              </a:rPr>
-              <a:t>il18_summary.tsv · il18_zero_check.tsv · il18_within_study_tests.tsv · run_log.md
-</a:t>
-            </a:r>
-            <a:pPr indent="0" marL="0">
-              <a:lnSpc>
-                <a:spcPct val="130000"/>
-              </a:lnSpc>
-              <a:buNone/>
-            </a:pPr>
-            <a:r>
-              <a:rPr lang="en-US" sz="1400" dirty="0">
-                <a:solidFill>
-                  <a:srgbClr val="C7D0E0"/>
-                </a:solidFill>
-                <a:latin typeface="Microsoft YaHei" pitchFamily="34" charset="0"/>
-                <a:ea typeface="Microsoft YaHei" pitchFamily="34" charset="-122"/>
-                <a:cs typeface="Microsoft YaHei" pitchFamily="34" charset="-120"/>
-              </a:rPr>
-              <a:t>figures/（人鼠分开的逐数据集散点图） · README.md</a:t>
-            </a:r>
-            <a:endParaRPr lang="en-US" sz="1400" dirty="0"/>
-          </a:p>
-        </p:txBody>
-      </p:sp>
-      <p:sp>
-        <p:nvSpPr>
-          <p:cNvPr id="6" name="Text 4"/>
-          <p:cNvSpPr txBox="1"/>
-          <p:nvPr/>
-        </p:nvSpPr>
-        <p:spPr>
-          <a:xfrm>
-            <a:off x="822960" y="6126480"/>
-            <a:ext cx="10515600" cy="365760"/>
-          </a:xfrm>
-          <a:prstGeom prst="rect">
-            <a:avLst/>
-          </a:prstGeom>
-          <a:noFill/>
-          <a:ln/>
-        </p:spPr>
-        <p:txBody>
-          <a:bodyPr wrap="square" rtlCol="0" anchor="ctr"/>
-          <a:lstStyle/>
-          <a:p>
-            <a:pPr indent="0" marL="0">
-              <a:buNone/>
-            </a:pPr>
-            <a:r>
-              <a:rPr lang="en-US" sz="1200" i="1" dirty="0">
-                <a:solidFill>
-                  <a:srgbClr val="7F8DA8"/>
-                </a:solidFill>
-                <a:latin typeface="Microsoft YaHei" pitchFamily="34" charset="0"/>
-                <a:ea typeface="Microsoft YaHei" pitchFamily="34" charset="-122"/>
-                <a:cs typeface="Microsoft YaHei" pitchFamily="34" charset="-120"/>
-              </a:rPr>
-              <a:t>本分析为转录本丰度，不等价于前体蛋白储量</a:t>
-            </a:r>
-            <a:endParaRPr lang="en-US" sz="1200" dirty="0"/>
+              <a:t>24 个单细胞数据集（人 17 · 小鼠 7） · CELLxGENE Census LTS 2025-11-08 · 以供体为统计单位</a:t>
+            </a:r>
+            <a:endParaRPr lang="en-US" sz="1250" dirty="0"/>
           </a:p>
         </p:txBody>
       </p:sp>
@@ -2169,7 +1701,7 @@
         <p:spPr>
           <a:xfrm>
             <a:off x="640080" y="457200"/>
-            <a:ext cx="10972800" cy="274320"/>
+            <a:ext cx="10972800" cy="640080"/>
           </a:xfrm>
           <a:prstGeom prst="rect">
             <a:avLst/>
@@ -2185,46 +1717,7 @@
               <a:buNone/>
             </a:pPr>
             <a:r>
-              <a:rPr lang="en-US" sz="1200" b="1" spc="200" kern="0" dirty="0">
-                <a:solidFill>
-                  <a:srgbClr val="1C5CAB"/>
-                </a:solidFill>
-                <a:latin typeface="Microsoft YaHei" pitchFamily="34" charset="0"/>
-                <a:ea typeface="Microsoft YaHei" pitchFamily="34" charset="-122"/>
-                <a:cs typeface="Microsoft YaHei" pitchFamily="34" charset="-120"/>
-              </a:rPr>
-              <a:t>结论</a:t>
-            </a:r>
-            <a:endParaRPr lang="en-US" sz="1200" dirty="0"/>
-          </a:p>
-        </p:txBody>
-      </p:sp>
-      <p:sp>
-        <p:nvSpPr>
-          <p:cNvPr id="3" name="Text 1"/>
-          <p:cNvSpPr txBox="1"/>
-          <p:nvPr/>
-        </p:nvSpPr>
-        <p:spPr>
-          <a:xfrm>
-            <a:off x="640080" y="713232"/>
-            <a:ext cx="10972800" cy="640080"/>
-          </a:xfrm>
-          <a:prstGeom prst="rect">
-            <a:avLst/>
-          </a:prstGeom>
-          <a:noFill/>
-          <a:ln/>
-        </p:spPr>
-        <p:txBody>
-          <a:bodyPr wrap="square" rtlCol="0" anchor="ctr"/>
-          <a:lstStyle/>
-          <a:p>
-            <a:pPr indent="0" marL="0">
-              <a:buNone/>
-            </a:pPr>
-            <a:r>
-              <a:rPr lang="en-US" sz="2600" b="1" dirty="0">
+              <a:rPr lang="en-US" sz="2500" b="1" dirty="0">
                 <a:solidFill>
                   <a:srgbClr val="1A1A1A"/>
                 </a:solidFill>
@@ -2232,49 +1725,22 @@
                 <a:ea typeface="Microsoft YaHei" pitchFamily="34" charset="-122"/>
                 <a:cs typeface="Microsoft YaHei" pitchFamily="34" charset="-120"/>
               </a:rPr>
-              <a:t>哪些细胞转录 IL18</a:t>
-            </a:r>
-            <a:endParaRPr lang="en-US" sz="2600" dirty="0"/>
-          </a:p>
-        </p:txBody>
-      </p:sp>
-      <p:sp>
-        <p:nvSpPr>
-          <p:cNvPr id="4" name="Shape 2"/>
-          <p:cNvSpPr/>
-          <p:nvPr/>
-        </p:nvSpPr>
-        <p:spPr>
-          <a:xfrm>
-            <a:off x="640080" y="1783080"/>
-            <a:ext cx="3511296" cy="3566160"/>
-          </a:xfrm>
-          <a:prstGeom prst="roundRect">
-            <a:avLst>
-              <a:gd name="adj" fmla="val 2083"/>
-            </a:avLst>
-          </a:prstGeom>
-          <a:solidFill>
-            <a:srgbClr val="F7F8FA"/>
-          </a:solidFill>
-          <a:ln w="12700">
-            <a:solidFill>
-              <a:srgbClr val="E6E8EC"/>
-            </a:solidFill>
-            <a:prstDash val="solid"/>
-          </a:ln>
-        </p:spPr>
-      </p:sp>
-      <p:sp>
-        <p:nvSpPr>
-          <p:cNvPr id="5" name="Text 3"/>
+              <a:t>结论：哪些细胞转录 IL18</a:t>
+            </a:r>
+            <a:endParaRPr lang="en-US" sz="2500" dirty="0"/>
+          </a:p>
+        </p:txBody>
+      </p:sp>
+      <p:sp>
+        <p:nvSpPr>
+          <p:cNvPr id="3" name="Text 1"/>
           <p:cNvSpPr txBox="1"/>
           <p:nvPr/>
         </p:nvSpPr>
         <p:spPr>
           <a:xfrm>
-            <a:off x="868680" y="2057400"/>
-            <a:ext cx="914400" cy="548640"/>
+            <a:off x="640080" y="1417320"/>
+            <a:ext cx="3200400" cy="1005840"/>
           </a:xfrm>
           <a:prstGeom prst="rect">
             <a:avLst/>
@@ -2283,53 +1749,14 @@
           <a:ln/>
         </p:spPr>
         <p:txBody>
-          <a:bodyPr wrap="square" rtlCol="0" anchor="ctr"/>
+          <a:bodyPr wrap="square" rtlCol="0" anchor="t"/>
           <a:lstStyle/>
           <a:p>
             <a:pPr indent="0" marL="0">
               <a:buNone/>
             </a:pPr>
             <a:r>
-              <a:rPr lang="en-US" sz="3000" b="1" dirty="0">
-                <a:solidFill>
-                  <a:srgbClr val="1C5CAB"/>
-                </a:solidFill>
-                <a:latin typeface="Microsoft YaHei" pitchFamily="34" charset="0"/>
-                <a:ea typeface="Microsoft YaHei" pitchFamily="34" charset="-122"/>
-                <a:cs typeface="Microsoft YaHei" pitchFamily="34" charset="-120"/>
-              </a:rPr>
-              <a:t>1</a:t>
-            </a:r>
-            <a:endParaRPr lang="en-US" sz="3000" dirty="0"/>
-          </a:p>
-        </p:txBody>
-      </p:sp>
-      <p:sp>
-        <p:nvSpPr>
-          <p:cNvPr id="6" name="Text 4"/>
-          <p:cNvSpPr txBox="1"/>
-          <p:nvPr/>
-        </p:nvSpPr>
-        <p:spPr>
-          <a:xfrm>
-            <a:off x="868680" y="2697480"/>
-            <a:ext cx="3054096" cy="731520"/>
-          </a:xfrm>
-          <a:prstGeom prst="rect">
-            <a:avLst/>
-          </a:prstGeom>
-          <a:noFill/>
-          <a:ln/>
-        </p:spPr>
-        <p:txBody>
-          <a:bodyPr wrap="square" rtlCol="0" anchor="ctr"/>
-          <a:lstStyle/>
-          <a:p>
-            <a:pPr indent="0" marL="0">
-              <a:buNone/>
-            </a:pPr>
-            <a:r>
-              <a:rPr lang="en-US" sz="1700" b="1" dirty="0">
+              <a:rPr lang="en-US" sz="1500" b="1" dirty="0">
                 <a:solidFill>
                   <a:srgbClr val="1A1A1A"/>
                 </a:solidFill>
@@ -2339,20 +1766,20 @@
               </a:rPr>
               <a:t>髓系是主要来源</a:t>
             </a:r>
-            <a:endParaRPr lang="en-US" sz="1700" dirty="0"/>
-          </a:p>
-        </p:txBody>
-      </p:sp>
-      <p:sp>
-        <p:nvSpPr>
-          <p:cNvPr id="7" name="Text 5"/>
+            <a:endParaRPr lang="en-US" sz="1500" dirty="0"/>
+          </a:p>
+        </p:txBody>
+      </p:sp>
+      <p:sp>
+        <p:nvSpPr>
+          <p:cNvPr id="4" name="Text 2"/>
           <p:cNvSpPr txBox="1"/>
           <p:nvPr/>
         </p:nvSpPr>
         <p:spPr>
           <a:xfrm>
-            <a:off x="868680" y="3383280"/>
-            <a:ext cx="3054096" cy="1828800"/>
+            <a:off x="3931920" y="1417320"/>
+            <a:ext cx="7589520" cy="1005840"/>
           </a:xfrm>
           <a:prstGeom prst="rect">
             <a:avLst/>
@@ -2366,62 +1793,35 @@
           <a:p>
             <a:pPr indent="0" marL="0">
               <a:lnSpc>
-                <a:spcPct val="115000"/>
+                <a:spcPct val="120000"/>
               </a:lnSpc>
               <a:buNone/>
             </a:pPr>
             <a:r>
-              <a:rPr lang="en-US" sz="1250" dirty="0">
+              <a:rPr lang="en-US" sz="1300" dirty="0">
                 <a:solidFill>
-                  <a:srgbClr val="6B6B6B"/>
+                  <a:srgbClr val="1A1A1A"/>
                 </a:solidFill>
                 <a:latin typeface="Microsoft YaHei" pitchFamily="34" charset="0"/>
                 <a:ea typeface="Microsoft YaHei" pitchFamily="34" charset="-122"/>
                 <a:cs typeface="Microsoft YaHei" pitchFamily="34" charset="-120"/>
               </a:rPr>
-              <a:t>树突状细胞、肺泡巨噬细胞、单核来源巨噬细胞在几乎所有数据集排名最前。小鼠肺泡巨噬细胞最突出（阳性率常 &gt;90%）。静息与感染条件下一致。</a:t>
-            </a:r>
-            <a:endParaRPr lang="en-US" sz="1250" dirty="0"/>
-          </a:p>
-        </p:txBody>
-      </p:sp>
-      <p:sp>
-        <p:nvSpPr>
-          <p:cNvPr id="8" name="Shape 6"/>
-          <p:cNvSpPr/>
-          <p:nvPr/>
-        </p:nvSpPr>
-        <p:spPr>
-          <a:xfrm>
-            <a:off x="4343400" y="1783080"/>
-            <a:ext cx="3511296" cy="3566160"/>
-          </a:xfrm>
-          <a:prstGeom prst="roundRect">
-            <a:avLst>
-              <a:gd name="adj" fmla="val 2083"/>
-            </a:avLst>
-          </a:prstGeom>
-          <a:solidFill>
-            <a:srgbClr val="F7F8FA"/>
-          </a:solidFill>
-          <a:ln w="12700">
-            <a:solidFill>
-              <a:srgbClr val="E6E8EC"/>
-            </a:solidFill>
-            <a:prstDash val="solid"/>
-          </a:ln>
-        </p:spPr>
-      </p:sp>
-      <p:sp>
-        <p:nvSpPr>
-          <p:cNvPr id="9" name="Text 7"/>
+              <a:t>树突状细胞、肺泡巨噬细胞、单核来源巨噬细胞在几乎所有数据集排名最前。小鼠肺泡巨噬细胞阳性率常 &gt;90%。静息与感染条件下一致。</a:t>
+            </a:r>
+            <a:endParaRPr lang="en-US" sz="1300" dirty="0"/>
+          </a:p>
+        </p:txBody>
+      </p:sp>
+      <p:sp>
+        <p:nvSpPr>
+          <p:cNvPr id="5" name="Text 3"/>
           <p:cNvSpPr txBox="1"/>
           <p:nvPr/>
         </p:nvSpPr>
         <p:spPr>
           <a:xfrm>
-            <a:off x="4572000" y="2057400"/>
-            <a:ext cx="914400" cy="548640"/>
+            <a:off x="640080" y="2624328"/>
+            <a:ext cx="3200400" cy="1005840"/>
           </a:xfrm>
           <a:prstGeom prst="rect">
             <a:avLst/>
@@ -2430,53 +1830,14 @@
           <a:ln/>
         </p:spPr>
         <p:txBody>
-          <a:bodyPr wrap="square" rtlCol="0" anchor="ctr"/>
+          <a:bodyPr wrap="square" rtlCol="0" anchor="t"/>
           <a:lstStyle/>
           <a:p>
             <a:pPr indent="0" marL="0">
               <a:buNone/>
             </a:pPr>
             <a:r>
-              <a:rPr lang="en-US" sz="3000" b="1" dirty="0">
-                <a:solidFill>
-                  <a:srgbClr val="1C5CAB"/>
-                </a:solidFill>
-                <a:latin typeface="Microsoft YaHei" pitchFamily="34" charset="0"/>
-                <a:ea typeface="Microsoft YaHei" pitchFamily="34" charset="-122"/>
-                <a:cs typeface="Microsoft YaHei" pitchFamily="34" charset="-120"/>
-              </a:rPr>
-              <a:t>2</a:t>
-            </a:r>
-            <a:endParaRPr lang="en-US" sz="3000" dirty="0"/>
-          </a:p>
-        </p:txBody>
-      </p:sp>
-      <p:sp>
-        <p:nvSpPr>
-          <p:cNvPr id="10" name="Text 8"/>
-          <p:cNvSpPr txBox="1"/>
-          <p:nvPr/>
-        </p:nvSpPr>
-        <p:spPr>
-          <a:xfrm>
-            <a:off x="4572000" y="2697480"/>
-            <a:ext cx="3054096" cy="731520"/>
-          </a:xfrm>
-          <a:prstGeom prst="rect">
-            <a:avLst/>
-          </a:prstGeom>
-          <a:noFill/>
-          <a:ln/>
-        </p:spPr>
-        <p:txBody>
-          <a:bodyPr wrap="square" rtlCol="0" anchor="ctr"/>
-          <a:lstStyle/>
-          <a:p>
-            <a:pPr indent="0" marL="0">
-              <a:buNone/>
-            </a:pPr>
-            <a:r>
-              <a:rPr lang="en-US" sz="1700" b="1" dirty="0">
+              <a:rPr lang="en-US" sz="1500" b="1" dirty="0">
                 <a:solidFill>
                   <a:srgbClr val="1A1A1A"/>
                 </a:solidFill>
@@ -2486,20 +1847,20 @@
               </a:rPr>
               <a:t>上皮确有转录</a:t>
             </a:r>
-            <a:endParaRPr lang="en-US" sz="1700" dirty="0"/>
-          </a:p>
-        </p:txBody>
-      </p:sp>
-      <p:sp>
-        <p:nvSpPr>
-          <p:cNvPr id="11" name="Text 9"/>
+            <a:endParaRPr lang="en-US" sz="1500" dirty="0"/>
+          </a:p>
+        </p:txBody>
+      </p:sp>
+      <p:sp>
+        <p:nvSpPr>
+          <p:cNvPr id="6" name="Text 4"/>
           <p:cNvSpPr txBox="1"/>
           <p:nvPr/>
         </p:nvSpPr>
         <p:spPr>
           <a:xfrm>
-            <a:off x="4572000" y="3383280"/>
-            <a:ext cx="3054096" cy="1828800"/>
+            <a:off x="3931920" y="2624328"/>
+            <a:ext cx="7589520" cy="1005840"/>
           </a:xfrm>
           <a:prstGeom prst="rect">
             <a:avLst/>
@@ -2513,117 +1874,12 @@
           <a:p>
             <a:pPr indent="0" marL="0">
               <a:lnSpc>
-                <a:spcPct val="115000"/>
+                <a:spcPct val="120000"/>
               </a:lnSpc>
               <a:buNone/>
             </a:pPr>
             <a:r>
-              <a:rPr lang="en-US" sz="1250" dirty="0">
-                <a:solidFill>
-                  <a:srgbClr val="6B6B6B"/>
-                </a:solidFill>
-                <a:latin typeface="Microsoft YaHei" pitchFamily="34" charset="0"/>
-                <a:ea typeface="Microsoft YaHei" pitchFamily="34" charset="-122"/>
-                <a:cs typeface="Microsoft YaHei" pitchFamily="34" charset="-120"/>
-              </a:rPr>
-              <a:t>经环境 RNA 校正的 Tabula Sapiens 中 AT1 排名第一、气道上皮居前。校正几乎不改变上皮信号，却清除内皮/淋巴信号——上皮 IL18 非污染所致。</a:t>
-            </a:r>
-            <a:endParaRPr lang="en-US" sz="1250" dirty="0"/>
-          </a:p>
-        </p:txBody>
-      </p:sp>
-      <p:sp>
-        <p:nvSpPr>
-          <p:cNvPr id="12" name="Shape 10"/>
-          <p:cNvSpPr/>
-          <p:nvPr/>
-        </p:nvSpPr>
-        <p:spPr>
-          <a:xfrm>
-            <a:off x="8046720" y="1783080"/>
-            <a:ext cx="3511296" cy="3566160"/>
-          </a:xfrm>
-          <a:prstGeom prst="roundRect">
-            <a:avLst>
-              <a:gd name="adj" fmla="val 2083"/>
-            </a:avLst>
-          </a:prstGeom>
-          <a:solidFill>
-            <a:srgbClr val="F7F8FA"/>
-          </a:solidFill>
-          <a:ln w="12700">
-            <a:solidFill>
-              <a:srgbClr val="E6E8EC"/>
-            </a:solidFill>
-            <a:prstDash val="solid"/>
-          </a:ln>
-        </p:spPr>
-      </p:sp>
-      <p:sp>
-        <p:nvSpPr>
-          <p:cNvPr id="13" name="Text 11"/>
-          <p:cNvSpPr txBox="1"/>
-          <p:nvPr/>
-        </p:nvSpPr>
-        <p:spPr>
-          <a:xfrm>
-            <a:off x="8275320" y="2057400"/>
-            <a:ext cx="914400" cy="548640"/>
-          </a:xfrm>
-          <a:prstGeom prst="rect">
-            <a:avLst/>
-          </a:prstGeom>
-          <a:noFill/>
-          <a:ln/>
-        </p:spPr>
-        <p:txBody>
-          <a:bodyPr wrap="square" rtlCol="0" anchor="ctr"/>
-          <a:lstStyle/>
-          <a:p>
-            <a:pPr indent="0" marL="0">
-              <a:buNone/>
-            </a:pPr>
-            <a:r>
-              <a:rPr lang="en-US" sz="3000" b="1" dirty="0">
-                <a:solidFill>
-                  <a:srgbClr val="1C5CAB"/>
-                </a:solidFill>
-                <a:latin typeface="Microsoft YaHei" pitchFamily="34" charset="0"/>
-                <a:ea typeface="Microsoft YaHei" pitchFamily="34" charset="-122"/>
-                <a:cs typeface="Microsoft YaHei" pitchFamily="34" charset="-120"/>
-              </a:rPr>
-              <a:t>3</a:t>
-            </a:r>
-            <a:endParaRPr lang="en-US" sz="3000" dirty="0"/>
-          </a:p>
-        </p:txBody>
-      </p:sp>
-      <p:sp>
-        <p:nvSpPr>
-          <p:cNvPr id="14" name="Text 12"/>
-          <p:cNvSpPr txBox="1"/>
-          <p:nvPr/>
-        </p:nvSpPr>
-        <p:spPr>
-          <a:xfrm>
-            <a:off x="8275320" y="2697480"/>
-            <a:ext cx="3054096" cy="731520"/>
-          </a:xfrm>
-          <a:prstGeom prst="rect">
-            <a:avLst/>
-          </a:prstGeom>
-          <a:noFill/>
-          <a:ln/>
-        </p:spPr>
-        <p:txBody>
-          <a:bodyPr wrap="square" rtlCol="0" anchor="ctr"/>
-          <a:lstStyle/>
-          <a:p>
-            <a:pPr indent="0" marL="0">
-              <a:buNone/>
-            </a:pPr>
-            <a:r>
-              <a:rPr lang="en-US" sz="1700" b="1" dirty="0">
+              <a:rPr lang="en-US" sz="1300" dirty="0">
                 <a:solidFill>
                   <a:srgbClr val="1A1A1A"/>
                 </a:solidFill>
@@ -2631,22 +1887,22 @@
                 <a:ea typeface="Microsoft YaHei" pitchFamily="34" charset="-122"/>
                 <a:cs typeface="Microsoft YaHei" pitchFamily="34" charset="-120"/>
               </a:rPr>
-              <a:t>淋巴·内皮·成纤维接近零</a:t>
-            </a:r>
-            <a:endParaRPr lang="en-US" sz="1700" dirty="0"/>
-          </a:p>
-        </p:txBody>
-      </p:sp>
-      <p:sp>
-        <p:nvSpPr>
-          <p:cNvPr id="15" name="Text 13"/>
+              <a:t>经环境 RNA 校正的 Tabula Sapiens 中 AT1 排名第一、气道上皮居前；校正几乎不改变上皮信号却清除内皮/淋巴信号，说明上皮 IL18 并非污染所致。</a:t>
+            </a:r>
+            <a:endParaRPr lang="en-US" sz="1300" dirty="0"/>
+          </a:p>
+        </p:txBody>
+      </p:sp>
+      <p:sp>
+        <p:nvSpPr>
+          <p:cNvPr id="7" name="Text 5"/>
           <p:cNvSpPr txBox="1"/>
           <p:nvPr/>
         </p:nvSpPr>
         <p:spPr>
           <a:xfrm>
-            <a:off x="8275320" y="3383280"/>
-            <a:ext cx="3054096" cy="1828800"/>
+            <a:off x="640080" y="3831336"/>
+            <a:ext cx="3200400" cy="1005840"/>
           </a:xfrm>
           <a:prstGeom prst="rect">
             <a:avLst/>
@@ -2656,55 +1912,13 @@
         </p:spPr>
         <p:txBody>
           <a:bodyPr wrap="square" rtlCol="0" anchor="t"/>
-          <a:lstStyle/>
-          <a:p>
-            <a:pPr indent="0" marL="0">
-              <a:lnSpc>
-                <a:spcPct val="115000"/>
-              </a:lnSpc>
-              <a:buNone/>
-            </a:pPr>
-            <a:r>
-              <a:rPr lang="en-US" sz="1250" dirty="0">
-                <a:solidFill>
-                  <a:srgbClr val="6B6B6B"/>
-                </a:solidFill>
-                <a:latin typeface="Microsoft YaHei" pitchFamily="34" charset="0"/>
-                <a:ea typeface="Microsoft YaHei" pitchFamily="34" charset="-122"/>
-                <a:cs typeface="Microsoft YaHei" pitchFamily="34" charset="-120"/>
-              </a:rPr>
-              <a:t>T/NK、B/浆细胞、内皮、成纤维阳性比例多 ≤5%。DICE（人）与 ImmGen（鼠）分选 bulk 证实 T/NK/B 的零为真零，非 dropout。</a:t>
-            </a:r>
-            <a:endParaRPr lang="en-US" sz="1250" dirty="0"/>
-          </a:p>
-        </p:txBody>
-      </p:sp>
-      <p:sp>
-        <p:nvSpPr>
-          <p:cNvPr id="16" name="Text 14"/>
-          <p:cNvSpPr txBox="1"/>
-          <p:nvPr/>
-        </p:nvSpPr>
-        <p:spPr>
-          <a:xfrm>
-            <a:off x="640080" y="5577840"/>
-            <a:ext cx="10972800" cy="548640"/>
-          </a:xfrm>
-          <a:prstGeom prst="rect">
-            <a:avLst/>
-          </a:prstGeom>
-          <a:noFill/>
-          <a:ln/>
-        </p:spPr>
-        <p:txBody>
-          <a:bodyPr wrap="square" rtlCol="0" anchor="ctr"/>
           <a:lstStyle/>
           <a:p>
             <a:pPr indent="0" marL="0">
               <a:buNone/>
             </a:pPr>
             <a:r>
-              <a:rPr lang="en-US" sz="1350" dirty="0">
+              <a:rPr lang="en-US" sz="1500" b="1" dirty="0">
                 <a:solidFill>
                   <a:srgbClr val="1A1A1A"/>
                 </a:solidFill>
@@ -2712,9 +1926,132 @@
                 <a:ea typeface="Microsoft YaHei" pitchFamily="34" charset="-122"/>
                 <a:cs typeface="Microsoft YaHei" pitchFamily="34" charset="-120"/>
               </a:rPr>
-              <a:t>感染（SARS-CoV-2、流感、细菌、LPS）未改变“哪些细胞转录 IL18”——主要来源仍是髓系；感染主要改变各群的细胞数量而非表达谱。</a:t>
-            </a:r>
-            <a:endParaRPr lang="en-US" sz="1350" dirty="0"/>
+              <a:t>淋巴 · 内皮 · 成纤维接近零</a:t>
+            </a:r>
+            <a:endParaRPr lang="en-US" sz="1500" dirty="0"/>
+          </a:p>
+        </p:txBody>
+      </p:sp>
+      <p:sp>
+        <p:nvSpPr>
+          <p:cNvPr id="8" name="Text 6"/>
+          <p:cNvSpPr txBox="1"/>
+          <p:nvPr/>
+        </p:nvSpPr>
+        <p:spPr>
+          <a:xfrm>
+            <a:off x="3931920" y="3831336"/>
+            <a:ext cx="7589520" cy="1005840"/>
+          </a:xfrm>
+          <a:prstGeom prst="rect">
+            <a:avLst/>
+          </a:prstGeom>
+          <a:noFill/>
+          <a:ln/>
+        </p:spPr>
+        <p:txBody>
+          <a:bodyPr wrap="square" rtlCol="0" anchor="t"/>
+          <a:lstStyle/>
+          <a:p>
+            <a:pPr indent="0" marL="0">
+              <a:lnSpc>
+                <a:spcPct val="120000"/>
+              </a:lnSpc>
+              <a:buNone/>
+            </a:pPr>
+            <a:r>
+              <a:rPr lang="en-US" sz="1300" dirty="0">
+                <a:solidFill>
+                  <a:srgbClr val="1A1A1A"/>
+                </a:solidFill>
+                <a:latin typeface="Microsoft YaHei" pitchFamily="34" charset="0"/>
+                <a:ea typeface="Microsoft YaHei" pitchFamily="34" charset="-122"/>
+                <a:cs typeface="Microsoft YaHei" pitchFamily="34" charset="-120"/>
+              </a:rPr>
+              <a:t>T/NK、B/浆细胞、内皮、成纤维阳性比例多 ≤5%。DICE（人）与 ImmGen（鼠）分选 bulk 证实 T/NK/B 的零为真零，非 dropout。</a:t>
+            </a:r>
+            <a:endParaRPr lang="en-US" sz="1300" dirty="0"/>
+          </a:p>
+        </p:txBody>
+      </p:sp>
+      <p:sp>
+        <p:nvSpPr>
+          <p:cNvPr id="9" name="Text 7"/>
+          <p:cNvSpPr txBox="1"/>
+          <p:nvPr/>
+        </p:nvSpPr>
+        <p:spPr>
+          <a:xfrm>
+            <a:off x="640080" y="5038344"/>
+            <a:ext cx="3200400" cy="1005840"/>
+          </a:xfrm>
+          <a:prstGeom prst="rect">
+            <a:avLst/>
+          </a:prstGeom>
+          <a:noFill/>
+          <a:ln/>
+        </p:spPr>
+        <p:txBody>
+          <a:bodyPr wrap="square" rtlCol="0" anchor="t"/>
+          <a:lstStyle/>
+          <a:p>
+            <a:pPr indent="0" marL="0">
+              <a:buNone/>
+            </a:pPr>
+            <a:r>
+              <a:rPr lang="en-US" sz="1500" b="1" dirty="0">
+                <a:solidFill>
+                  <a:srgbClr val="1A1A1A"/>
+                </a:solidFill>
+                <a:latin typeface="Microsoft YaHei" pitchFamily="34" charset="0"/>
+                <a:ea typeface="Microsoft YaHei" pitchFamily="34" charset="-122"/>
+                <a:cs typeface="Microsoft YaHei" pitchFamily="34" charset="-120"/>
+              </a:rPr>
+              <a:t>感染不改变表达谱</a:t>
+            </a:r>
+            <a:endParaRPr lang="en-US" sz="1500" dirty="0"/>
+          </a:p>
+        </p:txBody>
+      </p:sp>
+      <p:sp>
+        <p:nvSpPr>
+          <p:cNvPr id="10" name="Text 8"/>
+          <p:cNvSpPr txBox="1"/>
+          <p:nvPr/>
+        </p:nvSpPr>
+        <p:spPr>
+          <a:xfrm>
+            <a:off x="3931920" y="5038344"/>
+            <a:ext cx="7589520" cy="1005840"/>
+          </a:xfrm>
+          <a:prstGeom prst="rect">
+            <a:avLst/>
+          </a:prstGeom>
+          <a:noFill/>
+          <a:ln/>
+        </p:spPr>
+        <p:txBody>
+          <a:bodyPr wrap="square" rtlCol="0" anchor="t"/>
+          <a:lstStyle/>
+          <a:p>
+            <a:pPr indent="0" marL="0">
+              <a:lnSpc>
+                <a:spcPct val="120000"/>
+              </a:lnSpc>
+              <a:buNone/>
+            </a:pPr>
+            <a:r>
+              <a:rPr lang="en-US" sz="1300" dirty="0">
+                <a:solidFill>
+                  <a:srgbClr val="1A1A1A"/>
+                </a:solidFill>
+                <a:latin typeface="Microsoft YaHei" pitchFamily="34" charset="0"/>
+                <a:ea typeface="Microsoft YaHei" pitchFamily="34" charset="-122"/>
+                <a:cs typeface="Microsoft YaHei" pitchFamily="34" charset="-120"/>
+              </a:rPr>
+              <a:t>SARS-CoV-2、流感、细菌、LPS 下主要来源仍是髓系；研究内比较显示感染主要改变各群细胞数量，而非“哪些细胞转录 IL18”。</a:t>
+            </a:r>
+            <a:endParaRPr lang="en-US" sz="1300" dirty="0"/>
           </a:p>
         </p:txBody>
       </p:sp>
@@ -2752,7 +2089,7 @@
         <p:spPr>
           <a:xfrm>
             <a:off x="640080" y="457200"/>
-            <a:ext cx="10972800" cy="274320"/>
+            <a:ext cx="10972800" cy="640080"/>
           </a:xfrm>
           <a:prstGeom prst="rect">
             <a:avLst/>
@@ -2768,46 +2105,7 @@
               <a:buNone/>
             </a:pPr>
             <a:r>
-              <a:rPr lang="en-US" sz="1200" b="1" spc="200" kern="0" dirty="0">
-                <a:solidFill>
-                  <a:srgbClr val="1C5CAB"/>
-                </a:solidFill>
-                <a:latin typeface="Microsoft YaHei" pitchFamily="34" charset="0"/>
-                <a:ea typeface="Microsoft YaHei" pitchFamily="34" charset="-122"/>
-                <a:cs typeface="Microsoft YaHei" pitchFamily="34" charset="-120"/>
-              </a:rPr>
-              <a:t>数据与方法</a:t>
-            </a:r>
-            <a:endParaRPr lang="en-US" sz="1200" dirty="0"/>
-          </a:p>
-        </p:txBody>
-      </p:sp>
-      <p:sp>
-        <p:nvSpPr>
-          <p:cNvPr id="3" name="Text 1"/>
-          <p:cNvSpPr txBox="1"/>
-          <p:nvPr/>
-        </p:nvSpPr>
-        <p:spPr>
-          <a:xfrm>
-            <a:off x="640080" y="713232"/>
-            <a:ext cx="10972800" cy="640080"/>
-          </a:xfrm>
-          <a:prstGeom prst="rect">
-            <a:avLst/>
-          </a:prstGeom>
-          <a:noFill/>
-          <a:ln/>
-        </p:spPr>
-        <p:txBody>
-          <a:bodyPr wrap="square" rtlCol="0" anchor="ctr"/>
-          <a:lstStyle/>
-          <a:p>
-            <a:pPr indent="0" marL="0">
-              <a:buNone/>
-            </a:pPr>
-            <a:r>
-              <a:rPr lang="en-US" sz="2600" b="1" dirty="0">
+              <a:rPr lang="en-US" sz="2500" b="1" dirty="0">
                 <a:solidFill>
                   <a:srgbClr val="1A1A1A"/>
                 </a:solidFill>
@@ -2815,21 +2113,21 @@
                 <a:ea typeface="Microsoft YaHei" pitchFamily="34" charset="-122"/>
                 <a:cs typeface="Microsoft YaHei" pitchFamily="34" charset="-120"/>
               </a:rPr>
-              <a:t>覆盖范围与统计规则</a:t>
-            </a:r>
-            <a:endParaRPr lang="en-US" sz="2600" dirty="0"/>
-          </a:p>
-        </p:txBody>
-      </p:sp>
-      <p:sp>
-        <p:nvSpPr>
-          <p:cNvPr id="4" name="Text 2"/>
+              <a:t>数据、方法与来源</a:t>
+            </a:r>
+            <a:endParaRPr lang="en-US" sz="2500" dirty="0"/>
+          </a:p>
+        </p:txBody>
+      </p:sp>
+      <p:sp>
+        <p:nvSpPr>
+          <p:cNvPr id="3" name="Text 1"/>
           <p:cNvSpPr txBox="1"/>
           <p:nvPr/>
         </p:nvSpPr>
         <p:spPr>
           <a:xfrm>
-            <a:off x="640080" y="1874520"/>
+            <a:off x="640080" y="1371600"/>
             <a:ext cx="1554480" cy="457200"/>
           </a:xfrm>
           <a:prstGeom prst="rect">
@@ -2847,48 +2145,6 @@
             </a:pPr>
             <a:r>
               <a:rPr lang="en-US" sz="1300" b="1" dirty="0">
-                <a:solidFill>
-                  <a:srgbClr val="1C5CAB"/>
-                </a:solidFill>
-                <a:latin typeface="Microsoft YaHei" pitchFamily="34" charset="0"/>
-                <a:ea typeface="Microsoft YaHei" pitchFamily="34" charset="-122"/>
-                <a:cs typeface="Microsoft YaHei" pitchFamily="34" charset="-120"/>
-              </a:rPr>
-              <a:t>物种</a:t>
-            </a:r>
-            <a:endParaRPr lang="en-US" sz="1300" dirty="0"/>
-          </a:p>
-        </p:txBody>
-      </p:sp>
-      <p:sp>
-        <p:nvSpPr>
-          <p:cNvPr id="5" name="Text 3"/>
-          <p:cNvSpPr txBox="1"/>
-          <p:nvPr/>
-        </p:nvSpPr>
-        <p:spPr>
-          <a:xfrm>
-            <a:off x="2240280" y="1874520"/>
-            <a:ext cx="3931920" cy="914400"/>
-          </a:xfrm>
-          <a:prstGeom prst="rect">
-            <a:avLst/>
-          </a:prstGeom>
-          <a:noFill/>
-          <a:ln/>
-        </p:spPr>
-        <p:txBody>
-          <a:bodyPr wrap="square" rtlCol="0" anchor="t"/>
-          <a:lstStyle/>
-          <a:p>
-            <a:pPr indent="0" marL="0">
-              <a:lnSpc>
-                <a:spcPct val="112000"/>
-              </a:lnSpc>
-              <a:buNone/>
-            </a:pPr>
-            <a:r>
-              <a:rPr lang="en-US" sz="1250" dirty="0">
                 <a:solidFill>
                   <a:srgbClr val="1A1A1A"/>
                 </a:solidFill>
@@ -2896,22 +2152,22 @@
                 <a:ea typeface="Microsoft YaHei" pitchFamily="34" charset="-122"/>
                 <a:cs typeface="Microsoft YaHei" pitchFamily="34" charset="-120"/>
               </a:rPr>
-              <a:t>人、小鼠全程分开，任何表与图均不合并</a:t>
-            </a:r>
-            <a:endParaRPr lang="en-US" sz="1250" dirty="0"/>
-          </a:p>
-        </p:txBody>
-      </p:sp>
-      <p:sp>
-        <p:nvSpPr>
-          <p:cNvPr id="6" name="Text 4"/>
+              <a:t>物种</a:t>
+            </a:r>
+            <a:endParaRPr lang="en-US" sz="1300" dirty="0"/>
+          </a:p>
+        </p:txBody>
+      </p:sp>
+      <p:sp>
+        <p:nvSpPr>
+          <p:cNvPr id="4" name="Text 2"/>
           <p:cNvSpPr txBox="1"/>
           <p:nvPr/>
         </p:nvSpPr>
         <p:spPr>
           <a:xfrm>
-            <a:off x="640080" y="2898648"/>
-            <a:ext cx="1554480" cy="457200"/>
+            <a:off x="2286000" y="1371600"/>
+            <a:ext cx="9418320" cy="457200"/>
           </a:xfrm>
           <a:prstGeom prst="rect">
             <a:avLst/>
@@ -2927,49 +2183,7 @@
               <a:buNone/>
             </a:pPr>
             <a:r>
-              <a:rPr lang="en-US" sz="1300" b="1" dirty="0">
-                <a:solidFill>
-                  <a:srgbClr val="1C5CAB"/>
-                </a:solidFill>
-                <a:latin typeface="Microsoft YaHei" pitchFamily="34" charset="0"/>
-                <a:ea typeface="Microsoft YaHei" pitchFamily="34" charset="-122"/>
-                <a:cs typeface="Microsoft YaHei" pitchFamily="34" charset="-120"/>
-              </a:rPr>
-              <a:t>基因</a:t>
-            </a:r>
-            <a:endParaRPr lang="en-US" sz="1300" dirty="0"/>
-          </a:p>
-        </p:txBody>
-      </p:sp>
-      <p:sp>
-        <p:nvSpPr>
-          <p:cNvPr id="7" name="Text 5"/>
-          <p:cNvSpPr txBox="1"/>
-          <p:nvPr/>
-        </p:nvSpPr>
-        <p:spPr>
-          <a:xfrm>
-            <a:off x="2240280" y="2898648"/>
-            <a:ext cx="3931920" cy="914400"/>
-          </a:xfrm>
-          <a:prstGeom prst="rect">
-            <a:avLst/>
-          </a:prstGeom>
-          <a:noFill/>
-          <a:ln/>
-        </p:spPr>
-        <p:txBody>
-          <a:bodyPr wrap="square" rtlCol="0" anchor="t"/>
-          <a:lstStyle/>
-          <a:p>
-            <a:pPr indent="0" marL="0">
-              <a:lnSpc>
-                <a:spcPct val="112000"/>
-              </a:lnSpc>
-              <a:buNone/>
-            </a:pPr>
-            <a:r>
-              <a:rPr lang="en-US" sz="1250" dirty="0">
+              <a:rPr lang="en-US" sz="1300" dirty="0">
                 <a:solidFill>
                   <a:srgbClr val="1A1A1A"/>
                 </a:solidFill>
@@ -2977,21 +2191,21 @@
                 <a:ea typeface="Microsoft YaHei" pitchFamily="34" charset="-122"/>
                 <a:cs typeface="Microsoft YaHei" pitchFamily="34" charset="-120"/>
               </a:rPr>
-              <a:t>严格以 Ensembl ID 取：人 ENSG00000150782 / 鼠 ENSMUSG00000039217，每个数据集均命中</a:t>
-            </a:r>
-            <a:endParaRPr lang="en-US" sz="1250" dirty="0"/>
-          </a:p>
-        </p:txBody>
-      </p:sp>
-      <p:sp>
-        <p:nvSpPr>
-          <p:cNvPr id="8" name="Text 6"/>
+              <a:t>人、小鼠全程分开，表与图均不合并</a:t>
+            </a:r>
+            <a:endParaRPr lang="en-US" sz="1300" dirty="0"/>
+          </a:p>
+        </p:txBody>
+      </p:sp>
+      <p:sp>
+        <p:nvSpPr>
+          <p:cNvPr id="5" name="Text 3"/>
           <p:cNvSpPr txBox="1"/>
           <p:nvPr/>
         </p:nvSpPr>
         <p:spPr>
           <a:xfrm>
-            <a:off x="640080" y="3922776"/>
+            <a:off x="640080" y="1938528"/>
             <a:ext cx="1554480" cy="457200"/>
           </a:xfrm>
           <a:prstGeom prst="rect">
@@ -3009,48 +2223,6 @@
             </a:pPr>
             <a:r>
               <a:rPr lang="en-US" sz="1300" b="1" dirty="0">
-                <a:solidFill>
-                  <a:srgbClr val="1C5CAB"/>
-                </a:solidFill>
-                <a:latin typeface="Microsoft YaHei" pitchFamily="34" charset="0"/>
-                <a:ea typeface="Microsoft YaHei" pitchFamily="34" charset="-122"/>
-                <a:cs typeface="Microsoft YaHei" pitchFamily="34" charset="-120"/>
-              </a:rPr>
-              <a:t>条件</a:t>
-            </a:r>
-            <a:endParaRPr lang="en-US" sz="1300" dirty="0"/>
-          </a:p>
-        </p:txBody>
-      </p:sp>
-      <p:sp>
-        <p:nvSpPr>
-          <p:cNvPr id="9" name="Text 7"/>
-          <p:cNvSpPr txBox="1"/>
-          <p:nvPr/>
-        </p:nvSpPr>
-        <p:spPr>
-          <a:xfrm>
-            <a:off x="2240280" y="3922776"/>
-            <a:ext cx="3931920" cy="914400"/>
-          </a:xfrm>
-          <a:prstGeom prst="rect">
-            <a:avLst/>
-          </a:prstGeom>
-          <a:noFill/>
-          <a:ln/>
-        </p:spPr>
-        <p:txBody>
-          <a:bodyPr wrap="square" rtlCol="0" anchor="t"/>
-          <a:lstStyle/>
-          <a:p>
-            <a:pPr indent="0" marL="0">
-              <a:lnSpc>
-                <a:spcPct val="112000"/>
-              </a:lnSpc>
-              <a:buNone/>
-            </a:pPr>
-            <a:r>
-              <a:rPr lang="en-US" sz="1250" dirty="0">
                 <a:solidFill>
                   <a:srgbClr val="1A1A1A"/>
                 </a:solidFill>
@@ -3058,22 +2230,22 @@
                 <a:ea typeface="Microsoft YaHei" pitchFamily="34" charset="-122"/>
                 <a:cs typeface="Microsoft YaHei" pitchFamily="34" charset="-120"/>
               </a:rPr>
-              <a:t>静息 · SARS-CoV-2 · 甲型流感 · 细菌性肺炎 · LPS 急性肺损伤</a:t>
-            </a:r>
-            <a:endParaRPr lang="en-US" sz="1250" dirty="0"/>
-          </a:p>
-        </p:txBody>
-      </p:sp>
-      <p:sp>
-        <p:nvSpPr>
-          <p:cNvPr id="10" name="Text 8"/>
+              <a:t>基因</a:t>
+            </a:r>
+            <a:endParaRPr lang="en-US" sz="1300" dirty="0"/>
+          </a:p>
+        </p:txBody>
+      </p:sp>
+      <p:sp>
+        <p:nvSpPr>
+          <p:cNvPr id="6" name="Text 4"/>
           <p:cNvSpPr txBox="1"/>
           <p:nvPr/>
         </p:nvSpPr>
         <p:spPr>
           <a:xfrm>
-            <a:off x="640080" y="4946904"/>
-            <a:ext cx="1554480" cy="457200"/>
+            <a:off x="2286000" y="1938528"/>
+            <a:ext cx="9418320" cy="457200"/>
           </a:xfrm>
           <a:prstGeom prst="rect">
             <a:avLst/>
@@ -3089,49 +2261,7 @@
               <a:buNone/>
             </a:pPr>
             <a:r>
-              <a:rPr lang="en-US" sz="1300" b="1" dirty="0">
-                <a:solidFill>
-                  <a:srgbClr val="1C5CAB"/>
-                </a:solidFill>
-                <a:latin typeface="Microsoft YaHei" pitchFamily="34" charset="0"/>
-                <a:ea typeface="Microsoft YaHei" pitchFamily="34" charset="-122"/>
-                <a:cs typeface="Microsoft YaHei" pitchFamily="34" charset="-120"/>
-              </a:rPr>
-              <a:t>细胞类型</a:t>
-            </a:r>
-            <a:endParaRPr lang="en-US" sz="1300" dirty="0"/>
-          </a:p>
-        </p:txBody>
-      </p:sp>
-      <p:sp>
-        <p:nvSpPr>
-          <p:cNvPr id="11" name="Text 9"/>
-          <p:cNvSpPr txBox="1"/>
-          <p:nvPr/>
-        </p:nvSpPr>
-        <p:spPr>
-          <a:xfrm>
-            <a:off x="2240280" y="4946904"/>
-            <a:ext cx="3931920" cy="914400"/>
-          </a:xfrm>
-          <a:prstGeom prst="rect">
-            <a:avLst/>
-          </a:prstGeom>
-          <a:noFill/>
-          <a:ln/>
-        </p:spPr>
-        <p:txBody>
-          <a:bodyPr wrap="square" rtlCol="0" anchor="t"/>
-          <a:lstStyle/>
-          <a:p>
-            <a:pPr indent="0" marL="0">
-              <a:lnSpc>
-                <a:spcPct val="112000"/>
-              </a:lnSpc>
-              <a:buNone/>
-            </a:pPr>
-            <a:r>
-              <a:rPr lang="en-US" sz="1250" dirty="0">
+              <a:rPr lang="en-US" sz="1300" dirty="0">
                 <a:solidFill>
                   <a:srgbClr val="1A1A1A"/>
                 </a:solidFill>
@@ -3139,21 +2269,21 @@
                 <a:ea typeface="Microsoft YaHei" pitchFamily="34" charset="-122"/>
                 <a:cs typeface="Microsoft YaHei" pitchFamily="34" charset="-120"/>
               </a:rPr>
-              <a:t>统一为 11 类；用作者注释，不重新聚类（LPS 两套为自行注释，见末页）</a:t>
-            </a:r>
-            <a:endParaRPr lang="en-US" sz="1250" dirty="0"/>
-          </a:p>
-        </p:txBody>
-      </p:sp>
-      <p:sp>
-        <p:nvSpPr>
-          <p:cNvPr id="12" name="Text 10"/>
+              <a:t>以 Ensembl ID 取：人 ENSG00000150782 / 鼠 ENSMUSG00000039217</a:t>
+            </a:r>
+            <a:endParaRPr lang="en-US" sz="1300" dirty="0"/>
+          </a:p>
+        </p:txBody>
+      </p:sp>
+      <p:sp>
+        <p:nvSpPr>
+          <p:cNvPr id="7" name="Text 5"/>
           <p:cNvSpPr txBox="1"/>
           <p:nvPr/>
         </p:nvSpPr>
         <p:spPr>
           <a:xfrm>
-            <a:off x="6355080" y="1874520"/>
+            <a:off x="640080" y="2505456"/>
             <a:ext cx="1554480" cy="457200"/>
           </a:xfrm>
           <a:prstGeom prst="rect">
@@ -3171,48 +2301,6 @@
             </a:pPr>
             <a:r>
               <a:rPr lang="en-US" sz="1300" b="1" dirty="0">
-                <a:solidFill>
-                  <a:srgbClr val="1C5CAB"/>
-                </a:solidFill>
-                <a:latin typeface="Microsoft YaHei" pitchFamily="34" charset="0"/>
-                <a:ea typeface="Microsoft YaHei" pitchFamily="34" charset="-122"/>
-                <a:cs typeface="Microsoft YaHei" pitchFamily="34" charset="-120"/>
-              </a:rPr>
-              <a:t>统计单位</a:t>
-            </a:r>
-            <a:endParaRPr lang="en-US" sz="1300" dirty="0"/>
-          </a:p>
-        </p:txBody>
-      </p:sp>
-      <p:sp>
-        <p:nvSpPr>
-          <p:cNvPr id="13" name="Text 11"/>
-          <p:cNvSpPr txBox="1"/>
-          <p:nvPr/>
-        </p:nvSpPr>
-        <p:spPr>
-          <a:xfrm>
-            <a:off x="7955280" y="1874520"/>
-            <a:ext cx="3931920" cy="914400"/>
-          </a:xfrm>
-          <a:prstGeom prst="rect">
-            <a:avLst/>
-          </a:prstGeom>
-          <a:noFill/>
-          <a:ln/>
-        </p:spPr>
-        <p:txBody>
-          <a:bodyPr wrap="square" rtlCol="0" anchor="t"/>
-          <a:lstStyle/>
-          <a:p>
-            <a:pPr indent="0" marL="0">
-              <a:lnSpc>
-                <a:spcPct val="112000"/>
-              </a:lnSpc>
-              <a:buNone/>
-            </a:pPr>
-            <a:r>
-              <a:rPr lang="en-US" sz="1250" dirty="0">
                 <a:solidFill>
                   <a:srgbClr val="1A1A1A"/>
                 </a:solidFill>
@@ -3220,22 +2308,22 @@
                 <a:ea typeface="Microsoft YaHei" pitchFamily="34" charset="-122"/>
                 <a:cs typeface="Microsoft YaHei" pitchFamily="34" charset="-120"/>
               </a:rPr>
-              <a:t>供体/动物，绝不以细胞为重复</a:t>
-            </a:r>
-            <a:endParaRPr lang="en-US" sz="1250" dirty="0"/>
-          </a:p>
-        </p:txBody>
-      </p:sp>
-      <p:sp>
-        <p:nvSpPr>
-          <p:cNvPr id="14" name="Text 12"/>
+              <a:t>细胞类型</a:t>
+            </a:r>
+            <a:endParaRPr lang="en-US" sz="1300" dirty="0"/>
+          </a:p>
+        </p:txBody>
+      </p:sp>
+      <p:sp>
+        <p:nvSpPr>
+          <p:cNvPr id="8" name="Text 6"/>
           <p:cNvSpPr txBox="1"/>
           <p:nvPr/>
         </p:nvSpPr>
         <p:spPr>
           <a:xfrm>
-            <a:off x="6355080" y="2898648"/>
-            <a:ext cx="1554480" cy="457200"/>
+            <a:off x="2286000" y="2505456"/>
+            <a:ext cx="9418320" cy="457200"/>
           </a:xfrm>
           <a:prstGeom prst="rect">
             <a:avLst/>
@@ -3251,49 +2339,7 @@
               <a:buNone/>
             </a:pPr>
             <a:r>
-              <a:rPr lang="en-US" sz="1300" b="1" dirty="0">
-                <a:solidFill>
-                  <a:srgbClr val="1C5CAB"/>
-                </a:solidFill>
-                <a:latin typeface="Microsoft YaHei" pitchFamily="34" charset="0"/>
-                <a:ea typeface="Microsoft YaHei" pitchFamily="34" charset="-122"/>
-                <a:cs typeface="Microsoft YaHei" pitchFamily="34" charset="-120"/>
-              </a:rPr>
-              <a:t>阈值</a:t>
-            </a:r>
-            <a:endParaRPr lang="en-US" sz="1300" dirty="0"/>
-          </a:p>
-        </p:txBody>
-      </p:sp>
-      <p:sp>
-        <p:nvSpPr>
-          <p:cNvPr id="15" name="Text 13"/>
-          <p:cNvSpPr txBox="1"/>
-          <p:nvPr/>
-        </p:nvSpPr>
-        <p:spPr>
-          <a:xfrm>
-            <a:off x="7955280" y="2898648"/>
-            <a:ext cx="3931920" cy="914400"/>
-          </a:xfrm>
-          <a:prstGeom prst="rect">
-            <a:avLst/>
-          </a:prstGeom>
-          <a:noFill/>
-          <a:ln/>
-        </p:spPr>
-        <p:txBody>
-          <a:bodyPr wrap="square" rtlCol="0" anchor="t"/>
-          <a:lstStyle/>
-          <a:p>
-            <a:pPr indent="0" marL="0">
-              <a:lnSpc>
-                <a:spcPct val="112000"/>
-              </a:lnSpc>
-              <a:buNone/>
-            </a:pPr>
-            <a:r>
-              <a:rPr lang="en-US" sz="1250" dirty="0">
+              <a:rPr lang="en-US" sz="1300" dirty="0">
                 <a:solidFill>
                   <a:srgbClr val="1A1A1A"/>
                 </a:solidFill>
@@ -3301,21 +2347,21 @@
                 <a:ea typeface="Microsoft YaHei" pitchFamily="34" charset="-122"/>
                 <a:cs typeface="Microsoft YaHei" pitchFamily="34" charset="-120"/>
               </a:rPr>
-              <a:t>供体×细胞类型 n_cells&lt;20 置 NA；条件 n_donors&lt;3 仅描述统计</a:t>
-            </a:r>
-            <a:endParaRPr lang="en-US" sz="1250" dirty="0"/>
-          </a:p>
-        </p:txBody>
-      </p:sp>
-      <p:sp>
-        <p:nvSpPr>
-          <p:cNvPr id="16" name="Text 14"/>
+              <a:t>统一为 11 类；用作者注释，不重新聚类（小鼠 LPS 两套无作者注释，自行注释）</a:t>
+            </a:r>
+            <a:endParaRPr lang="en-US" sz="1300" dirty="0"/>
+          </a:p>
+        </p:txBody>
+      </p:sp>
+      <p:sp>
+        <p:nvSpPr>
+          <p:cNvPr id="9" name="Text 7"/>
           <p:cNvSpPr txBox="1"/>
           <p:nvPr/>
         </p:nvSpPr>
         <p:spPr>
           <a:xfrm>
-            <a:off x="6355080" y="3922776"/>
+            <a:off x="640080" y="3072384"/>
             <a:ext cx="1554480" cy="457200"/>
           </a:xfrm>
           <a:prstGeom prst="rect">
@@ -3333,48 +2379,6 @@
             </a:pPr>
             <a:r>
               <a:rPr lang="en-US" sz="1300" b="1" dirty="0">
-                <a:solidFill>
-                  <a:srgbClr val="1C5CAB"/>
-                </a:solidFill>
-                <a:latin typeface="Microsoft YaHei" pitchFamily="34" charset="0"/>
-                <a:ea typeface="Microsoft YaHei" pitchFamily="34" charset="-122"/>
-                <a:cs typeface="Microsoft YaHei" pitchFamily="34" charset="-120"/>
-              </a:rPr>
-              <a:t>跨数据集</a:t>
-            </a:r>
-            <a:endParaRPr lang="en-US" sz="1300" dirty="0"/>
-          </a:p>
-        </p:txBody>
-      </p:sp>
-      <p:sp>
-        <p:nvSpPr>
-          <p:cNvPr id="17" name="Text 15"/>
-          <p:cNvSpPr txBox="1"/>
-          <p:nvPr/>
-        </p:nvSpPr>
-        <p:spPr>
-          <a:xfrm>
-            <a:off x="7955280" y="3922776"/>
-            <a:ext cx="3931920" cy="914400"/>
-          </a:xfrm>
-          <a:prstGeom prst="rect">
-            <a:avLst/>
-          </a:prstGeom>
-          <a:noFill/>
-          <a:ln/>
-        </p:spPr>
-        <p:txBody>
-          <a:bodyPr wrap="square" rtlCol="0" anchor="t"/>
-          <a:lstStyle/>
-          <a:p>
-            <a:pPr indent="0" marL="0">
-              <a:lnSpc>
-                <a:spcPct val="112000"/>
-              </a:lnSpc>
-              <a:buNone/>
-            </a:pPr>
-            <a:r>
-              <a:rPr lang="en-US" sz="1250" dirty="0">
                 <a:solidFill>
                   <a:srgbClr val="1A1A1A"/>
                 </a:solidFill>
@@ -3382,22 +2386,22 @@
                 <a:ea typeface="Microsoft YaHei" pitchFamily="34" charset="-122"/>
                 <a:cs typeface="Microsoft YaHei" pitchFamily="34" charset="-120"/>
               </a:rPr>
-              <a:t>只比数据集内排序，不比 logCPM 绝对值</a:t>
-            </a:r>
-            <a:endParaRPr lang="en-US" sz="1250" dirty="0"/>
-          </a:p>
-        </p:txBody>
-      </p:sp>
-      <p:sp>
-        <p:nvSpPr>
-          <p:cNvPr id="18" name="Text 16"/>
+              <a:t>统计</a:t>
+            </a:r>
+            <a:endParaRPr lang="en-US" sz="1300" dirty="0"/>
+          </a:p>
+        </p:txBody>
+      </p:sp>
+      <p:sp>
+        <p:nvSpPr>
+          <p:cNvPr id="10" name="Text 8"/>
           <p:cNvSpPr txBox="1"/>
           <p:nvPr/>
         </p:nvSpPr>
         <p:spPr>
           <a:xfrm>
-            <a:off x="6355080" y="4946904"/>
-            <a:ext cx="1554480" cy="457200"/>
+            <a:off x="2286000" y="3072384"/>
+            <a:ext cx="9418320" cy="457200"/>
           </a:xfrm>
           <a:prstGeom prst="rect">
             <a:avLst/>
@@ -3413,9 +2417,48 @@
               <a:buNone/>
             </a:pPr>
             <a:r>
+              <a:rPr lang="en-US" sz="1300" dirty="0">
+                <a:solidFill>
+                  <a:srgbClr val="1A1A1A"/>
+                </a:solidFill>
+                <a:latin typeface="Microsoft YaHei" pitchFamily="34" charset="0"/>
+                <a:ea typeface="Microsoft YaHei" pitchFamily="34" charset="-122"/>
+                <a:cs typeface="Microsoft YaHei" pitchFamily="34" charset="-120"/>
+              </a:rPr>
+              <a:t>以供体为单位；n_cells&lt;20 置 NA，n_donors&lt;3 仅描述统计；跨数据集只比数据集内排序</a:t>
+            </a:r>
+            <a:endParaRPr lang="en-US" sz="1300" dirty="0"/>
+          </a:p>
+        </p:txBody>
+      </p:sp>
+      <p:sp>
+        <p:nvSpPr>
+          <p:cNvPr id="11" name="Text 9"/>
+          <p:cNvSpPr txBox="1"/>
+          <p:nvPr/>
+        </p:nvSpPr>
+        <p:spPr>
+          <a:xfrm>
+            <a:off x="640080" y="3639312"/>
+            <a:ext cx="1554480" cy="457200"/>
+          </a:xfrm>
+          <a:prstGeom prst="rect">
+            <a:avLst/>
+          </a:prstGeom>
+          <a:noFill/>
+          <a:ln/>
+        </p:spPr>
+        <p:txBody>
+          <a:bodyPr wrap="square" rtlCol="0" anchor="t"/>
+          <a:lstStyle/>
+          <a:p>
+            <a:pPr indent="0" marL="0">
+              <a:buNone/>
+            </a:pPr>
+            <a:r>
               <a:rPr lang="en-US" sz="1300" b="1" dirty="0">
                 <a:solidFill>
-                  <a:srgbClr val="1C5CAB"/>
+                  <a:srgbClr val="1A1A1A"/>
                 </a:solidFill>
                 <a:latin typeface="Microsoft YaHei" pitchFamily="34" charset="0"/>
                 <a:ea typeface="Microsoft YaHei" pitchFamily="34" charset="-122"/>
@@ -3429,14 +2472,14 @@
       </p:sp>
       <p:sp>
         <p:nvSpPr>
-          <p:cNvPr id="19" name="Text 17"/>
+          <p:cNvPr id="12" name="Text 10"/>
           <p:cNvSpPr txBox="1"/>
           <p:nvPr/>
         </p:nvSpPr>
         <p:spPr>
           <a:xfrm>
-            <a:off x="7955280" y="4946904"/>
-            <a:ext cx="3931920" cy="914400"/>
+            <a:off x="2286000" y="3639312"/>
+            <a:ext cx="9418320" cy="457200"/>
           </a:xfrm>
           <a:prstGeom prst="rect">
             <a:avLst/>
@@ -3449,13 +2492,10 @@
           <a:lstStyle/>
           <a:p>
             <a:pPr indent="0" marL="0">
-              <a:lnSpc>
-                <a:spcPct val="112000"/>
-              </a:lnSpc>
               <a:buNone/>
             </a:pPr>
             <a:r>
-              <a:rPr lang="en-US" sz="1250" dirty="0">
+              <a:rPr lang="en-US" sz="1300" dirty="0">
                 <a:solidFill>
                   <a:srgbClr val="1A1A1A"/>
                 </a:solidFill>
@@ -3465,20 +2505,43 @@
               </a:rPr>
               <a:t>无法校正的 10x 数据其上皮结果不进结论；Tabula Sapiens 用作者 decontX</a:t>
             </a:r>
-            <a:endParaRPr lang="en-US" sz="1250" dirty="0"/>
-          </a:p>
-        </p:txBody>
-      </p:sp>
-      <p:sp>
-        <p:nvSpPr>
-          <p:cNvPr id="20" name="Text 18"/>
+            <a:endParaRPr lang="en-US" sz="1300" dirty="0"/>
+          </a:p>
+        </p:txBody>
+      </p:sp>
+      <p:sp>
+        <p:nvSpPr>
+          <p:cNvPr id="13" name="Shape 11"/>
+          <p:cNvSpPr/>
+          <p:nvPr/>
+        </p:nvSpPr>
+        <p:spPr>
+          <a:xfrm>
+            <a:off x="640080" y="4251960"/>
+            <a:ext cx="10881360" cy="0"/>
+          </a:xfrm>
+          <a:prstGeom prst="line">
+            <a:avLst/>
+          </a:prstGeom>
+          <a:noFill/>
+          <a:ln w="12700">
+            <a:solidFill>
+              <a:srgbClr val="D8DBE0"/>
+            </a:solidFill>
+            <a:prstDash val="solid"/>
+          </a:ln>
+        </p:spPr>
+      </p:sp>
+      <p:sp>
+        <p:nvSpPr>
+          <p:cNvPr id="14" name="Text 12"/>
           <p:cNvSpPr txBox="1"/>
           <p:nvPr/>
         </p:nvSpPr>
         <p:spPr>
           <a:xfrm>
-            <a:off x="640080" y="6291072"/>
-            <a:ext cx="10972800" cy="365760"/>
+            <a:off x="640080" y="4389120"/>
+            <a:ext cx="10972800" cy="320040"/>
           </a:xfrm>
           <a:prstGeom prst="rect">
             <a:avLst/>
@@ -3494,7 +2557,46 @@
               <a:buNone/>
             </a:pPr>
             <a:r>
-              <a:rPr lang="en-US" sz="1050" i="1" dirty="0">
+              <a:rPr lang="en-US" sz="1300" b="1" dirty="0">
+                <a:solidFill>
+                  <a:srgbClr val="1A1A1A"/>
+                </a:solidFill>
+                <a:latin typeface="Microsoft YaHei" pitchFamily="34" charset="0"/>
+                <a:ea typeface="Microsoft YaHei" pitchFamily="34" charset="-122"/>
+                <a:cs typeface="Microsoft YaHei" pitchFamily="34" charset="-120"/>
+              </a:rPr>
+              <a:t>数据库来源</a:t>
+            </a:r>
+            <a:endParaRPr lang="en-US" sz="1300" dirty="0"/>
+          </a:p>
+        </p:txBody>
+      </p:sp>
+      <p:sp>
+        <p:nvSpPr>
+          <p:cNvPr id="15" name="Text 13"/>
+          <p:cNvSpPr txBox="1"/>
+          <p:nvPr/>
+        </p:nvSpPr>
+        <p:spPr>
+          <a:xfrm>
+            <a:off x="640080" y="4663440"/>
+            <a:ext cx="11338560" cy="292608"/>
+          </a:xfrm>
+          <a:prstGeom prst="rect">
+            <a:avLst/>
+          </a:prstGeom>
+          <a:noFill/>
+          <a:ln/>
+        </p:spPr>
+        <p:txBody>
+          <a:bodyPr wrap="square" rtlCol="0" anchor="t"/>
+          <a:lstStyle/>
+          <a:p>
+            <a:pPr indent="0" marL="0">
+              <a:buNone/>
+            </a:pPr>
+            <a:r>
+              <a:rPr lang="en-US" sz="1100" dirty="0">
                 <a:solidFill>
                   <a:srgbClr val="6B6B6B"/>
                 </a:solidFill>
@@ -3502,9 +2604,165 @@
                 <a:ea typeface="Microsoft YaHei" pitchFamily="34" charset="-122"/>
                 <a:cs typeface="Microsoft YaHei" pitchFamily="34" charset="-120"/>
               </a:rPr>
-              <a:t>来源：CZ CELLxGENE Census、Human Lung Cell Atlas、Tabula Sapiens/Muris Senis、LungMAP、COVID-19 Cell Atlas、GEO；零值参考 DICE（人）与 ImmGen（鼠）</a:t>
-            </a:r>
-            <a:endParaRPr lang="en-US" sz="1050" dirty="0"/>
+              <a:t>CZ CELLxGENE Census（主入口，人/小鼠肺）</a:t>
+            </a:r>
+            <a:endParaRPr lang="en-US" sz="1100" dirty="0"/>
+          </a:p>
+        </p:txBody>
+      </p:sp>
+      <p:sp>
+        <p:nvSpPr>
+          <p:cNvPr id="16" name="Text 14"/>
+          <p:cNvSpPr txBox="1"/>
+          <p:nvPr/>
+        </p:nvSpPr>
+        <p:spPr>
+          <a:xfrm>
+            <a:off x="640080" y="5029200"/>
+            <a:ext cx="11338560" cy="292608"/>
+          </a:xfrm>
+          <a:prstGeom prst="rect">
+            <a:avLst/>
+          </a:prstGeom>
+          <a:noFill/>
+          <a:ln/>
+        </p:spPr>
+        <p:txBody>
+          <a:bodyPr wrap="square" rtlCol="0" anchor="t"/>
+          <a:lstStyle/>
+          <a:p>
+            <a:pPr indent="0" marL="0">
+              <a:buNone/>
+            </a:pPr>
+            <a:r>
+              <a:rPr lang="en-US" sz="1100" dirty="0">
+                <a:solidFill>
+                  <a:srgbClr val="6B6B6B"/>
+                </a:solidFill>
+                <a:latin typeface="Microsoft YaHei" pitchFamily="34" charset="0"/>
+                <a:ea typeface="Microsoft YaHei" pitchFamily="34" charset="-122"/>
+                <a:cs typeface="Microsoft YaHei" pitchFamily="34" charset="-120"/>
+              </a:rPr>
+              <a:t>Human Lung Cell Atlas · Tabula Sapiens · Tabula Muris Senis · LungMAP/CellRef · Cross-tissue Immune · Travaglini</a:t>
+            </a:r>
+            <a:endParaRPr lang="en-US" sz="1100" dirty="0"/>
+          </a:p>
+        </p:txBody>
+      </p:sp>
+      <p:sp>
+        <p:nvSpPr>
+          <p:cNvPr id="17" name="Text 15"/>
+          <p:cNvSpPr txBox="1"/>
+          <p:nvPr/>
+        </p:nvSpPr>
+        <p:spPr>
+          <a:xfrm>
+            <a:off x="640080" y="5394960"/>
+            <a:ext cx="11338560" cy="292608"/>
+          </a:xfrm>
+          <a:prstGeom prst="rect">
+            <a:avLst/>
+          </a:prstGeom>
+          <a:noFill/>
+          <a:ln/>
+        </p:spPr>
+        <p:txBody>
+          <a:bodyPr wrap="square" rtlCol="0" anchor="t"/>
+          <a:lstStyle/>
+          <a:p>
+            <a:pPr indent="0" marL="0">
+              <a:buNone/>
+            </a:pPr>
+            <a:r>
+              <a:rPr lang="en-US" sz="1100" dirty="0">
+                <a:solidFill>
+                  <a:srgbClr val="6B6B6B"/>
+                </a:solidFill>
+                <a:latin typeface="Microsoft YaHei" pitchFamily="34" charset="0"/>
+                <a:ea typeface="Microsoft YaHei" pitchFamily="34" charset="-122"/>
+                <a:cs typeface="Microsoft YaHei" pitchFamily="34" charset="-120"/>
+              </a:rPr>
+              <a:t>COVID-19 Cell Atlas：Melms / Delorey / Bharat 尸检 · Liao / Wauters / Grant BALF · Wu 离体肺</a:t>
+            </a:r>
+            <a:endParaRPr lang="en-US" sz="1100" dirty="0"/>
+          </a:p>
+        </p:txBody>
+      </p:sp>
+      <p:sp>
+        <p:nvSpPr>
+          <p:cNvPr id="18" name="Text 16"/>
+          <p:cNvSpPr txBox="1"/>
+          <p:nvPr/>
+        </p:nvSpPr>
+        <p:spPr>
+          <a:xfrm>
+            <a:off x="640080" y="5760720"/>
+            <a:ext cx="11338560" cy="292608"/>
+          </a:xfrm>
+          <a:prstGeom prst="rect">
+            <a:avLst/>
+          </a:prstGeom>
+          <a:noFill/>
+          <a:ln/>
+        </p:spPr>
+        <p:txBody>
+          <a:bodyPr wrap="square" rtlCol="0" anchor="t"/>
+          <a:lstStyle/>
+          <a:p>
+            <a:pPr indent="0" marL="0">
+              <a:buNone/>
+            </a:pPr>
+            <a:r>
+              <a:rPr lang="en-US" sz="1100" dirty="0">
+                <a:solidFill>
+                  <a:srgbClr val="6B6B6B"/>
+                </a:solidFill>
+                <a:latin typeface="Microsoft YaHei" pitchFamily="34" charset="0"/>
+                <a:ea typeface="Microsoft YaHei" pitchFamily="34" charset="-122"/>
+                <a:cs typeface="Microsoft YaHei" pitchFamily="34" charset="-120"/>
+              </a:rPr>
+              <a:t>GEO 小鼠：S. pneumoniae GSE236342 · A. baumannii GSE313334 · LPS-ALI GSE280364 / GSE280611</a:t>
+            </a:r>
+            <a:endParaRPr lang="en-US" sz="1100" dirty="0"/>
+          </a:p>
+        </p:txBody>
+      </p:sp>
+      <p:sp>
+        <p:nvSpPr>
+          <p:cNvPr id="19" name="Text 17"/>
+          <p:cNvSpPr txBox="1"/>
+          <p:nvPr/>
+        </p:nvSpPr>
+        <p:spPr>
+          <a:xfrm>
+            <a:off x="640080" y="6126480"/>
+            <a:ext cx="11338560" cy="292608"/>
+          </a:xfrm>
+          <a:prstGeom prst="rect">
+            <a:avLst/>
+          </a:prstGeom>
+          <a:noFill/>
+          <a:ln/>
+        </p:spPr>
+        <p:txBody>
+          <a:bodyPr wrap="square" rtlCol="0" anchor="t"/>
+          <a:lstStyle/>
+          <a:p>
+            <a:pPr indent="0" marL="0">
+              <a:buNone/>
+            </a:pPr>
+            <a:r>
+              <a:rPr lang="en-US" sz="1100" dirty="0">
+                <a:solidFill>
+                  <a:srgbClr val="6B6B6B"/>
+                </a:solidFill>
+                <a:latin typeface="Microsoft YaHei" pitchFamily="34" charset="0"/>
+                <a:ea typeface="Microsoft YaHei" pitchFamily="34" charset="-122"/>
+                <a:cs typeface="Microsoft YaHei" pitchFamily="34" charset="-120"/>
+              </a:rPr>
+              <a:t>零值参考（分选 bulk）：DICE（人）· ImmGen（鼠）</a:t>
+            </a:r>
+            <a:endParaRPr lang="en-US" sz="1100" dirty="0"/>
           </a:p>
         </p:txBody>
       </p:sp>
@@ -3542,7 +2800,7 @@
         <p:spPr>
           <a:xfrm>
             <a:off x="640080" y="457200"/>
-            <a:ext cx="10972800" cy="274320"/>
+            <a:ext cx="10972800" cy="640080"/>
           </a:xfrm>
           <a:prstGeom prst="rect">
             <a:avLst/>
@@ -3558,46 +2816,7 @@
               <a:buNone/>
             </a:pPr>
             <a:r>
-              <a:rPr lang="en-US" sz="1200" b="1" spc="200" kern="0" dirty="0">
-                <a:solidFill>
-                  <a:srgbClr val="1C5CAB"/>
-                </a:solidFill>
-                <a:latin typeface="Microsoft YaHei" pitchFamily="34" charset="0"/>
-                <a:ea typeface="Microsoft YaHei" pitchFamily="34" charset="-122"/>
-                <a:cs typeface="Microsoft YaHei" pitchFamily="34" charset="-120"/>
-              </a:rPr>
-              <a:t>人 · 总览</a:t>
-            </a:r>
-            <a:endParaRPr lang="en-US" sz="1200" dirty="0"/>
-          </a:p>
-        </p:txBody>
-      </p:sp>
-      <p:sp>
-        <p:nvSpPr>
-          <p:cNvPr id="3" name="Text 1"/>
-          <p:cNvSpPr txBox="1"/>
-          <p:nvPr/>
-        </p:nvSpPr>
-        <p:spPr>
-          <a:xfrm>
-            <a:off x="640080" y="713232"/>
-            <a:ext cx="10972800" cy="640080"/>
-          </a:xfrm>
-          <a:prstGeom prst="rect">
-            <a:avLst/>
-          </a:prstGeom>
-          <a:noFill/>
-          <a:ln/>
-        </p:spPr>
-        <p:txBody>
-          <a:bodyPr wrap="square" rtlCol="0" anchor="ctr"/>
-          <a:lstStyle/>
-          <a:p>
-            <a:pPr indent="0" marL="0">
-              <a:buNone/>
-            </a:pPr>
-            <a:r>
-              <a:rPr lang="en-US" sz="2600" b="1" dirty="0">
+              <a:rPr lang="en-US" sz="2500" b="1" dirty="0">
                 <a:solidFill>
                   <a:srgbClr val="1A1A1A"/>
                 </a:solidFill>
@@ -3605,15 +2824,15 @@
                 <a:ea typeface="Microsoft YaHei" pitchFamily="34" charset="-122"/>
                 <a:cs typeface="Microsoft YaHei" pitchFamily="34" charset="-120"/>
               </a:rPr>
-              <a:t>每个单细胞数据集的 IL18 散点图</a:t>
-            </a:r>
-            <a:endParaRPr lang="en-US" sz="2600" dirty="0"/>
+              <a:t>人 · 各单细胞数据集的 IL18 散点图</a:t>
+            </a:r>
+            <a:endParaRPr lang="en-US" sz="2500" dirty="0"/>
           </a:p>
         </p:txBody>
       </p:sp>
       <p:pic>
         <p:nvPicPr>
-          <p:cNvPr id="4" name="Image 0" descr="/home/user/aaa/il18_lung/figures/master_human.png">    </p:cNvPr>
+          <p:cNvPr id="3" name="Image 0" descr="/home/user/aaa/il18_lung/figures/master_human.png">    </p:cNvPr>
           <p:cNvPicPr>
             <a:picLocks noChangeAspect="1"/>
           </p:cNvPicPr>
@@ -3627,8 +2846,8 @@
         </p:blipFill>
         <p:spPr>
           <a:xfrm>
-            <a:off x="2466837" y="1417320"/>
-            <a:ext cx="7255278" cy="4937760"/>
+            <a:off x="2366069" y="1234440"/>
+            <a:ext cx="7456814" cy="5074920"/>
           </a:xfrm>
           <a:prstGeom prst="rect">
             <a:avLst/>
@@ -3637,14 +2856,14 @@
       </p:pic>
       <p:sp>
         <p:nvSpPr>
-          <p:cNvPr id="5" name="Text 2"/>
+          <p:cNvPr id="4" name="Text 1"/>
           <p:cNvSpPr txBox="1"/>
           <p:nvPr/>
         </p:nvSpPr>
         <p:spPr>
           <a:xfrm>
-            <a:off x="640080" y="6291072"/>
-            <a:ext cx="10972800" cy="365760"/>
+            <a:off x="640080" y="6327648"/>
+            <a:ext cx="10972800" cy="347472"/>
           </a:xfrm>
           <a:prstGeom prst="rect">
             <a:avLst/>
@@ -3660,7 +2879,7 @@
               <a:buNone/>
             </a:pPr>
             <a:r>
-              <a:rPr lang="en-US" sz="1050" i="1" dirty="0">
+              <a:rPr lang="en-US" sz="1050" dirty="0">
                 <a:solidFill>
                   <a:srgbClr val="6B6B6B"/>
                 </a:solidFill>
@@ -3668,7 +2887,7 @@
                 <a:ea typeface="Microsoft YaHei" pitchFamily="34" charset="-122"/>
                 <a:cs typeface="Microsoft YaHei" pitchFamily="34" charset="-120"/>
               </a:rPr>
-              <a:t>测量对象：IL18 转录本（pro-IL-18）。点大小=供体中位阳性比例；颜色=数据集内排序（1=最高）。空心点=环境 RNA 未校正的上皮类，不用于结论。</a:t>
+              <a:t>点大小=供体中位阳性比例；颜色=数据集内排序（1=最高）。空心点=环境 RNA 未校正的上皮类，不用于结论。</a:t>
             </a:r>
             <a:endParaRPr lang="en-US" sz="1050" dirty="0"/>
           </a:p>
@@ -3708,7 +2927,7 @@
         <p:spPr>
           <a:xfrm>
             <a:off x="640080" y="457200"/>
-            <a:ext cx="10972800" cy="274320"/>
+            <a:ext cx="10972800" cy="640080"/>
           </a:xfrm>
           <a:prstGeom prst="rect">
             <a:avLst/>
@@ -3724,46 +2943,7 @@
               <a:buNone/>
             </a:pPr>
             <a:r>
-              <a:rPr lang="en-US" sz="1200" b="1" spc="200" kern="0" dirty="0">
-                <a:solidFill>
-                  <a:srgbClr val="1C5CAB"/>
-                </a:solidFill>
-                <a:latin typeface="Microsoft YaHei" pitchFamily="34" charset="0"/>
-                <a:ea typeface="Microsoft YaHei" pitchFamily="34" charset="-122"/>
-                <a:cs typeface="Microsoft YaHei" pitchFamily="34" charset="-120"/>
-              </a:rPr>
-              <a:t>小鼠 · 总览</a:t>
-            </a:r>
-            <a:endParaRPr lang="en-US" sz="1200" dirty="0"/>
-          </a:p>
-        </p:txBody>
-      </p:sp>
-      <p:sp>
-        <p:nvSpPr>
-          <p:cNvPr id="3" name="Text 1"/>
-          <p:cNvSpPr txBox="1"/>
-          <p:nvPr/>
-        </p:nvSpPr>
-        <p:spPr>
-          <a:xfrm>
-            <a:off x="640080" y="713232"/>
-            <a:ext cx="10972800" cy="640080"/>
-          </a:xfrm>
-          <a:prstGeom prst="rect">
-            <a:avLst/>
-          </a:prstGeom>
-          <a:noFill/>
-          <a:ln/>
-        </p:spPr>
-        <p:txBody>
-          <a:bodyPr wrap="square" rtlCol="0" anchor="ctr"/>
-          <a:lstStyle/>
-          <a:p>
-            <a:pPr indent="0" marL="0">
-              <a:buNone/>
-            </a:pPr>
-            <a:r>
-              <a:rPr lang="en-US" sz="2600" b="1" dirty="0">
+              <a:rPr lang="en-US" sz="2500" b="1" dirty="0">
                 <a:solidFill>
                   <a:srgbClr val="1A1A1A"/>
                 </a:solidFill>
@@ -3771,15 +2951,15 @@
                 <a:ea typeface="Microsoft YaHei" pitchFamily="34" charset="-122"/>
                 <a:cs typeface="Microsoft YaHei" pitchFamily="34" charset="-120"/>
               </a:rPr>
-              <a:t>每个单细胞数据集的 IL18 散点图</a:t>
-            </a:r>
-            <a:endParaRPr lang="en-US" sz="2600" dirty="0"/>
+              <a:t>小鼠 · 各单细胞数据集的 IL18 散点图</a:t>
+            </a:r>
+            <a:endParaRPr lang="en-US" sz="2500" dirty="0"/>
           </a:p>
         </p:txBody>
       </p:sp>
       <p:pic>
         <p:nvPicPr>
-          <p:cNvPr id="4" name="Image 0" descr="/home/user/aaa/il18_lung/figures/master_mouse.png">    </p:cNvPr>
+          <p:cNvPr id="3" name="Image 0" descr="/home/user/aaa/il18_lung/figures/master_mouse.png">    </p:cNvPr>
           <p:cNvPicPr>
             <a:picLocks noChangeAspect="1"/>
           </p:cNvPicPr>
@@ -3793,8 +2973,8 @@
         </p:blipFill>
         <p:spPr>
           <a:xfrm>
-            <a:off x="1025133" y="1508760"/>
-            <a:ext cx="10138685" cy="4526280"/>
+            <a:off x="973928" y="1371600"/>
+            <a:ext cx="10241096" cy="4572000"/>
           </a:xfrm>
           <a:prstGeom prst="rect">
             <a:avLst/>
@@ -3803,14 +2983,14 @@
       </p:pic>
       <p:sp>
         <p:nvSpPr>
-          <p:cNvPr id="5" name="Text 2"/>
+          <p:cNvPr id="4" name="Text 1"/>
           <p:cNvSpPr txBox="1"/>
           <p:nvPr/>
         </p:nvSpPr>
         <p:spPr>
           <a:xfrm>
-            <a:off x="640080" y="6291072"/>
-            <a:ext cx="10972800" cy="365760"/>
+            <a:off x="640080" y="6327648"/>
+            <a:ext cx="10972800" cy="347472"/>
           </a:xfrm>
           <a:prstGeom prst="rect">
             <a:avLst/>
@@ -3826,7 +3006,7 @@
               <a:buNone/>
             </a:pPr>
             <a:r>
-              <a:rPr lang="en-US" sz="1050" i="1" dirty="0">
+              <a:rPr lang="en-US" sz="1050" dirty="0">
                 <a:solidFill>
                   <a:srgbClr val="6B6B6B"/>
                 </a:solidFill>
@@ -3834,7 +3014,7 @@
                 <a:ea typeface="Microsoft YaHei" pitchFamily="34" charset="-122"/>
                 <a:cs typeface="Microsoft YaHei" pitchFamily="34" charset="-120"/>
               </a:rPr>
-              <a:t>测量对象：IL18 转录本（pro-IL-18）。肺泡巨噬细胞在静息、流感、细菌、LPS 全部条件下均排名第一。带 * 为自行注释的 LPS 数据集。流感仅示 d42。</a:t>
+              <a:t>肺泡巨噬细胞在静息、流感、细菌、LPS 全部条件下排名第一。带 * 为自行注释的 LPS 数据集；流感仅示 d42。</a:t>
             </a:r>
             <a:endParaRPr lang="en-US" sz="1050" dirty="0"/>
           </a:p>
@@ -3874,7 +3054,7 @@
         <p:spPr>
           <a:xfrm>
             <a:off x="640080" y="457200"/>
-            <a:ext cx="10972800" cy="274320"/>
+            <a:ext cx="10972800" cy="640080"/>
           </a:xfrm>
           <a:prstGeom prst="rect">
             <a:avLst/>
@@ -3890,46 +3070,7 @@
               <a:buNone/>
             </a:pPr>
             <a:r>
-              <a:rPr lang="en-US" sz="1200" b="1" spc="200" kern="0" dirty="0">
-                <a:solidFill>
-                  <a:srgbClr val="1C5CAB"/>
-                </a:solidFill>
-                <a:latin typeface="Microsoft YaHei" pitchFamily="34" charset="0"/>
-                <a:ea typeface="Microsoft YaHei" pitchFamily="34" charset="-122"/>
-                <a:cs typeface="Microsoft YaHei" pitchFamily="34" charset="-120"/>
-              </a:rPr>
-              <a:t>上皮信号的真伪</a:t>
-            </a:r>
-            <a:endParaRPr lang="en-US" sz="1200" dirty="0"/>
-          </a:p>
-        </p:txBody>
-      </p:sp>
-      <p:sp>
-        <p:nvSpPr>
-          <p:cNvPr id="3" name="Text 1"/>
-          <p:cNvSpPr txBox="1"/>
-          <p:nvPr/>
-        </p:nvSpPr>
-        <p:spPr>
-          <a:xfrm>
-            <a:off x="640080" y="713232"/>
-            <a:ext cx="10972800" cy="640080"/>
-          </a:xfrm>
-          <a:prstGeom prst="rect">
-            <a:avLst/>
-          </a:prstGeom>
-          <a:noFill/>
-          <a:ln/>
-        </p:spPr>
-        <p:txBody>
-          <a:bodyPr wrap="square" rtlCol="0" anchor="ctr"/>
-          <a:lstStyle/>
-          <a:p>
-            <a:pPr indent="0" marL="0">
-              <a:buNone/>
-            </a:pPr>
-            <a:r>
-              <a:rPr lang="en-US" sz="2600" b="1" dirty="0">
+              <a:rPr lang="en-US" sz="2500" b="1" dirty="0">
                 <a:solidFill>
                   <a:srgbClr val="1A1A1A"/>
                 </a:solidFill>
@@ -3937,15 +3078,15 @@
                 <a:ea typeface="Microsoft YaHei" pitchFamily="34" charset="-122"/>
                 <a:cs typeface="Microsoft YaHei" pitchFamily="34" charset="-120"/>
               </a:rPr>
-              <a:t>环境 RNA 校正后，上皮 IL18 依然存在</a:t>
-            </a:r>
-            <a:endParaRPr lang="en-US" sz="2600" dirty="0"/>
+              <a:t>上皮信号经环境 RNA 校正后依然存在</a:t>
+            </a:r>
+            <a:endParaRPr lang="en-US" sz="2500" dirty="0"/>
           </a:p>
         </p:txBody>
       </p:sp>
       <p:pic>
         <p:nvPicPr>
-          <p:cNvPr id="4" name="Image 0" descr="/home/user/aaa/il18_lung/figures/human/H03_TabulaSapiens_lung.png">    </p:cNvPr>
+          <p:cNvPr id="3" name="Image 0" descr="/home/user/aaa/il18_lung/figures/human/H03_TabulaSapiens_lung.png">    </p:cNvPr>
           <p:cNvPicPr>
             <a:picLocks noChangeAspect="1"/>
           </p:cNvPicPr>
@@ -3959,8 +3100,8 @@
         </p:blipFill>
         <p:spPr>
           <a:xfrm>
-            <a:off x="2448884" y="1600200"/>
-            <a:ext cx="7291184" cy="2606040"/>
+            <a:off x="2576799" y="1417320"/>
+            <a:ext cx="7035353" cy="2514600"/>
           </a:xfrm>
           <a:prstGeom prst="rect">
             <a:avLst/>
@@ -3969,34 +3110,14 @@
       </p:pic>
       <p:sp>
         <p:nvSpPr>
-          <p:cNvPr id="5" name="Shape 2"/>
-          <p:cNvSpPr/>
-          <p:nvPr/>
-        </p:nvSpPr>
-        <p:spPr>
-          <a:xfrm>
-            <a:off x="777240" y="4654296"/>
-            <a:ext cx="82296" cy="82296"/>
-          </a:xfrm>
-          <a:prstGeom prst="ellipse">
-            <a:avLst/>
-          </a:prstGeom>
-          <a:solidFill>
-            <a:srgbClr val="1C5CAB"/>
-          </a:solidFill>
-          <a:ln/>
-        </p:spPr>
-      </p:sp>
-      <p:sp>
-        <p:nvSpPr>
-          <p:cNvPr id="6" name="Text 3"/>
+          <p:cNvPr id="4" name="Text 1"/>
           <p:cNvSpPr txBox="1"/>
           <p:nvPr/>
         </p:nvSpPr>
         <p:spPr>
           <a:xfrm>
-            <a:off x="1005840" y="4572000"/>
-            <a:ext cx="10332720" cy="411480"/>
+            <a:off x="822960" y="4389120"/>
+            <a:ext cx="10515600" cy="411480"/>
           </a:xfrm>
           <a:prstGeom prst="rect">
             <a:avLst/>
@@ -4028,34 +3149,14 @@
       </p:sp>
       <p:sp>
         <p:nvSpPr>
-          <p:cNvPr id="7" name="Shape 4"/>
-          <p:cNvSpPr/>
-          <p:nvPr/>
-        </p:nvSpPr>
-        <p:spPr>
-          <a:xfrm>
-            <a:off x="777240" y="5129784"/>
-            <a:ext cx="82296" cy="82296"/>
-          </a:xfrm>
-          <a:prstGeom prst="ellipse">
-            <a:avLst/>
-          </a:prstGeom>
-          <a:solidFill>
-            <a:srgbClr val="1C5CAB"/>
-          </a:solidFill>
-          <a:ln/>
-        </p:spPr>
-      </p:sp>
-      <p:sp>
-        <p:nvSpPr>
-          <p:cNvPr id="8" name="Text 5"/>
+          <p:cNvPr id="5" name="Text 2"/>
           <p:cNvSpPr txBox="1"/>
           <p:nvPr/>
         </p:nvSpPr>
         <p:spPr>
           <a:xfrm>
-            <a:off x="1005840" y="5047488"/>
-            <a:ext cx="10332720" cy="411480"/>
+            <a:off x="822960" y="4864608"/>
+            <a:ext cx="10515600" cy="411480"/>
           </a:xfrm>
           <a:prstGeom prst="rect">
             <a:avLst/>
@@ -4087,34 +3188,14 @@
       </p:sp>
       <p:sp>
         <p:nvSpPr>
-          <p:cNvPr id="9" name="Shape 6"/>
-          <p:cNvSpPr/>
-          <p:nvPr/>
-        </p:nvSpPr>
-        <p:spPr>
-          <a:xfrm>
-            <a:off x="777240" y="5605272"/>
-            <a:ext cx="82296" cy="82296"/>
-          </a:xfrm>
-          <a:prstGeom prst="ellipse">
-            <a:avLst/>
-          </a:prstGeom>
-          <a:solidFill>
-            <a:srgbClr val="1C5CAB"/>
-          </a:solidFill>
-          <a:ln/>
-        </p:spPr>
-      </p:sp>
-      <p:sp>
-        <p:nvSpPr>
-          <p:cNvPr id="10" name="Text 7"/>
+          <p:cNvPr id="6" name="Text 3"/>
           <p:cNvSpPr txBox="1"/>
           <p:nvPr/>
         </p:nvSpPr>
         <p:spPr>
           <a:xfrm>
-            <a:off x="1005840" y="5522976"/>
-            <a:ext cx="10332720" cy="411480"/>
+            <a:off x="822960" y="5340096"/>
+            <a:ext cx="10515600" cy="411480"/>
           </a:xfrm>
           <a:prstGeom prst="rect">
             <a:avLst/>
@@ -4138,7 +3219,7 @@
                 <a:ea typeface="Microsoft YaHei" pitchFamily="34" charset="-122"/>
                 <a:cs typeface="Microsoft YaHei" pitchFamily="34" charset="-120"/>
               </a:rPr>
-              <a:t>结论：人肺泡及气道上皮的 IL18 并非肺泡巨噬细胞游离 RNA 污染所致</a:t>
+              <a:t>故人肺泡及气道上皮的 IL18 并非肺泡巨噬细胞游离 RNA 污染所致</a:t>
             </a:r>
             <a:endParaRPr lang="en-US" sz="1350" dirty="0"/>
           </a:p>
@@ -4178,7 +3259,7 @@
         <p:spPr>
           <a:xfrm>
             <a:off x="640080" y="457200"/>
-            <a:ext cx="10972800" cy="274320"/>
+            <a:ext cx="10972800" cy="640080"/>
           </a:xfrm>
           <a:prstGeom prst="rect">
             <a:avLst/>
@@ -4194,46 +3275,7 @@
               <a:buNone/>
             </a:pPr>
             <a:r>
-              <a:rPr lang="en-US" sz="1200" b="1" spc="200" kern="0" dirty="0">
-                <a:solidFill>
-                  <a:srgbClr val="1C5CAB"/>
-                </a:solidFill>
-                <a:latin typeface="Microsoft YaHei" pitchFamily="34" charset="0"/>
-                <a:ea typeface="Microsoft YaHei" pitchFamily="34" charset="-122"/>
-                <a:cs typeface="Microsoft YaHei" pitchFamily="34" charset="-120"/>
-              </a:rPr>
-              <a:t>甲型流感 · 小鼠</a:t>
-            </a:r>
-            <a:endParaRPr lang="en-US" sz="1200" dirty="0"/>
-          </a:p>
-        </p:txBody>
-      </p:sp>
-      <p:sp>
-        <p:nvSpPr>
-          <p:cNvPr id="3" name="Text 1"/>
-          <p:cNvSpPr txBox="1"/>
-          <p:nvPr/>
-        </p:nvSpPr>
-        <p:spPr>
-          <a:xfrm>
-            <a:off x="640080" y="713232"/>
-            <a:ext cx="10972800" cy="640080"/>
-          </a:xfrm>
-          <a:prstGeom prst="rect">
-            <a:avLst/>
-          </a:prstGeom>
-          <a:noFill/>
-          <a:ln/>
-        </p:spPr>
-        <p:txBody>
-          <a:bodyPr wrap="square" rtlCol="0" anchor="ctr"/>
-          <a:lstStyle/>
-          <a:p>
-            <a:pPr indent="0" marL="0">
-              <a:buNone/>
-            </a:pPr>
-            <a:r>
-              <a:rPr lang="en-US" sz="2600" b="1" dirty="0">
+              <a:rPr lang="en-US" sz="2500" b="1" dirty="0">
                 <a:solidFill>
                   <a:srgbClr val="1A1A1A"/>
                 </a:solidFill>
@@ -4241,181 +3283,15 @@
                 <a:ea typeface="Microsoft YaHei" pitchFamily="34" charset="-122"/>
                 <a:cs typeface="Microsoft YaHei" pitchFamily="34" charset="-120"/>
               </a:rPr>
-              <a:t>感染全程肺泡巨噬细胞稳居第一（PR8，第 0–366 天）</a:t>
-            </a:r>
-            <a:endParaRPr lang="en-US" sz="2600" dirty="0"/>
-          </a:p>
-        </p:txBody>
-      </p:sp>
-      <p:pic>
-        <p:nvPicPr>
-          <p:cNvPr id="4" name="Image 0" descr="/home/user/aaa/il18_lung/figures/mouse/M03_PostFlu_timeseries.png">    </p:cNvPr>
-          <p:cNvPicPr>
-            <a:picLocks noChangeAspect="1"/>
-          </p:cNvPicPr>
-          <p:nvPr/>
-        </p:nvPicPr>
-        <p:blipFill>
-          <a:blip r:embed="rId1"/>
-          <a:stretch>
-            <a:fillRect/>
-          </a:stretch>
-        </p:blipFill>
-        <p:spPr>
-          <a:xfrm>
-            <a:off x="2285436" y="1463040"/>
-            <a:ext cx="7618081" cy="4572000"/>
-          </a:xfrm>
-          <a:prstGeom prst="rect">
-            <a:avLst/>
-          </a:prstGeom>
-        </p:spPr>
-      </p:pic>
-      <p:sp>
-        <p:nvSpPr>
-          <p:cNvPr id="5" name="Text 2"/>
-          <p:cNvSpPr txBox="1"/>
-          <p:nvPr/>
-        </p:nvSpPr>
-        <p:spPr>
-          <a:xfrm>
-            <a:off x="640080" y="6291072"/>
-            <a:ext cx="10972800" cy="365760"/>
-          </a:xfrm>
-          <a:prstGeom prst="rect">
-            <a:avLst/>
-          </a:prstGeom>
-          <a:noFill/>
-          <a:ln/>
-        </p:spPr>
-        <p:txBody>
-          <a:bodyPr wrap="square" rtlCol="0" anchor="ctr"/>
-          <a:lstStyle/>
-          <a:p>
-            <a:pPr indent="0" marL="0">
-              <a:buNone/>
-            </a:pPr>
-            <a:r>
-              <a:rPr lang="en-US" sz="1050" i="1" dirty="0">
-                <a:solidFill>
-                  <a:srgbClr val="6B6B6B"/>
-                </a:solidFill>
-                <a:latin typeface="Microsoft YaHei" pitchFamily="34" charset="0"/>
-                <a:ea typeface="Microsoft YaHei" pitchFamily="34" charset="-122"/>
-                <a:cs typeface="Microsoft YaHei" pitchFamily="34" charset="-120"/>
-              </a:rPr>
-              <a:t>感染未产生新的高表达细胞类型。第 6 天肺泡巨噬细胞被耗竭至每样本 &lt;20 个细胞（按规则置 NA），该时点中性粒细胞短暂升为最高可计类别。</a:t>
-            </a:r>
-            <a:endParaRPr lang="en-US" sz="1050" dirty="0"/>
-          </a:p>
-        </p:txBody>
-      </p:sp>
-    </p:spTree>
-  </p:cSld>
-  <p:clrMapOvr>
-    <a:masterClrMapping/>
-  </p:clrMapOvr>
-</p:sld>
-</file>
-
-<file path=ppt/slides/slide8.xml><?xml version="1.0" encoding="utf-8"?>
-<p:sld xmlns:a="http://schemas.openxmlformats.org/drawingml/2006/main" xmlns:r="http://schemas.openxmlformats.org/officeDocument/2006/relationships" xmlns:p="http://schemas.openxmlformats.org/presentationml/2006/main">
-  <p:cSld name="Slide 8">
-    <p:spTree>
-      <p:nvGrpSpPr>
-        <p:cNvPr id="1" name=""/>
-        <p:cNvGrpSpPr/>
-        <p:nvPr/>
-      </p:nvGrpSpPr>
-      <p:grpSpPr>
-        <a:xfrm>
-          <a:off x="0" y="0"/>
-          <a:ext cx="0" cy="0"/>
-          <a:chOff x="0" y="0"/>
-          <a:chExt cx="0" cy="0"/>
-        </a:xfrm>
-      </p:grpSpPr>
-      <p:sp>
-        <p:nvSpPr>
-          <p:cNvPr id="2" name="Text 0"/>
-          <p:cNvSpPr txBox="1"/>
-          <p:nvPr/>
-        </p:nvSpPr>
-        <p:spPr>
-          <a:xfrm>
-            <a:off x="640080" y="457200"/>
-            <a:ext cx="10972800" cy="274320"/>
-          </a:xfrm>
-          <a:prstGeom prst="rect">
-            <a:avLst/>
-          </a:prstGeom>
-          <a:noFill/>
-          <a:ln/>
-        </p:spPr>
-        <p:txBody>
-          <a:bodyPr wrap="square" rtlCol="0" anchor="ctr"/>
-          <a:lstStyle/>
-          <a:p>
-            <a:pPr indent="0" marL="0">
-              <a:buNone/>
-            </a:pPr>
-            <a:r>
-              <a:rPr lang="en-US" sz="1200" b="1" spc="200" kern="0" dirty="0">
-                <a:solidFill>
-                  <a:srgbClr val="1C5CAB"/>
-                </a:solidFill>
-                <a:latin typeface="Microsoft YaHei" pitchFamily="34" charset="0"/>
-                <a:ea typeface="Microsoft YaHei" pitchFamily="34" charset="-122"/>
-                <a:cs typeface="Microsoft YaHei" pitchFamily="34" charset="-120"/>
-              </a:rPr>
-              <a:t>零值判读</a:t>
-            </a:r>
-            <a:endParaRPr lang="en-US" sz="1200" dirty="0"/>
-          </a:p>
-        </p:txBody>
-      </p:sp>
-      <p:sp>
-        <p:nvSpPr>
-          <p:cNvPr id="3" name="Text 1"/>
-          <p:cNvSpPr txBox="1"/>
-          <p:nvPr/>
-        </p:nvSpPr>
-        <p:spPr>
-          <a:xfrm>
-            <a:off x="640080" y="713232"/>
-            <a:ext cx="10972800" cy="640080"/>
-          </a:xfrm>
-          <a:prstGeom prst="rect">
-            <a:avLst/>
-          </a:prstGeom>
-          <a:noFill/>
-          <a:ln/>
-        </p:spPr>
-        <p:txBody>
-          <a:bodyPr wrap="square" rtlCol="0" anchor="ctr"/>
-          <a:lstStyle/>
-          <a:p>
-            <a:pPr indent="0" marL="0">
-              <a:buNone/>
-            </a:pPr>
-            <a:r>
-              <a:rPr lang="en-US" sz="2600" b="1" dirty="0">
-                <a:solidFill>
-                  <a:srgbClr val="1A1A1A"/>
-                </a:solidFill>
-                <a:latin typeface="Microsoft YaHei" pitchFamily="34" charset="0"/>
-                <a:ea typeface="Microsoft YaHei" pitchFamily="34" charset="-122"/>
-                <a:cs typeface="Microsoft YaHei" pitchFamily="34" charset="-120"/>
-              </a:rPr>
-              <a:t>真零 vs 技术零（对照分选 bulk）</a:t>
-            </a:r>
-            <a:endParaRPr lang="en-US" sz="2600" dirty="0"/>
+              <a:t>零值判读：真零 vs 技术零（对照分选 bulk）</a:t>
+            </a:r>
+            <a:endParaRPr lang="en-US" sz="2500" dirty="0"/>
           </a:p>
         </p:txBody>
       </p:sp>
       <p:graphicFrame>
         <p:nvGraphicFramePr>
-          <p:cNvPr id="9" name="Table 0"/>
+          <p:cNvPr id="8" name="Table 0"/>
           <p:cNvGraphicFramePr>
             <a:graphicFrameLocks noGrp="1"/>
           </p:cNvGraphicFramePr>
@@ -4428,8 +3304,8 @@
           </p:nvPr>
         </p:nvGraphicFramePr>
         <p:xfrm>
-          <a:off x="640080" y="1920240"/>
-          <a:ext cx="10972800" cy="914400"/>
+          <a:off x="640080" y="1463040"/>
+          <a:ext cx="10881360" cy="914400"/>
         </p:xfrm>
         <a:graphic>
           <a:graphicData uri="http://schemas.openxmlformats.org/drawingml/2006/table">
@@ -4438,10 +3314,10 @@
               <a:tblGrid>
                 <a:gridCol w="2286000"/>
                 <a:gridCol w="2011680"/>
-                <a:gridCol w="4480560"/>
+                <a:gridCol w="4389120"/>
                 <a:gridCol w="2194560"/>
               </a:tblGrid>
-              <a:tr h="566928">
+              <a:tr h="548640">
                 <a:tc>
                   <a:txBody>
                     <a:bodyPr/>
@@ -4453,7 +3329,7 @@
                       <a:r>
                         <a:rPr lang="en-US" sz="1250" b="1" dirty="0">
                           <a:solidFill>
-                            <a:srgbClr val="FFFFFF"/>
+                            <a:srgbClr val="1A1A1A"/>
                           </a:solidFill>
                           <a:latin typeface="Microsoft YaHei" pitchFamily="34" charset="0"/>
                           <a:ea typeface="Microsoft YaHei" pitchFamily="34" charset="-122"/>
@@ -4471,7 +3347,7 @@
                   <a:tcPr marL="76200" marR="76200" marT="50800" marB="50800" anchor="ctr">
                     <a:lnL w="12700" cap="flat" cmpd="sng" algn="ctr">
                       <a:solidFill>
-                        <a:srgbClr val="E6E8EC"/>
+                        <a:srgbClr val="D8DBE0"/>
                       </a:solidFill>
                       <a:prstDash val="solid"/>
                       <a:round/>
@@ -4480,7 +3356,7 @@
                     </a:lnL>
                     <a:lnR w="12700" cap="flat" cmpd="sng" algn="ctr">
                       <a:solidFill>
-                        <a:srgbClr val="E6E8EC"/>
+                        <a:srgbClr val="D8DBE0"/>
                       </a:solidFill>
                       <a:prstDash val="solid"/>
                       <a:round/>
@@ -4489,7 +3365,7 @@
                     </a:lnR>
                     <a:lnT w="12700" cap="flat" cmpd="sng" algn="ctr">
                       <a:solidFill>
-                        <a:srgbClr val="E6E8EC"/>
+                        <a:srgbClr val="D8DBE0"/>
                       </a:solidFill>
                       <a:prstDash val="solid"/>
                       <a:round/>
@@ -4498,7 +3374,7 @@
                     </a:lnT>
                     <a:lnB w="12700" cap="flat" cmpd="sng" algn="ctr">
                       <a:solidFill>
-                        <a:srgbClr val="E6E8EC"/>
+                        <a:srgbClr val="D8DBE0"/>
                       </a:solidFill>
                       <a:prstDash val="solid"/>
                       <a:round/>
@@ -4506,7 +3382,7 @@
                       <a:tailEnd type="none" w="med" len="med"/>
                     </a:lnB>
                     <a:solidFill>
-                      <a:srgbClr val="16233E"/>
+                      <a:srgbClr val="EEF1F5"/>
                     </a:solidFill>
                   </a:tcPr>
                 </a:tc>
@@ -4521,7 +3397,7 @@
                       <a:r>
                         <a:rPr lang="en-US" sz="1250" b="1" dirty="0">
                           <a:solidFill>
-                            <a:srgbClr val="FFFFFF"/>
+                            <a:srgbClr val="1A1A1A"/>
                           </a:solidFill>
                           <a:latin typeface="Microsoft YaHei" pitchFamily="34" charset="0"/>
                           <a:ea typeface="Microsoft YaHei" pitchFamily="34" charset="-122"/>
@@ -4539,7 +3415,7 @@
                   <a:tcPr marL="76200" marR="76200" marT="50800" marB="50800" anchor="ctr">
                     <a:lnL w="12700" cap="flat" cmpd="sng" algn="ctr">
                       <a:solidFill>
-                        <a:srgbClr val="E6E8EC"/>
+                        <a:srgbClr val="D8DBE0"/>
                       </a:solidFill>
                       <a:prstDash val="solid"/>
                       <a:round/>
@@ -4548,7 +3424,7 @@
                     </a:lnL>
                     <a:lnR w="12700" cap="flat" cmpd="sng" algn="ctr">
                       <a:solidFill>
-                        <a:srgbClr val="E6E8EC"/>
+                        <a:srgbClr val="D8DBE0"/>
                       </a:solidFill>
                       <a:prstDash val="solid"/>
                       <a:round/>
@@ -4557,7 +3433,7 @@
                     </a:lnR>
                     <a:lnT w="12700" cap="flat" cmpd="sng" algn="ctr">
                       <a:solidFill>
-                        <a:srgbClr val="E6E8EC"/>
+                        <a:srgbClr val="D8DBE0"/>
                       </a:solidFill>
                       <a:prstDash val="solid"/>
                       <a:round/>
@@ -4566,7 +3442,7 @@
                     </a:lnT>
                     <a:lnB w="12700" cap="flat" cmpd="sng" algn="ctr">
                       <a:solidFill>
-                        <a:srgbClr val="E6E8EC"/>
+                        <a:srgbClr val="D8DBE0"/>
                       </a:solidFill>
                       <a:prstDash val="solid"/>
                       <a:round/>
@@ -4574,7 +3450,7 @@
                       <a:tailEnd type="none" w="med" len="med"/>
                     </a:lnB>
                     <a:solidFill>
-                      <a:srgbClr val="16233E"/>
+                      <a:srgbClr val="EEF1F5"/>
                     </a:solidFill>
                   </a:tcPr>
                 </a:tc>
@@ -4589,7 +3465,7 @@
                       <a:r>
                         <a:rPr lang="en-US" sz="1250" b="1" dirty="0">
                           <a:solidFill>
-                            <a:srgbClr val="FFFFFF"/>
+                            <a:srgbClr val="1A1A1A"/>
                           </a:solidFill>
                           <a:latin typeface="Microsoft YaHei" pitchFamily="34" charset="0"/>
                           <a:ea typeface="Microsoft YaHei" pitchFamily="34" charset="-122"/>
@@ -4607,7 +3483,7 @@
                   <a:tcPr marL="76200" marR="76200" marT="50800" marB="50800" anchor="ctr">
                     <a:lnL w="12700" cap="flat" cmpd="sng" algn="ctr">
                       <a:solidFill>
-                        <a:srgbClr val="E6E8EC"/>
+                        <a:srgbClr val="D8DBE0"/>
                       </a:solidFill>
                       <a:prstDash val="solid"/>
                       <a:round/>
@@ -4616,7 +3492,7 @@
                     </a:lnL>
                     <a:lnR w="12700" cap="flat" cmpd="sng" algn="ctr">
                       <a:solidFill>
-                        <a:srgbClr val="E6E8EC"/>
+                        <a:srgbClr val="D8DBE0"/>
                       </a:solidFill>
                       <a:prstDash val="solid"/>
                       <a:round/>
@@ -4625,7 +3501,7 @@
                     </a:lnR>
                     <a:lnT w="12700" cap="flat" cmpd="sng" algn="ctr">
                       <a:solidFill>
-                        <a:srgbClr val="E6E8EC"/>
+                        <a:srgbClr val="D8DBE0"/>
                       </a:solidFill>
                       <a:prstDash val="solid"/>
                       <a:round/>
@@ -4634,7 +3510,7 @@
                     </a:lnT>
                     <a:lnB w="12700" cap="flat" cmpd="sng" algn="ctr">
                       <a:solidFill>
-                        <a:srgbClr val="E6E8EC"/>
+                        <a:srgbClr val="D8DBE0"/>
                       </a:solidFill>
                       <a:prstDash val="solid"/>
                       <a:round/>
@@ -4642,7 +3518,7 @@
                       <a:tailEnd type="none" w="med" len="med"/>
                     </a:lnB>
                     <a:solidFill>
-                      <a:srgbClr val="16233E"/>
+                      <a:srgbClr val="EEF1F5"/>
                     </a:solidFill>
                   </a:tcPr>
                 </a:tc>
@@ -4657,7 +3533,7 @@
                       <a:r>
                         <a:rPr lang="en-US" sz="1250" b="1" dirty="0">
                           <a:solidFill>
-                            <a:srgbClr val="FFFFFF"/>
+                            <a:srgbClr val="1A1A1A"/>
                           </a:solidFill>
                           <a:latin typeface="Microsoft YaHei" pitchFamily="34" charset="0"/>
                           <a:ea typeface="Microsoft YaHei" pitchFamily="34" charset="-122"/>
@@ -4675,7 +3551,7 @@
                   <a:tcPr marL="76200" marR="76200" marT="50800" marB="50800" anchor="ctr">
                     <a:lnL w="12700" cap="flat" cmpd="sng" algn="ctr">
                       <a:solidFill>
-                        <a:srgbClr val="E6E8EC"/>
+                        <a:srgbClr val="D8DBE0"/>
                       </a:solidFill>
                       <a:prstDash val="solid"/>
                       <a:round/>
@@ -4684,7 +3560,7 @@
                     </a:lnL>
                     <a:lnR w="12700" cap="flat" cmpd="sng" algn="ctr">
                       <a:solidFill>
-                        <a:srgbClr val="E6E8EC"/>
+                        <a:srgbClr val="D8DBE0"/>
                       </a:solidFill>
                       <a:prstDash val="solid"/>
                       <a:round/>
@@ -4693,7 +3569,7 @@
                     </a:lnR>
                     <a:lnT w="12700" cap="flat" cmpd="sng" algn="ctr">
                       <a:solidFill>
-                        <a:srgbClr val="E6E8EC"/>
+                        <a:srgbClr val="D8DBE0"/>
                       </a:solidFill>
                       <a:prstDash val="solid"/>
                       <a:round/>
@@ -4702,7 +3578,7 @@
                     </a:lnT>
                     <a:lnB w="12700" cap="flat" cmpd="sng" algn="ctr">
                       <a:solidFill>
-                        <a:srgbClr val="E6E8EC"/>
+                        <a:srgbClr val="D8DBE0"/>
                       </a:solidFill>
                       <a:prstDash val="solid"/>
                       <a:round/>
@@ -4710,12 +3586,12 @@
                       <a:tailEnd type="none" w="med" len="med"/>
                     </a:lnB>
                     <a:solidFill>
-                      <a:srgbClr val="16233E"/>
+                      <a:srgbClr val="EEF1F5"/>
                     </a:solidFill>
                   </a:tcPr>
                 </a:tc>
               </a:tr>
-              <a:tr h="566928">
+              <a:tr h="548640">
                 <a:tc>
                   <a:txBody>
                     <a:bodyPr/>
@@ -4745,7 +3621,7 @@
                   <a:tcPr marL="76200" marR="76200" marT="50800" marB="50800" anchor="ctr">
                     <a:lnL w="12700" cap="flat" cmpd="sng" algn="ctr">
                       <a:solidFill>
-                        <a:srgbClr val="E6E8EC"/>
+                        <a:srgbClr val="D8DBE0"/>
                       </a:solidFill>
                       <a:prstDash val="solid"/>
                       <a:round/>
@@ -4754,7 +3630,7 @@
                     </a:lnL>
                     <a:lnR w="12700" cap="flat" cmpd="sng" algn="ctr">
                       <a:solidFill>
-                        <a:srgbClr val="E6E8EC"/>
+                        <a:srgbClr val="D8DBE0"/>
                       </a:solidFill>
                       <a:prstDash val="solid"/>
                       <a:round/>
@@ -4763,7 +3639,7 @@
                     </a:lnR>
                     <a:lnT w="12700" cap="flat" cmpd="sng" algn="ctr">
                       <a:solidFill>
-                        <a:srgbClr val="E6E8EC"/>
+                        <a:srgbClr val="D8DBE0"/>
                       </a:solidFill>
                       <a:prstDash val="solid"/>
                       <a:round/>
@@ -4772,7 +3648,7 @@
                     </a:lnT>
                     <a:lnB w="12700" cap="flat" cmpd="sng" algn="ctr">
                       <a:solidFill>
-                        <a:srgbClr val="E6E8EC"/>
+                        <a:srgbClr val="D8DBE0"/>
                       </a:solidFill>
                       <a:prstDash val="solid"/>
                       <a:round/>
@@ -4813,7 +3689,7 @@
                   <a:tcPr marL="76200" marR="76200" marT="50800" marB="50800" anchor="ctr">
                     <a:lnL w="12700" cap="flat" cmpd="sng" algn="ctr">
                       <a:solidFill>
-                        <a:srgbClr val="E6E8EC"/>
+                        <a:srgbClr val="D8DBE0"/>
                       </a:solidFill>
                       <a:prstDash val="solid"/>
                       <a:round/>
@@ -4822,7 +3698,7 @@
                     </a:lnL>
                     <a:lnR w="12700" cap="flat" cmpd="sng" algn="ctr">
                       <a:solidFill>
-                        <a:srgbClr val="E6E8EC"/>
+                        <a:srgbClr val="D8DBE0"/>
                       </a:solidFill>
                       <a:prstDash val="solid"/>
                       <a:round/>
@@ -4831,7 +3707,7 @@
                     </a:lnR>
                     <a:lnT w="12700" cap="flat" cmpd="sng" algn="ctr">
                       <a:solidFill>
-                        <a:srgbClr val="E6E8EC"/>
+                        <a:srgbClr val="D8DBE0"/>
                       </a:solidFill>
                       <a:prstDash val="solid"/>
                       <a:round/>
@@ -4840,7 +3716,7 @@
                     </a:lnT>
                     <a:lnB w="12700" cap="flat" cmpd="sng" algn="ctr">
                       <a:solidFill>
-                        <a:srgbClr val="E6E8EC"/>
+                        <a:srgbClr val="D8DBE0"/>
                       </a:solidFill>
                       <a:prstDash val="solid"/>
                       <a:round/>
@@ -4881,7 +3757,7 @@
                   <a:tcPr marL="76200" marR="76200" marT="50800" marB="50800" anchor="ctr">
                     <a:lnL w="12700" cap="flat" cmpd="sng" algn="ctr">
                       <a:solidFill>
-                        <a:srgbClr val="E6E8EC"/>
+                        <a:srgbClr val="D8DBE0"/>
                       </a:solidFill>
                       <a:prstDash val="solid"/>
                       <a:round/>
@@ -4890,7 +3766,7 @@
                     </a:lnL>
                     <a:lnR w="12700" cap="flat" cmpd="sng" algn="ctr">
                       <a:solidFill>
-                        <a:srgbClr val="E6E8EC"/>
+                        <a:srgbClr val="D8DBE0"/>
                       </a:solidFill>
                       <a:prstDash val="solid"/>
                       <a:round/>
@@ -4899,7 +3775,7 @@
                     </a:lnR>
                     <a:lnT w="12700" cap="flat" cmpd="sng" algn="ctr">
                       <a:solidFill>
-                        <a:srgbClr val="E6E8EC"/>
+                        <a:srgbClr val="D8DBE0"/>
                       </a:solidFill>
                       <a:prstDash val="solid"/>
                       <a:round/>
@@ -4908,7 +3784,7 @@
                     </a:lnT>
                     <a:lnB w="12700" cap="flat" cmpd="sng" algn="ctr">
                       <a:solidFill>
-                        <a:srgbClr val="E6E8EC"/>
+                        <a:srgbClr val="D8DBE0"/>
                       </a:solidFill>
                       <a:prstDash val="solid"/>
                       <a:round/>
@@ -4949,7 +3825,7 @@
                   <a:tcPr marL="76200" marR="76200" marT="50800" marB="50800" anchor="ctr">
                     <a:lnL w="12700" cap="flat" cmpd="sng" algn="ctr">
                       <a:solidFill>
-                        <a:srgbClr val="E6E8EC"/>
+                        <a:srgbClr val="D8DBE0"/>
                       </a:solidFill>
                       <a:prstDash val="solid"/>
                       <a:round/>
@@ -4958,7 +3834,7 @@
                     </a:lnL>
                     <a:lnR w="12700" cap="flat" cmpd="sng" algn="ctr">
                       <a:solidFill>
-                        <a:srgbClr val="E6E8EC"/>
+                        <a:srgbClr val="D8DBE0"/>
                       </a:solidFill>
                       <a:prstDash val="solid"/>
                       <a:round/>
@@ -4967,7 +3843,7 @@
                     </a:lnR>
                     <a:lnT w="12700" cap="flat" cmpd="sng" algn="ctr">
                       <a:solidFill>
-                        <a:srgbClr val="E6E8EC"/>
+                        <a:srgbClr val="D8DBE0"/>
                       </a:solidFill>
                       <a:prstDash val="solid"/>
                       <a:round/>
@@ -4976,7 +3852,7 @@
                     </a:lnT>
                     <a:lnB w="12700" cap="flat" cmpd="sng" algn="ctr">
                       <a:solidFill>
-                        <a:srgbClr val="E6E8EC"/>
+                        <a:srgbClr val="D8DBE0"/>
                       </a:solidFill>
                       <a:prstDash val="solid"/>
                       <a:round/>
@@ -4989,7 +3865,7 @@
                   </a:tcPr>
                 </a:tc>
               </a:tr>
-              <a:tr h="566928">
+              <a:tr h="548640">
                 <a:tc>
                   <a:txBody>
                     <a:bodyPr/>
@@ -5019,7 +3895,7 @@
                   <a:tcPr marL="76200" marR="76200" marT="50800" marB="50800" anchor="ctr">
                     <a:lnL w="12700" cap="flat" cmpd="sng" algn="ctr">
                       <a:solidFill>
-                        <a:srgbClr val="E6E8EC"/>
+                        <a:srgbClr val="D8DBE0"/>
                       </a:solidFill>
                       <a:prstDash val="solid"/>
                       <a:round/>
@@ -5028,7 +3904,7 @@
                     </a:lnL>
                     <a:lnR w="12700" cap="flat" cmpd="sng" algn="ctr">
                       <a:solidFill>
-                        <a:srgbClr val="E6E8EC"/>
+                        <a:srgbClr val="D8DBE0"/>
                       </a:solidFill>
                       <a:prstDash val="solid"/>
                       <a:round/>
@@ -5037,7 +3913,7 @@
                     </a:lnR>
                     <a:lnT w="12700" cap="flat" cmpd="sng" algn="ctr">
                       <a:solidFill>
-                        <a:srgbClr val="E6E8EC"/>
+                        <a:srgbClr val="D8DBE0"/>
                       </a:solidFill>
                       <a:prstDash val="solid"/>
                       <a:round/>
@@ -5046,7 +3922,7 @@
                     </a:lnT>
                     <a:lnB w="12700" cap="flat" cmpd="sng" algn="ctr">
                       <a:solidFill>
-                        <a:srgbClr val="E6E8EC"/>
+                        <a:srgbClr val="D8DBE0"/>
                       </a:solidFill>
                       <a:prstDash val="solid"/>
                       <a:round/>
@@ -5054,7 +3930,7 @@
                       <a:tailEnd type="none" w="med" len="med"/>
                     </a:lnB>
                     <a:solidFill>
-                      <a:srgbClr val="F5F7FA"/>
+                      <a:srgbClr val="FFFFFF"/>
                     </a:solidFill>
                   </a:tcPr>
                 </a:tc>
@@ -5087,7 +3963,7 @@
                   <a:tcPr marL="76200" marR="76200" marT="50800" marB="50800" anchor="ctr">
                     <a:lnL w="12700" cap="flat" cmpd="sng" algn="ctr">
                       <a:solidFill>
-                        <a:srgbClr val="E6E8EC"/>
+                        <a:srgbClr val="D8DBE0"/>
                       </a:solidFill>
                       <a:prstDash val="solid"/>
                       <a:round/>
@@ -5096,7 +3972,7 @@
                     </a:lnL>
                     <a:lnR w="12700" cap="flat" cmpd="sng" algn="ctr">
                       <a:solidFill>
-                        <a:srgbClr val="E6E8EC"/>
+                        <a:srgbClr val="D8DBE0"/>
                       </a:solidFill>
                       <a:prstDash val="solid"/>
                       <a:round/>
@@ -5105,7 +3981,7 @@
                     </a:lnR>
                     <a:lnT w="12700" cap="flat" cmpd="sng" algn="ctr">
                       <a:solidFill>
-                        <a:srgbClr val="E6E8EC"/>
+                        <a:srgbClr val="D8DBE0"/>
                       </a:solidFill>
                       <a:prstDash val="solid"/>
                       <a:round/>
@@ -5114,7 +3990,7 @@
                     </a:lnT>
                     <a:lnB w="12700" cap="flat" cmpd="sng" algn="ctr">
                       <a:solidFill>
-                        <a:srgbClr val="E6E8EC"/>
+                        <a:srgbClr val="D8DBE0"/>
                       </a:solidFill>
                       <a:prstDash val="solid"/>
                       <a:round/>
@@ -5122,7 +3998,7 @@
                       <a:tailEnd type="none" w="med" len="med"/>
                     </a:lnB>
                     <a:solidFill>
-                      <a:srgbClr val="F5F7FA"/>
+                      <a:srgbClr val="FFFFFF"/>
                     </a:solidFill>
                   </a:tcPr>
                 </a:tc>
@@ -5155,7 +4031,7 @@
                   <a:tcPr marL="76200" marR="76200" marT="50800" marB="50800" anchor="ctr">
                     <a:lnL w="12700" cap="flat" cmpd="sng" algn="ctr">
                       <a:solidFill>
-                        <a:srgbClr val="E6E8EC"/>
+                        <a:srgbClr val="D8DBE0"/>
                       </a:solidFill>
                       <a:prstDash val="solid"/>
                       <a:round/>
@@ -5164,7 +4040,7 @@
                     </a:lnL>
                     <a:lnR w="12700" cap="flat" cmpd="sng" algn="ctr">
                       <a:solidFill>
-                        <a:srgbClr val="E6E8EC"/>
+                        <a:srgbClr val="D8DBE0"/>
                       </a:solidFill>
                       <a:prstDash val="solid"/>
                       <a:round/>
@@ -5173,7 +4049,7 @@
                     </a:lnR>
                     <a:lnT w="12700" cap="flat" cmpd="sng" algn="ctr">
                       <a:solidFill>
-                        <a:srgbClr val="E6E8EC"/>
+                        <a:srgbClr val="D8DBE0"/>
                       </a:solidFill>
                       <a:prstDash val="solid"/>
                       <a:round/>
@@ -5182,7 +4058,7 @@
                     </a:lnT>
                     <a:lnB w="12700" cap="flat" cmpd="sng" algn="ctr">
                       <a:solidFill>
-                        <a:srgbClr val="E6E8EC"/>
+                        <a:srgbClr val="D8DBE0"/>
                       </a:solidFill>
                       <a:prstDash val="solid"/>
                       <a:round/>
@@ -5190,7 +4066,7 @@
                       <a:tailEnd type="none" w="med" len="med"/>
                     </a:lnB>
                     <a:solidFill>
-                      <a:srgbClr val="F5F7FA"/>
+                      <a:srgbClr val="FFFFFF"/>
                     </a:solidFill>
                   </a:tcPr>
                 </a:tc>
@@ -5223,7 +4099,7 @@
                   <a:tcPr marL="76200" marR="76200" marT="50800" marB="50800" anchor="ctr">
                     <a:lnL w="12700" cap="flat" cmpd="sng" algn="ctr">
                       <a:solidFill>
-                        <a:srgbClr val="E6E8EC"/>
+                        <a:srgbClr val="D8DBE0"/>
                       </a:solidFill>
                       <a:prstDash val="solid"/>
                       <a:round/>
@@ -5232,7 +4108,7 @@
                     </a:lnL>
                     <a:lnR w="12700" cap="flat" cmpd="sng" algn="ctr">
                       <a:solidFill>
-                        <a:srgbClr val="E6E8EC"/>
+                        <a:srgbClr val="D8DBE0"/>
                       </a:solidFill>
                       <a:prstDash val="solid"/>
                       <a:round/>
@@ -5241,7 +4117,7 @@
                     </a:lnR>
                     <a:lnT w="12700" cap="flat" cmpd="sng" algn="ctr">
                       <a:solidFill>
-                        <a:srgbClr val="E6E8EC"/>
+                        <a:srgbClr val="D8DBE0"/>
                       </a:solidFill>
                       <a:prstDash val="solid"/>
                       <a:round/>
@@ -5250,7 +4126,7 @@
                     </a:lnT>
                     <a:lnB w="12700" cap="flat" cmpd="sng" algn="ctr">
                       <a:solidFill>
-                        <a:srgbClr val="E6E8EC"/>
+                        <a:srgbClr val="D8DBE0"/>
                       </a:solidFill>
                       <a:prstDash val="solid"/>
                       <a:round/>
@@ -5258,12 +4134,12 @@
                       <a:tailEnd type="none" w="med" len="med"/>
                     </a:lnB>
                     <a:solidFill>
-                      <a:srgbClr val="F5F7FA"/>
+                      <a:srgbClr val="FFFFFF"/>
                     </a:solidFill>
                   </a:tcPr>
                 </a:tc>
               </a:tr>
-              <a:tr h="566928">
+              <a:tr h="548640">
                 <a:tc>
                   <a:txBody>
                     <a:bodyPr/>
@@ -5293,7 +4169,7 @@
                   <a:tcPr marL="76200" marR="76200" marT="50800" marB="50800" anchor="ctr">
                     <a:lnL w="12700" cap="flat" cmpd="sng" algn="ctr">
                       <a:solidFill>
-                        <a:srgbClr val="E6E8EC"/>
+                        <a:srgbClr val="D8DBE0"/>
                       </a:solidFill>
                       <a:prstDash val="solid"/>
                       <a:round/>
@@ -5302,7 +4178,7 @@
                     </a:lnL>
                     <a:lnR w="12700" cap="flat" cmpd="sng" algn="ctr">
                       <a:solidFill>
-                        <a:srgbClr val="E6E8EC"/>
+                        <a:srgbClr val="D8DBE0"/>
                       </a:solidFill>
                       <a:prstDash val="solid"/>
                       <a:round/>
@@ -5311,7 +4187,7 @@
                     </a:lnR>
                     <a:lnT w="12700" cap="flat" cmpd="sng" algn="ctr">
                       <a:solidFill>
-                        <a:srgbClr val="E6E8EC"/>
+                        <a:srgbClr val="D8DBE0"/>
                       </a:solidFill>
                       <a:prstDash val="solid"/>
                       <a:round/>
@@ -5320,7 +4196,7 @@
                     </a:lnT>
                     <a:lnB w="12700" cap="flat" cmpd="sng" algn="ctr">
                       <a:solidFill>
-                        <a:srgbClr val="E6E8EC"/>
+                        <a:srgbClr val="D8DBE0"/>
                       </a:solidFill>
                       <a:prstDash val="solid"/>
                       <a:round/>
@@ -5361,7 +4237,7 @@
                   <a:tcPr marL="76200" marR="76200" marT="50800" marB="50800" anchor="ctr">
                     <a:lnL w="12700" cap="flat" cmpd="sng" algn="ctr">
                       <a:solidFill>
-                        <a:srgbClr val="E6E8EC"/>
+                        <a:srgbClr val="D8DBE0"/>
                       </a:solidFill>
                       <a:prstDash val="solid"/>
                       <a:round/>
@@ -5370,7 +4246,7 @@
                     </a:lnL>
                     <a:lnR w="12700" cap="flat" cmpd="sng" algn="ctr">
                       <a:solidFill>
-                        <a:srgbClr val="E6E8EC"/>
+                        <a:srgbClr val="D8DBE0"/>
                       </a:solidFill>
                       <a:prstDash val="solid"/>
                       <a:round/>
@@ -5379,7 +4255,7 @@
                     </a:lnR>
                     <a:lnT w="12700" cap="flat" cmpd="sng" algn="ctr">
                       <a:solidFill>
-                        <a:srgbClr val="E6E8EC"/>
+                        <a:srgbClr val="D8DBE0"/>
                       </a:solidFill>
                       <a:prstDash val="solid"/>
                       <a:round/>
@@ -5388,7 +4264,7 @@
                     </a:lnT>
                     <a:lnB w="12700" cap="flat" cmpd="sng" algn="ctr">
                       <a:solidFill>
-                        <a:srgbClr val="E6E8EC"/>
+                        <a:srgbClr val="D8DBE0"/>
                       </a:solidFill>
                       <a:prstDash val="solid"/>
                       <a:round/>
@@ -5429,7 +4305,7 @@
                   <a:tcPr marL="76200" marR="76200" marT="50800" marB="50800" anchor="ctr">
                     <a:lnL w="12700" cap="flat" cmpd="sng" algn="ctr">
                       <a:solidFill>
-                        <a:srgbClr val="E6E8EC"/>
+                        <a:srgbClr val="D8DBE0"/>
                       </a:solidFill>
                       <a:prstDash val="solid"/>
                       <a:round/>
@@ -5438,7 +4314,7 @@
                     </a:lnL>
                     <a:lnR w="12700" cap="flat" cmpd="sng" algn="ctr">
                       <a:solidFill>
-                        <a:srgbClr val="E6E8EC"/>
+                        <a:srgbClr val="D8DBE0"/>
                       </a:solidFill>
                       <a:prstDash val="solid"/>
                       <a:round/>
@@ -5447,7 +4323,7 @@
                     </a:lnR>
                     <a:lnT w="12700" cap="flat" cmpd="sng" algn="ctr">
                       <a:solidFill>
-                        <a:srgbClr val="E6E8EC"/>
+                        <a:srgbClr val="D8DBE0"/>
                       </a:solidFill>
                       <a:prstDash val="solid"/>
                       <a:round/>
@@ -5456,7 +4332,7 @@
                     </a:lnT>
                     <a:lnB w="12700" cap="flat" cmpd="sng" algn="ctr">
                       <a:solidFill>
-                        <a:srgbClr val="E6E8EC"/>
+                        <a:srgbClr val="D8DBE0"/>
                       </a:solidFill>
                       <a:prstDash val="solid"/>
                       <a:round/>
@@ -5485,7 +4361,7 @@
                           <a:ea typeface="Microsoft YaHei" pitchFamily="34" charset="-122"/>
                           <a:cs typeface="Microsoft YaHei" pitchFamily="34" charset="-120"/>
                         </a:rPr>
-                        <a:t>无 bulk 可判（上皮另由 decontX 判定）</a:t>
+                        <a:t>无 bulk 可判（上皮由 decontX 判定）</a:t>
                       </a:r>
                       <a:endParaRPr lang="en-US" sz="1200" dirty="0">
                         <a:latin typeface="Microsoft YaHei" charset="0"/>
@@ -5497,7 +4373,7 @@
                   <a:tcPr marL="76200" marR="76200" marT="50800" marB="50800" anchor="ctr">
                     <a:lnL w="12700" cap="flat" cmpd="sng" algn="ctr">
                       <a:solidFill>
-                        <a:srgbClr val="E6E8EC"/>
+                        <a:srgbClr val="D8DBE0"/>
                       </a:solidFill>
                       <a:prstDash val="solid"/>
                       <a:round/>
@@ -5506,7 +4382,7 @@
                     </a:lnL>
                     <a:lnR w="12700" cap="flat" cmpd="sng" algn="ctr">
                       <a:solidFill>
-                        <a:srgbClr val="E6E8EC"/>
+                        <a:srgbClr val="D8DBE0"/>
                       </a:solidFill>
                       <a:prstDash val="solid"/>
                       <a:round/>
@@ -5515,7 +4391,7 @@
                     </a:lnR>
                     <a:lnT w="12700" cap="flat" cmpd="sng" algn="ctr">
                       <a:solidFill>
-                        <a:srgbClr val="E6E8EC"/>
+                        <a:srgbClr val="D8DBE0"/>
                       </a:solidFill>
                       <a:prstDash val="solid"/>
                       <a:round/>
@@ -5524,7 +4400,7 @@
                     </a:lnT>
                     <a:lnB w="12700" cap="flat" cmpd="sng" algn="ctr">
                       <a:solidFill>
-                        <a:srgbClr val="E6E8EC"/>
+                        <a:srgbClr val="D8DBE0"/>
                       </a:solidFill>
                       <a:prstDash val="solid"/>
                       <a:round/>
@@ -5537,7 +4413,7 @@
                   </a:tcPr>
                 </a:tc>
               </a:tr>
-              <a:tr h="566928">
+              <a:tr h="548640">
                 <a:tc>
                   <a:txBody>
                     <a:bodyPr/>
@@ -5567,7 +4443,7 @@
                   <a:tcPr marL="76200" marR="76200" marT="50800" marB="50800" anchor="ctr">
                     <a:lnL w="12700" cap="flat" cmpd="sng" algn="ctr">
                       <a:solidFill>
-                        <a:srgbClr val="E6E8EC"/>
+                        <a:srgbClr val="D8DBE0"/>
                       </a:solidFill>
                       <a:prstDash val="solid"/>
                       <a:round/>
@@ -5576,7 +4452,7 @@
                     </a:lnL>
                     <a:lnR w="12700" cap="flat" cmpd="sng" algn="ctr">
                       <a:solidFill>
-                        <a:srgbClr val="E6E8EC"/>
+                        <a:srgbClr val="D8DBE0"/>
                       </a:solidFill>
                       <a:prstDash val="solid"/>
                       <a:round/>
@@ -5585,7 +4461,7 @@
                     </a:lnR>
                     <a:lnT w="12700" cap="flat" cmpd="sng" algn="ctr">
                       <a:solidFill>
-                        <a:srgbClr val="E6E8EC"/>
+                        <a:srgbClr val="D8DBE0"/>
                       </a:solidFill>
                       <a:prstDash val="solid"/>
                       <a:round/>
@@ -5594,7 +4470,7 @@
                     </a:lnT>
                     <a:lnB w="12700" cap="flat" cmpd="sng" algn="ctr">
                       <a:solidFill>
-                        <a:srgbClr val="E6E8EC"/>
+                        <a:srgbClr val="D8DBE0"/>
                       </a:solidFill>
                       <a:prstDash val="solid"/>
                       <a:round/>
@@ -5602,7 +4478,7 @@
                       <a:tailEnd type="none" w="med" len="med"/>
                     </a:lnB>
                     <a:solidFill>
-                      <a:srgbClr val="F5F7FA"/>
+                      <a:srgbClr val="FFFFFF"/>
                     </a:solidFill>
                   </a:tcPr>
                 </a:tc>
@@ -5635,7 +4511,7 @@
                   <a:tcPr marL="76200" marR="76200" marT="50800" marB="50800" anchor="ctr">
                     <a:lnL w="12700" cap="flat" cmpd="sng" algn="ctr">
                       <a:solidFill>
-                        <a:srgbClr val="E6E8EC"/>
+                        <a:srgbClr val="D8DBE0"/>
                       </a:solidFill>
                       <a:prstDash val="solid"/>
                       <a:round/>
@@ -5644,7 +4520,7 @@
                     </a:lnL>
                     <a:lnR w="12700" cap="flat" cmpd="sng" algn="ctr">
                       <a:solidFill>
-                        <a:srgbClr val="E6E8EC"/>
+                        <a:srgbClr val="D8DBE0"/>
                       </a:solidFill>
                       <a:prstDash val="solid"/>
                       <a:round/>
@@ -5653,7 +4529,7 @@
                     </a:lnR>
                     <a:lnT w="12700" cap="flat" cmpd="sng" algn="ctr">
                       <a:solidFill>
-                        <a:srgbClr val="E6E8EC"/>
+                        <a:srgbClr val="D8DBE0"/>
                       </a:solidFill>
                       <a:prstDash val="solid"/>
                       <a:round/>
@@ -5662,7 +4538,7 @@
                     </a:lnT>
                     <a:lnB w="12700" cap="flat" cmpd="sng" algn="ctr">
                       <a:solidFill>
-                        <a:srgbClr val="E6E8EC"/>
+                        <a:srgbClr val="D8DBE0"/>
                       </a:solidFill>
                       <a:prstDash val="solid"/>
                       <a:round/>
@@ -5670,7 +4546,7 @@
                       <a:tailEnd type="none" w="med" len="med"/>
                     </a:lnB>
                     <a:solidFill>
-                      <a:srgbClr val="F5F7FA"/>
+                      <a:srgbClr val="FFFFFF"/>
                     </a:solidFill>
                   </a:tcPr>
                 </a:tc>
@@ -5703,7 +4579,7 @@
                   <a:tcPr marL="76200" marR="76200" marT="50800" marB="50800" anchor="ctr">
                     <a:lnL w="12700" cap="flat" cmpd="sng" algn="ctr">
                       <a:solidFill>
-                        <a:srgbClr val="E6E8EC"/>
+                        <a:srgbClr val="D8DBE0"/>
                       </a:solidFill>
                       <a:prstDash val="solid"/>
                       <a:round/>
@@ -5712,7 +4588,7 @@
                     </a:lnL>
                     <a:lnR w="12700" cap="flat" cmpd="sng" algn="ctr">
                       <a:solidFill>
-                        <a:srgbClr val="E6E8EC"/>
+                        <a:srgbClr val="D8DBE0"/>
                       </a:solidFill>
                       <a:prstDash val="solid"/>
                       <a:round/>
@@ -5721,7 +4597,7 @@
                     </a:lnR>
                     <a:lnT w="12700" cap="flat" cmpd="sng" algn="ctr">
                       <a:solidFill>
-                        <a:srgbClr val="E6E8EC"/>
+                        <a:srgbClr val="D8DBE0"/>
                       </a:solidFill>
                       <a:prstDash val="solid"/>
                       <a:round/>
@@ -5730,7 +4606,7 @@
                     </a:lnT>
                     <a:lnB w="12700" cap="flat" cmpd="sng" algn="ctr">
                       <a:solidFill>
-                        <a:srgbClr val="E6E8EC"/>
+                        <a:srgbClr val="D8DBE0"/>
                       </a:solidFill>
                       <a:prstDash val="solid"/>
                       <a:round/>
@@ -5738,7 +4614,7 @@
                       <a:tailEnd type="none" w="med" len="med"/>
                     </a:lnB>
                     <a:solidFill>
-                      <a:srgbClr val="F5F7FA"/>
+                      <a:srgbClr val="FFFFFF"/>
                     </a:solidFill>
                   </a:tcPr>
                 </a:tc>
@@ -5771,7 +4647,7 @@
                   <a:tcPr marL="76200" marR="76200" marT="50800" marB="50800" anchor="ctr">
                     <a:lnL w="12700" cap="flat" cmpd="sng" algn="ctr">
                       <a:solidFill>
-                        <a:srgbClr val="E6E8EC"/>
+                        <a:srgbClr val="D8DBE0"/>
                       </a:solidFill>
                       <a:prstDash val="solid"/>
                       <a:round/>
@@ -5780,7 +4656,7 @@
                     </a:lnL>
                     <a:lnR w="12700" cap="flat" cmpd="sng" algn="ctr">
                       <a:solidFill>
-                        <a:srgbClr val="E6E8EC"/>
+                        <a:srgbClr val="D8DBE0"/>
                       </a:solidFill>
                       <a:prstDash val="solid"/>
                       <a:round/>
@@ -5789,7 +4665,7 @@
                     </a:lnR>
                     <a:lnT w="12700" cap="flat" cmpd="sng" algn="ctr">
                       <a:solidFill>
-                        <a:srgbClr val="E6E8EC"/>
+                        <a:srgbClr val="D8DBE0"/>
                       </a:solidFill>
                       <a:prstDash val="solid"/>
                       <a:round/>
@@ -5798,7 +4674,7 @@
                     </a:lnT>
                     <a:lnB w="12700" cap="flat" cmpd="sng" algn="ctr">
                       <a:solidFill>
-                        <a:srgbClr val="E6E8EC"/>
+                        <a:srgbClr val="D8DBE0"/>
                       </a:solidFill>
                       <a:prstDash val="solid"/>
                       <a:round/>
@@ -5806,7 +4682,7 @@
                       <a:tailEnd type="none" w="med" len="med"/>
                     </a:lnB>
                     <a:solidFill>
-                      <a:srgbClr val="F5F7FA"/>
+                      <a:srgbClr val="FFFFFF"/>
                     </a:solidFill>
                   </a:tcPr>
                 </a:tc>
@@ -5817,14 +4693,14 @@
       </p:graphicFrame>
       <p:sp>
         <p:nvSpPr>
-          <p:cNvPr id="5" name="Text 2"/>
+          <p:cNvPr id="4" name="Text 1"/>
           <p:cNvSpPr txBox="1"/>
           <p:nvPr/>
         </p:nvSpPr>
         <p:spPr>
           <a:xfrm>
-            <a:off x="640080" y="6291072"/>
-            <a:ext cx="10972800" cy="365760"/>
+            <a:off x="640080" y="6327648"/>
+            <a:ext cx="10972800" cy="347472"/>
           </a:xfrm>
           <a:prstGeom prst="rect">
             <a:avLst/>
@@ -5840,7 +4716,7 @@
               <a:buNone/>
             </a:pPr>
             <a:r>
-              <a:rPr lang="en-US" sz="1050" i="1" dirty="0">
+              <a:rPr lang="en-US" sz="1050" dirty="0">
                 <a:solidFill>
                   <a:srgbClr val="6B6B6B"/>
                 </a:solidFill>
@@ -5848,7 +4724,7 @@
                 <a:ea typeface="Microsoft YaHei" pitchFamily="34" charset="-122"/>
                 <a:cs typeface="Microsoft YaHei" pitchFamily="34" charset="-120"/>
               </a:rPr>
-              <a:t>仅并列呈现，不做统计检验（规格 §6.3）。完整表：results/il18_zero_check.tsv</a:t>
+              <a:t>仅并列呈现，不做统计检验。完整表：results/il18_zero_check.tsv</a:t>
             </a:r>
             <a:endParaRPr lang="en-US" sz="1050" dirty="0"/>
           </a:p>
@@ -5862,9 +4738,9 @@
 </p:sld>
 </file>
 
-<file path=ppt/slides/slide9.xml><?xml version="1.0" encoding="utf-8"?>
+<file path=ppt/slides/slide8.xml><?xml version="1.0" encoding="utf-8"?>
 <p:sld xmlns:a="http://schemas.openxmlformats.org/drawingml/2006/main" xmlns:r="http://schemas.openxmlformats.org/officeDocument/2006/relationships" xmlns:p="http://schemas.openxmlformats.org/presentationml/2006/main">
-  <p:cSld name="Slide 9">
+  <p:cSld name="Slide 8">
     <p:spTree>
       <p:nvGrpSpPr>
         <p:cNvPr id="1" name=""/>
@@ -5888,7 +4764,7 @@
         <p:spPr>
           <a:xfrm>
             <a:off x="640080" y="457200"/>
-            <a:ext cx="10972800" cy="274320"/>
+            <a:ext cx="10972800" cy="640080"/>
           </a:xfrm>
           <a:prstGeom prst="rect">
             <a:avLst/>
@@ -5904,46 +4780,7 @@
               <a:buNone/>
             </a:pPr>
             <a:r>
-              <a:rPr lang="en-US" sz="1200" b="1" spc="200" kern="0" dirty="0">
-                <a:solidFill>
-                  <a:srgbClr val="1C5CAB"/>
-                </a:solidFill>
-                <a:latin typeface="Microsoft YaHei" pitchFamily="34" charset="0"/>
-                <a:ea typeface="Microsoft YaHei" pitchFamily="34" charset="-122"/>
-                <a:cs typeface="Microsoft YaHei" pitchFamily="34" charset="-120"/>
-              </a:rPr>
-              <a:t>数据缺口与偏离</a:t>
-            </a:r>
-            <a:endParaRPr lang="en-US" sz="1200" dirty="0"/>
-          </a:p>
-        </p:txBody>
-      </p:sp>
-      <p:sp>
-        <p:nvSpPr>
-          <p:cNvPr id="3" name="Text 1"/>
-          <p:cNvSpPr txBox="1"/>
-          <p:nvPr/>
-        </p:nvSpPr>
-        <p:spPr>
-          <a:xfrm>
-            <a:off x="640080" y="713232"/>
-            <a:ext cx="10972800" cy="640080"/>
-          </a:xfrm>
-          <a:prstGeom prst="rect">
-            <a:avLst/>
-          </a:prstGeom>
-          <a:noFill/>
-          <a:ln/>
-        </p:spPr>
-        <p:txBody>
-          <a:bodyPr wrap="square" rtlCol="0" anchor="ctr"/>
-          <a:lstStyle/>
-          <a:p>
-            <a:pPr indent="0" marL="0">
-              <a:buNone/>
-            </a:pPr>
-            <a:r>
-              <a:rPr lang="en-US" sz="2600" b="1" dirty="0">
+              <a:rPr lang="en-US" sz="2500" b="1" dirty="0">
                 <a:solidFill>
                   <a:srgbClr val="1A1A1A"/>
                 </a:solidFill>
@@ -5951,22 +4788,22 @@
                 <a:ea typeface="Microsoft YaHei" pitchFamily="34" charset="-122"/>
                 <a:cs typeface="Microsoft YaHei" pitchFamily="34" charset="-120"/>
               </a:rPr>
-              <a:t>如实记录</a:t>
-            </a:r>
-            <a:endParaRPr lang="en-US" sz="2600" dirty="0"/>
-          </a:p>
-        </p:txBody>
-      </p:sp>
-      <p:sp>
-        <p:nvSpPr>
-          <p:cNvPr id="4" name="Text 2"/>
+              <a:t>数据缺口与偏离</a:t>
+            </a:r>
+            <a:endParaRPr lang="en-US" sz="2500" dirty="0"/>
+          </a:p>
+        </p:txBody>
+      </p:sp>
+      <p:sp>
+        <p:nvSpPr>
+          <p:cNvPr id="3" name="Text 1"/>
           <p:cNvSpPr txBox="1"/>
           <p:nvPr/>
         </p:nvSpPr>
         <p:spPr>
           <a:xfrm>
-            <a:off x="640080" y="1828800"/>
-            <a:ext cx="2743200" cy="822960"/>
+            <a:off x="640080" y="1417320"/>
+            <a:ext cx="2743200" cy="914400"/>
           </a:xfrm>
           <a:prstGeom prst="rect">
             <a:avLst/>
@@ -5984,7 +4821,7 @@
             <a:r>
               <a:rPr lang="en-US" sz="1350" b="1" dirty="0">
                 <a:solidFill>
-                  <a:srgbClr val="1C5CAB"/>
+                  <a:srgbClr val="1A1A1A"/>
                 </a:solidFill>
                 <a:latin typeface="Microsoft YaHei" pitchFamily="34" charset="0"/>
                 <a:ea typeface="Microsoft YaHei" pitchFamily="34" charset="-122"/>
@@ -5998,14 +4835,14 @@
       </p:sp>
       <p:sp>
         <p:nvSpPr>
-          <p:cNvPr id="5" name="Text 3"/>
+          <p:cNvPr id="4" name="Text 2"/>
           <p:cNvSpPr txBox="1"/>
           <p:nvPr/>
         </p:nvSpPr>
         <p:spPr>
           <a:xfrm>
-            <a:off x="3474720" y="1828800"/>
-            <a:ext cx="8046720" cy="868680"/>
+            <a:off x="3474720" y="1417320"/>
+            <a:ext cx="8046720" cy="914400"/>
           </a:xfrm>
           <a:prstGeom prst="rect">
             <a:avLst/>
@@ -6019,7 +4856,7 @@
           <a:p>
             <a:pPr indent="0" marL="0">
               <a:lnSpc>
-                <a:spcPct val="112000"/>
+                <a:spcPct val="118000"/>
               </a:lnSpc>
               <a:buNone/>
             </a:pPr>
@@ -6032,7 +4869,7 @@
                 <a:ea typeface="Microsoft YaHei" pitchFamily="34" charset="-122"/>
                 <a:cs typeface="Microsoft YaHei" pitchFamily="34" charset="-120"/>
               </a:rPr>
-              <a:t>数据缺口：人肺流感单细胞几乎不存在（唯一候选为单供体离体肺）。未用鼻腔/外周血填补。</a:t>
+              <a:t>数据缺口：人肺流感单细胞几乎不存在（唯一候选为单供体离体肺）；未用鼻腔/外周血填补。</a:t>
             </a:r>
             <a:endParaRPr lang="en-US" sz="1300" dirty="0"/>
           </a:p>
@@ -6040,14 +4877,14 @@
       </p:sp>
       <p:sp>
         <p:nvSpPr>
-          <p:cNvPr id="6" name="Text 4"/>
+          <p:cNvPr id="5" name="Text 3"/>
           <p:cNvSpPr txBox="1"/>
           <p:nvPr/>
         </p:nvSpPr>
         <p:spPr>
           <a:xfrm>
-            <a:off x="640080" y="2852928"/>
-            <a:ext cx="2743200" cy="822960"/>
+            <a:off x="640080" y="2514600"/>
+            <a:ext cx="2743200" cy="914400"/>
           </a:xfrm>
           <a:prstGeom prst="rect">
             <a:avLst/>
@@ -6065,7 +4902,7 @@
             <a:r>
               <a:rPr lang="en-US" sz="1350" b="1" dirty="0">
                 <a:solidFill>
-                  <a:srgbClr val="1C5CAB"/>
+                  <a:srgbClr val="1A1A1A"/>
                 </a:solidFill>
                 <a:latin typeface="Microsoft YaHei" pitchFamily="34" charset="0"/>
                 <a:ea typeface="Microsoft YaHei" pitchFamily="34" charset="-122"/>
@@ -6079,14 +4916,14 @@
       </p:sp>
       <p:sp>
         <p:nvSpPr>
-          <p:cNvPr id="7" name="Text 5"/>
+          <p:cNvPr id="6" name="Text 4"/>
           <p:cNvSpPr txBox="1"/>
           <p:nvPr/>
         </p:nvSpPr>
         <p:spPr>
           <a:xfrm>
-            <a:off x="3474720" y="2852928"/>
-            <a:ext cx="8046720" cy="868680"/>
+            <a:off x="3474720" y="2514600"/>
+            <a:ext cx="8046720" cy="914400"/>
           </a:xfrm>
           <a:prstGeom prst="rect">
             <a:avLst/>
@@ -6100,7 +4937,7 @@
           <a:p>
             <a:pPr indent="0" marL="0">
               <a:lnSpc>
-                <a:spcPct val="112000"/>
+                <a:spcPct val="118000"/>
               </a:lnSpc>
               <a:buNone/>
             </a:pPr>
@@ -6121,14 +4958,14 @@
       </p:sp>
       <p:sp>
         <p:nvSpPr>
-          <p:cNvPr id="8" name="Text 6"/>
+          <p:cNvPr id="7" name="Text 5"/>
           <p:cNvSpPr txBox="1"/>
           <p:nvPr/>
         </p:nvSpPr>
         <p:spPr>
           <a:xfrm>
-            <a:off x="640080" y="3877056"/>
-            <a:ext cx="2743200" cy="822960"/>
+            <a:off x="640080" y="3611880"/>
+            <a:ext cx="2743200" cy="914400"/>
           </a:xfrm>
           <a:prstGeom prst="rect">
             <a:avLst/>
@@ -6146,7 +4983,7 @@
             <a:r>
               <a:rPr lang="en-US" sz="1350" b="1" dirty="0">
                 <a:solidFill>
-                  <a:srgbClr val="1C5CAB"/>
+                  <a:srgbClr val="1A1A1A"/>
                 </a:solidFill>
                 <a:latin typeface="Microsoft YaHei" pitchFamily="34" charset="0"/>
                 <a:ea typeface="Microsoft YaHei" pitchFamily="34" charset="-122"/>
@@ -6160,14 +4997,14 @@
       </p:sp>
       <p:sp>
         <p:nvSpPr>
-          <p:cNvPr id="9" name="Text 7"/>
+          <p:cNvPr id="8" name="Text 6"/>
           <p:cNvSpPr txBox="1"/>
           <p:nvPr/>
         </p:nvSpPr>
         <p:spPr>
           <a:xfrm>
-            <a:off x="3474720" y="3877056"/>
-            <a:ext cx="8046720" cy="868680"/>
+            <a:off x="3474720" y="3611880"/>
+            <a:ext cx="8046720" cy="914400"/>
           </a:xfrm>
           <a:prstGeom prst="rect">
             <a:avLst/>
@@ -6181,7 +5018,7 @@
           <a:p>
             <a:pPr indent="0" marL="0">
               <a:lnSpc>
-                <a:spcPct val="112000"/>
+                <a:spcPct val="118000"/>
               </a:lnSpc>
               <a:buNone/>
             </a:pPr>
@@ -6202,14 +5039,14 @@
       </p:sp>
       <p:sp>
         <p:nvSpPr>
-          <p:cNvPr id="10" name="Text 8"/>
+          <p:cNvPr id="9" name="Text 7"/>
           <p:cNvSpPr txBox="1"/>
           <p:nvPr/>
         </p:nvSpPr>
         <p:spPr>
           <a:xfrm>
-            <a:off x="640080" y="4901184"/>
-            <a:ext cx="2743200" cy="822960"/>
+            <a:off x="640080" y="4709160"/>
+            <a:ext cx="2743200" cy="914400"/>
           </a:xfrm>
           <a:prstGeom prst="rect">
             <a:avLst/>
@@ -6227,7 +5064,7 @@
             <a:r>
               <a:rPr lang="en-US" sz="1350" b="1" dirty="0">
                 <a:solidFill>
-                  <a:srgbClr val="1C5CAB"/>
+                  <a:srgbClr val="1A1A1A"/>
                 </a:solidFill>
                 <a:latin typeface="Microsoft YaHei" pitchFamily="34" charset="0"/>
                 <a:ea typeface="Microsoft YaHei" pitchFamily="34" charset="-122"/>
@@ -6241,14 +5078,14 @@
       </p:sp>
       <p:sp>
         <p:nvSpPr>
-          <p:cNvPr id="11" name="Text 9"/>
+          <p:cNvPr id="10" name="Text 8"/>
           <p:cNvSpPr txBox="1"/>
           <p:nvPr/>
         </p:nvSpPr>
         <p:spPr>
           <a:xfrm>
-            <a:off x="3474720" y="4901184"/>
-            <a:ext cx="8046720" cy="868680"/>
+            <a:off x="3474720" y="4709160"/>
+            <a:ext cx="8046720" cy="914400"/>
           </a:xfrm>
           <a:prstGeom prst="rect">
             <a:avLst/>
@@ -6262,7 +5099,7 @@
           <a:p>
             <a:pPr indent="0" marL="0">
               <a:lnSpc>
-                <a:spcPct val="112000"/>
+                <a:spcPct val="118000"/>
               </a:lnSpc>
               <a:buNone/>
             </a:pPr>
@@ -6275,7 +5112,7 @@
                 <a:ea typeface="Microsoft YaHei" pitchFamily="34" charset="-122"/>
                 <a:cs typeface="Microsoft YaHei" pitchFamily="34" charset="-120"/>
               </a:rPr>
-              <a:t>已纳入 GSE280364、GSE280611（全肺、2 vs 2、含对照）。因无作者逐细胞注释，采用自行注释（scanpy Leiden + marker），属经授权的偏离；结果与其余数据一致（肺泡巨噬细胞排名第一）。</a:t>
+              <a:t>已纳入 GSE280364、GSE280611（全肺、2 vs 2、含对照）。因无作者注释，经授权采用自行注释（scanpy Leiden + marker），结果与其余数据一致（肺泡巨噬细胞排名第一）。</a:t>
             </a:r>
             <a:endParaRPr lang="en-US" sz="1300" dirty="0"/>
           </a:p>

</xml_diff>

<commit_message>
Deck: add final conclusion slide answering the question by condition x species
Builds on the user-edited 7-slide deck and appends slide 8: a species x
condition matrix (resting / influenza / SARS-CoV-2 / bacterial / LPS-ALI)
listing which cell types transcribe IL18 in human and mouse lung, with the
data gaps stated and a one-line common answer.

Co-Authored-By: Claude Opus 4.8 <noreply@anthropic.com>
Claude-Session: https://claude.ai/code/session_017TbtQvXEFqesh7AxtExDwE
</commit_message>
<xml_diff>
--- a/il18_lung/IL18_lung_celltype.pptx
+++ b/il18_lung/IL18_lung_celltype.pptx
@@ -1,22 +1,22 @@
 
 <file path=ppt/presentation.xml><?xml version="1.0" encoding="utf-8"?>
-<p:presentation xmlns:a="http://schemas.openxmlformats.org/drawingml/2006/main" xmlns:r="http://schemas.openxmlformats.org/officeDocument/2006/relationships" xmlns:p="http://schemas.openxmlformats.org/presentationml/2006/main" saveSubsetFonts="1" autoCompressPictures="0">
+<p:presentation xmlns:a="http://schemas.openxmlformats.org/drawingml/2006/main" xmlns:r="http://schemas.openxmlformats.org/officeDocument/2006/relationships" xmlns:p="http://schemas.openxmlformats.org/presentationml/2006/main" autoCompressPictures="0">
   <p:sldMasterIdLst>
     <p:sldMasterId id="2147483648" r:id="rId1"/>
   </p:sldMasterIdLst>
+  <p:notesMasterIdLst>
+    <p:notesMasterId r:id="rId4"/>
+  </p:notesMasterIdLst>
   <p:sldIdLst>
-    <p:sldId id="256" r:id="rId2"/>
-    <p:sldId id="257" r:id="rId3"/>
-    <p:sldId id="258" r:id="rId4"/>
-    <p:sldId id="259" r:id="rId5"/>
-    <p:sldId id="260" r:id="rId6"/>
-    <p:sldId id="261" r:id="rId7"/>
-    <p:sldId id="262" r:id="rId8"/>
-    <p:sldId id="263" r:id="rId9"/>
+    <p:sldId id="256" r:id="rId3"/>
+    <p:sldId id="257" r:id="rId5"/>
+    <p:sldId id="258" r:id="rId6"/>
+    <p:sldId id="259" r:id="rId7"/>
+    <p:sldId id="260" r:id="rId8"/>
+    <p:sldId id="261" r:id="rId9"/>
+    <p:sldId id="263" r:id="rId10"/>
+    <p:sldId id="264" r:id="rId14"/>
   </p:sldIdLst>
-  <p:notesMasterIdLst>
-    <p:notesMasterId r:id="rId10"/>
-  </p:notesMasterIdLst>
   <p:sldSz cx="12192000" cy="6858000"/>
   <p:notesSz cx="6858000" cy="12192000"/>
   <p:defaultTextStyle>
@@ -196,7 +196,6 @@
           <a:p>
             <a:fld id="{5282F153-3F37-0F45-9E97-73ACFA13230C}" type="datetimeFigureOut">
               <a:rPr lang="en-US"/>
-              <a:t>7/23/19</a:t>
             </a:fld>
             <a:endParaRPr lang="en-US"/>
           </a:p>
@@ -263,6 +262,7 @@
               <a:rPr lang="en-US"/>
               <a:t>Click to edit Master text styles</a:t>
             </a:r>
+            <a:endParaRPr lang="en-US"/>
           </a:p>
           <a:p>
             <a:pPr lvl="1"/>
@@ -270,6 +270,7 @@
               <a:rPr lang="en-US"/>
               <a:t>Second level</a:t>
             </a:r>
+            <a:endParaRPr lang="en-US"/>
           </a:p>
           <a:p>
             <a:pPr lvl="2"/>
@@ -277,6 +278,7 @@
               <a:rPr lang="en-US"/>
               <a:t>Third level</a:t>
             </a:r>
+            <a:endParaRPr lang="en-US"/>
           </a:p>
           <a:p>
             <a:pPr lvl="3"/>
@@ -284,6 +286,7 @@
               <a:rPr lang="en-US"/>
               <a:t>Fourth level</a:t>
             </a:r>
+            <a:endParaRPr lang="en-US"/>
           </a:p>
           <a:p>
             <a:pPr lvl="4"/>
@@ -291,6 +294,7 @@
               <a:rPr lang="en-US"/>
               <a:t>Fifth level</a:t>
             </a:r>
+            <a:endParaRPr lang="en-US"/>
           </a:p>
         </p:txBody>
       </p:sp>
@@ -354,18 +358,12 @@
           <a:p>
             <a:fld id="{CE5E9CC1-C706-0F49-92D6-E571CC5EEA8F}" type="slidenum">
               <a:rPr lang="en-US"/>
-              <a:t>‹#›</a:t>
             </a:fld>
             <a:endParaRPr lang="en-US"/>
           </a:p>
         </p:txBody>
       </p:sp>
     </p:spTree>
-    <p:extLst>
-      <p:ext uri="{BB962C8B-B14F-4D97-AF65-F5344CB8AC3E}">
-        <p14:creationId xmlns:p14="http://schemas.microsoft.com/office/powerpoint/2010/main" val="1024086991"/>
-      </p:ext>
-    </p:extLst>
   </p:cSld>
   <p:clrMap bg1="lt1" tx1="dk1" bg2="lt2" tx2="dk2" accent1="accent1" accent2="accent2" accent3="accent3" accent4="accent4" accent5="accent5" accent6="accent6" hlink="hlink" folHlink="folHlink"/>
   <p:notesStyle>
@@ -507,10 +505,6 @@
           <a:bodyPr/>
           <a:lstStyle/>
           <a:p>
-            <a:r>
-              <a:rPr lang="en-US" dirty="0"/>
-              <a:t/>
-            </a:r>
             <a:endParaRPr lang="en-US" dirty="0"/>
           </a:p>
         </p:txBody>
@@ -532,18 +526,12 @@
           <a:p>
             <a:fld id="{F7021451-1387-4CA6-816F-3879F97B5CBC}" type="slidenum">
               <a:rPr lang="en-US"/>
-              <a:t>1</a:t>
             </a:fld>
             <a:endParaRPr lang="en-US"/>
           </a:p>
         </p:txBody>
       </p:sp>
     </p:spTree>
-    <p:extLst>
-      <p:ext uri="{BB962C8B-B14F-4D97-AF65-F5344CB8AC3E}">
-        <p14:creationId xmlns:p14="http://schemas.microsoft.com/office/powerpoint/2010/main" val="1024086991"/>
-      </p:ext>
-    </p:extLst>
   </p:cSld>
   <p:clrMapOvr>
     <a:masterClrMapping/>
@@ -595,10 +583,6 @@
           <a:bodyPr/>
           <a:lstStyle/>
           <a:p>
-            <a:r>
-              <a:rPr lang="en-US" dirty="0"/>
-              <a:t/>
-            </a:r>
             <a:endParaRPr lang="en-US" dirty="0"/>
           </a:p>
         </p:txBody>
@@ -620,18 +604,12 @@
           <a:p>
             <a:fld id="{F7021451-1387-4CA6-816F-3879F97B5CBC}" type="slidenum">
               <a:rPr lang="en-US"/>
-              <a:t>2</a:t>
             </a:fld>
             <a:endParaRPr lang="en-US"/>
           </a:p>
         </p:txBody>
       </p:sp>
     </p:spTree>
-    <p:extLst>
-      <p:ext uri="{BB962C8B-B14F-4D97-AF65-F5344CB8AC3E}">
-        <p14:creationId xmlns:p14="http://schemas.microsoft.com/office/powerpoint/2010/main" val="1024086991"/>
-      </p:ext>
-    </p:extLst>
   </p:cSld>
   <p:clrMapOvr>
     <a:masterClrMapping/>
@@ -683,10 +661,6 @@
           <a:bodyPr/>
           <a:lstStyle/>
           <a:p>
-            <a:r>
-              <a:rPr lang="en-US" dirty="0"/>
-              <a:t/>
-            </a:r>
             <a:endParaRPr lang="en-US" dirty="0"/>
           </a:p>
         </p:txBody>
@@ -708,18 +682,12 @@
           <a:p>
             <a:fld id="{F7021451-1387-4CA6-816F-3879F97B5CBC}" type="slidenum">
               <a:rPr lang="en-US"/>
-              <a:t>3</a:t>
             </a:fld>
             <a:endParaRPr lang="en-US"/>
           </a:p>
         </p:txBody>
       </p:sp>
     </p:spTree>
-    <p:extLst>
-      <p:ext uri="{BB962C8B-B14F-4D97-AF65-F5344CB8AC3E}">
-        <p14:creationId xmlns:p14="http://schemas.microsoft.com/office/powerpoint/2010/main" val="1024086991"/>
-      </p:ext>
-    </p:extLst>
   </p:cSld>
   <p:clrMapOvr>
     <a:masterClrMapping/>
@@ -771,10 +739,6 @@
           <a:bodyPr/>
           <a:lstStyle/>
           <a:p>
-            <a:r>
-              <a:rPr lang="en-US" dirty="0"/>
-              <a:t/>
-            </a:r>
             <a:endParaRPr lang="en-US" dirty="0"/>
           </a:p>
         </p:txBody>
@@ -796,18 +760,12 @@
           <a:p>
             <a:fld id="{F7021451-1387-4CA6-816F-3879F97B5CBC}" type="slidenum">
               <a:rPr lang="en-US"/>
-              <a:t>4</a:t>
             </a:fld>
             <a:endParaRPr lang="en-US"/>
           </a:p>
         </p:txBody>
       </p:sp>
     </p:spTree>
-    <p:extLst>
-      <p:ext uri="{BB962C8B-B14F-4D97-AF65-F5344CB8AC3E}">
-        <p14:creationId xmlns:p14="http://schemas.microsoft.com/office/powerpoint/2010/main" val="1024086991"/>
-      </p:ext>
-    </p:extLst>
   </p:cSld>
   <p:clrMapOvr>
     <a:masterClrMapping/>
@@ -859,10 +817,6 @@
           <a:bodyPr/>
           <a:lstStyle/>
           <a:p>
-            <a:r>
-              <a:rPr lang="en-US" dirty="0"/>
-              <a:t/>
-            </a:r>
             <a:endParaRPr lang="en-US" dirty="0"/>
           </a:p>
         </p:txBody>
@@ -884,18 +838,12 @@
           <a:p>
             <a:fld id="{F7021451-1387-4CA6-816F-3879F97B5CBC}" type="slidenum">
               <a:rPr lang="en-US"/>
-              <a:t>5</a:t>
             </a:fld>
             <a:endParaRPr lang="en-US"/>
           </a:p>
         </p:txBody>
       </p:sp>
     </p:spTree>
-    <p:extLst>
-      <p:ext uri="{BB962C8B-B14F-4D97-AF65-F5344CB8AC3E}">
-        <p14:creationId xmlns:p14="http://schemas.microsoft.com/office/powerpoint/2010/main" val="1024086991"/>
-      </p:ext>
-    </p:extLst>
   </p:cSld>
   <p:clrMapOvr>
     <a:masterClrMapping/>
@@ -947,10 +895,6 @@
           <a:bodyPr/>
           <a:lstStyle/>
           <a:p>
-            <a:r>
-              <a:rPr lang="en-US" dirty="0"/>
-              <a:t/>
-            </a:r>
             <a:endParaRPr lang="en-US" dirty="0"/>
           </a:p>
         </p:txBody>
@@ -972,18 +916,12 @@
           <a:p>
             <a:fld id="{F7021451-1387-4CA6-816F-3879F97B5CBC}" type="slidenum">
               <a:rPr lang="en-US"/>
-              <a:t>6</a:t>
             </a:fld>
             <a:endParaRPr lang="en-US"/>
           </a:p>
         </p:txBody>
       </p:sp>
     </p:spTree>
-    <p:extLst>
-      <p:ext uri="{BB962C8B-B14F-4D97-AF65-F5344CB8AC3E}">
-        <p14:creationId xmlns:p14="http://schemas.microsoft.com/office/powerpoint/2010/main" val="1024086991"/>
-      </p:ext>
-    </p:extLst>
   </p:cSld>
   <p:clrMapOvr>
     <a:masterClrMapping/>
@@ -1035,10 +973,6 @@
           <a:bodyPr/>
           <a:lstStyle/>
           <a:p>
-            <a:r>
-              <a:rPr lang="en-US" dirty="0"/>
-              <a:t/>
-            </a:r>
             <a:endParaRPr lang="en-US" dirty="0"/>
           </a:p>
         </p:txBody>
@@ -1060,106 +994,12 @@
           <a:p>
             <a:fld id="{F7021451-1387-4CA6-816F-3879F97B5CBC}" type="slidenum">
               <a:rPr lang="en-US"/>
-              <a:t>7</a:t>
             </a:fld>
             <a:endParaRPr lang="en-US"/>
           </a:p>
         </p:txBody>
       </p:sp>
     </p:spTree>
-    <p:extLst>
-      <p:ext uri="{BB962C8B-B14F-4D97-AF65-F5344CB8AC3E}">
-        <p14:creationId xmlns:p14="http://schemas.microsoft.com/office/powerpoint/2010/main" val="1024086991"/>
-      </p:ext>
-    </p:extLst>
-  </p:cSld>
-  <p:clrMapOvr>
-    <a:masterClrMapping/>
-  </p:clrMapOvr>
-</p:notes>
-</file>
-
-<file path=ppt/notesSlides/notesSlide8.xml><?xml version="1.0" encoding="utf-8"?>
-<p:notes xmlns:a="http://schemas.openxmlformats.org/drawingml/2006/main" xmlns:r="http://schemas.openxmlformats.org/officeDocument/2006/relationships" xmlns:p="http://schemas.openxmlformats.org/presentationml/2006/main">
-  <p:cSld>
-    <p:spTree>
-      <p:nvGrpSpPr>
-        <p:cNvPr id="1" name=""/>
-        <p:cNvGrpSpPr/>
-        <p:nvPr/>
-      </p:nvGrpSpPr>
-      <p:grpSpPr>
-        <a:xfrm>
-          <a:off x="0" y="0"/>
-          <a:ext cx="0" cy="0"/>
-          <a:chOff x="0" y="0"/>
-          <a:chExt cx="0" cy="0"/>
-        </a:xfrm>
-      </p:grpSpPr>
-      <p:sp>
-        <p:nvSpPr>
-          <p:cNvPr id="2" name="Slide Image Placeholder 1"/>
-          <p:cNvSpPr>
-            <a:spLocks noGrp="1" noRot="1" noChangeAspect="1"/>
-          </p:cNvSpPr>
-          <p:nvPr>
-            <p:ph type="sldImg"/>
-          </p:nvPr>
-        </p:nvSpPr>
-        <p:spPr/>
-      </p:sp>
-      <p:sp>
-        <p:nvSpPr>
-          <p:cNvPr id="3" name="Notes Placeholder 2"/>
-          <p:cNvSpPr>
-            <a:spLocks noGrp="1"/>
-          </p:cNvSpPr>
-          <p:nvPr>
-            <p:ph type="body" idx="1"/>
-          </p:nvPr>
-        </p:nvSpPr>
-        <p:spPr/>
-        <p:txBody>
-          <a:bodyPr/>
-          <a:lstStyle/>
-          <a:p>
-            <a:r>
-              <a:rPr lang="en-US" dirty="0"/>
-              <a:t/>
-            </a:r>
-            <a:endParaRPr lang="en-US" dirty="0"/>
-          </a:p>
-        </p:txBody>
-      </p:sp>
-      <p:sp>
-        <p:nvSpPr>
-          <p:cNvPr id="4" name="Slide Number Placeholder 3"/>
-          <p:cNvSpPr>
-            <a:spLocks noGrp="1"/>
-          </p:cNvSpPr>
-          <p:nvPr>
-            <p:ph type="sldNum" sz="quarter" idx="10"/>
-          </p:nvPr>
-        </p:nvSpPr>
-        <p:spPr/>
-        <p:txBody>
-          <a:bodyPr/>
-          <a:lstStyle/>
-          <a:p>
-            <a:fld id="{F7021451-1387-4CA6-816F-3879F97B5CBC}" type="slidenum">
-              <a:rPr lang="en-US"/>
-              <a:t>8</a:t>
-            </a:fld>
-            <a:endParaRPr lang="en-US"/>
-          </a:p>
-        </p:txBody>
-      </p:sp>
-    </p:spTree>
-    <p:extLst>
-      <p:ext uri="{BB962C8B-B14F-4D97-AF65-F5344CB8AC3E}">
-        <p14:creationId xmlns:p14="http://schemas.microsoft.com/office/powerpoint/2010/main" val="1024086991"/>
-      </p:ext>
-    </p:extLst>
   </p:cSld>
   <p:clrMapOvr>
     <a:masterClrMapping/>
@@ -1200,6 +1040,11 @@
 <file path=ppt/slideMasters/slideMaster1.xml><?xml version="1.0" encoding="utf-8"?>
 <p:sldMaster xmlns:a="http://schemas.openxmlformats.org/drawingml/2006/main" xmlns:r="http://schemas.openxmlformats.org/officeDocument/2006/relationships" xmlns:p="http://schemas.openxmlformats.org/presentationml/2006/main">
   <p:cSld>
+    <p:bg>
+      <p:bgRef idx="1001">
+        <a:schemeClr val="bg1"/>
+      </p:bgRef>
+    </p:bg>
     <p:spTree>
       <p:nvGrpSpPr>
         <p:cNvPr id="1" name=""/>
@@ -1243,7 +1088,7 @@
         <a:spcBef>
           <a:spcPct val="20000"/>
         </a:spcBef>
-        <a:buFont typeface="Arial" pitchFamily="34" charset="0"/>
+        <a:buFont typeface="Arial" panose="020B0704020202020204" pitchFamily="34" charset="0"/>
         <a:buChar char="•"/>
         <a:defRPr sz="3200" kern="1200">
           <a:solidFill>
@@ -1258,7 +1103,7 @@
         <a:spcBef>
           <a:spcPct val="20000"/>
         </a:spcBef>
-        <a:buFont typeface="Arial" pitchFamily="34" charset="0"/>
+        <a:buFont typeface="Arial" panose="020B0704020202020204" pitchFamily="34" charset="0"/>
         <a:buChar char="–"/>
         <a:defRPr sz="2800" kern="1200">
           <a:solidFill>
@@ -1273,7 +1118,7 @@
         <a:spcBef>
           <a:spcPct val="20000"/>
         </a:spcBef>
-        <a:buFont typeface="Arial" pitchFamily="34" charset="0"/>
+        <a:buFont typeface="Arial" panose="020B0704020202020204" pitchFamily="34" charset="0"/>
         <a:buChar char="•"/>
         <a:defRPr sz="2400" kern="1200">
           <a:solidFill>
@@ -1288,7 +1133,7 @@
         <a:spcBef>
           <a:spcPct val="20000"/>
         </a:spcBef>
-        <a:buFont typeface="Arial" pitchFamily="34" charset="0"/>
+        <a:buFont typeface="Arial" panose="020B0704020202020204" pitchFamily="34" charset="0"/>
         <a:buChar char="–"/>
         <a:defRPr sz="2000" kern="1200">
           <a:solidFill>
@@ -1303,7 +1148,7 @@
         <a:spcBef>
           <a:spcPct val="20000"/>
         </a:spcBef>
-        <a:buFont typeface="Arial" pitchFamily="34" charset="0"/>
+        <a:buFont typeface="Arial" panose="020B0704020202020204" pitchFamily="34" charset="0"/>
         <a:buChar char="»"/>
         <a:defRPr sz="2000" kern="1200">
           <a:solidFill>
@@ -1318,7 +1163,7 @@
         <a:spcBef>
           <a:spcPct val="20000"/>
         </a:spcBef>
-        <a:buFont typeface="Arial" pitchFamily="34" charset="0"/>
+        <a:buFont typeface="Arial" panose="020B0704020202020204" pitchFamily="34" charset="0"/>
         <a:buChar char="•"/>
         <a:defRPr sz="2000" kern="1200">
           <a:solidFill>
@@ -1333,7 +1178,7 @@
         <a:spcBef>
           <a:spcPct val="20000"/>
         </a:spcBef>
-        <a:buFont typeface="Arial" pitchFamily="34" charset="0"/>
+        <a:buFont typeface="Arial" panose="020B0704020202020204" pitchFamily="34" charset="0"/>
         <a:buChar char="•"/>
         <a:defRPr sz="2000" kern="1200">
           <a:solidFill>
@@ -1348,7 +1193,7 @@
         <a:spcBef>
           <a:spcPct val="20000"/>
         </a:spcBef>
-        <a:buFont typeface="Arial" pitchFamily="34" charset="0"/>
+        <a:buFont typeface="Arial" panose="020B0704020202020204" pitchFamily="34" charset="0"/>
         <a:buChar char="•"/>
         <a:defRPr sz="2000" kern="1200">
           <a:solidFill>
@@ -1363,7 +1208,7 @@
         <a:spcBef>
           <a:spcPct val="20000"/>
         </a:spcBef>
-        <a:buFont typeface="Arial" pitchFamily="34" charset="0"/>
+        <a:buFont typeface="Arial" panose="020B0704020202020204" pitchFamily="34" charset="0"/>
         <a:buChar char="•"/>
         <a:defRPr sz="2000" kern="1200">
           <a:solidFill>
@@ -1476,7 +1321,7 @@
 
 <file path=ppt/slides/slide1.xml><?xml version="1.0" encoding="utf-8"?>
 <p:sld xmlns:a="http://schemas.openxmlformats.org/drawingml/2006/main" xmlns:r="http://schemas.openxmlformats.org/officeDocument/2006/relationships" xmlns:p="http://schemas.openxmlformats.org/presentationml/2006/main">
-  <p:cSld name="Slide 1">
+  <p:cSld>
     <p:spTree>
       <p:nvGrpSpPr>
         <p:cNvPr id="1" name=""/>
@@ -1506,13 +1351,12 @@
             <a:avLst/>
           </a:prstGeom>
           <a:noFill/>
-          <a:ln/>
         </p:spPr>
         <p:txBody>
           <a:bodyPr wrap="square" rtlCol="0" anchor="ctr"/>
           <a:lstStyle/>
           <a:p>
-            <a:pPr indent="0" marL="0">
+            <a:pPr marL="0" indent="0">
               <a:buNone/>
             </a:pPr>
             <a:r>
@@ -1520,9 +1364,9 @@
                 <a:solidFill>
                   <a:srgbClr val="1A1A1A"/>
                 </a:solidFill>
-                <a:latin typeface="Microsoft YaHei" pitchFamily="34" charset="0"/>
-                <a:ea typeface="Microsoft YaHei" pitchFamily="34" charset="-122"/>
-                <a:cs typeface="Microsoft YaHei" pitchFamily="34" charset="-120"/>
+                <a:latin typeface="微软雅黑" pitchFamily="34" charset="0"/>
+                <a:ea typeface="微软雅黑" pitchFamily="34" charset="-122"/>
+                <a:cs typeface="微软雅黑" pitchFamily="34" charset="-120"/>
               </a:rPr>
               <a:t>肺内 IL18 转录（pro-IL-18）的细胞类型谱</a:t>
             </a:r>
@@ -1545,13 +1389,12 @@
             <a:avLst/>
           </a:prstGeom>
           <a:noFill/>
-          <a:ln/>
         </p:spPr>
         <p:txBody>
           <a:bodyPr wrap="square" rtlCol="0" anchor="ctr"/>
           <a:lstStyle/>
           <a:p>
-            <a:pPr indent="0" marL="0">
+            <a:pPr marL="0" indent="0">
               <a:buNone/>
             </a:pPr>
             <a:r>
@@ -1559,9 +1402,9 @@
                 <a:solidFill>
                   <a:srgbClr val="6B6B6B"/>
                 </a:solidFill>
-                <a:latin typeface="Microsoft YaHei" pitchFamily="34" charset="0"/>
-                <a:ea typeface="Microsoft YaHei" pitchFamily="34" charset="-122"/>
-                <a:cs typeface="Microsoft YaHei" pitchFamily="34" charset="-120"/>
+                <a:latin typeface="微软雅黑" pitchFamily="34" charset="0"/>
+                <a:ea typeface="微软雅黑" pitchFamily="34" charset="-122"/>
+                <a:cs typeface="微软雅黑" pitchFamily="34" charset="-120"/>
               </a:rPr>
               <a:t>人与小鼠 · 静息与病原感染 · 单细胞转录组，并以分选 bulk（DICE、ImmGen）交叉验证零值</a:t>
             </a:r>
@@ -1584,13 +1427,12 @@
             <a:avLst/>
           </a:prstGeom>
           <a:noFill/>
-          <a:ln/>
         </p:spPr>
         <p:txBody>
           <a:bodyPr wrap="square" rtlCol="0" anchor="ctr"/>
           <a:lstStyle/>
           <a:p>
-            <a:pPr indent="0" marL="0">
+            <a:pPr marL="0" indent="0">
               <a:lnSpc>
                 <a:spcPct val="125000"/>
               </a:lnSpc>
@@ -1601,26 +1443,20 @@
                 <a:solidFill>
                   <a:srgbClr val="1A1A1A"/>
                 </a:solidFill>
-                <a:latin typeface="Microsoft YaHei" pitchFamily="34" charset="0"/>
-                <a:ea typeface="Microsoft YaHei" pitchFamily="34" charset="-122"/>
-                <a:cs typeface="Microsoft YaHei" pitchFamily="34" charset="-120"/>
+                <a:latin typeface="微软雅黑" pitchFamily="34" charset="0"/>
+                <a:ea typeface="微软雅黑" pitchFamily="34" charset="-122"/>
+                <a:cs typeface="微软雅黑" pitchFamily="34" charset="-120"/>
               </a:rPr>
               <a:t>测量对象：IL18 转录本，即 pro-IL-18 的转录信号。</a:t>
             </a:r>
-            <a:pPr indent="0" marL="0">
-              <a:lnSpc>
-                <a:spcPct val="125000"/>
-              </a:lnSpc>
-              <a:buNone/>
-            </a:pPr>
             <a:r>
               <a:rPr lang="en-US" sz="1300" dirty="0">
                 <a:solidFill>
                   <a:srgbClr val="1A1A1A"/>
                 </a:solidFill>
-                <a:latin typeface="Microsoft YaHei" pitchFamily="34" charset="0"/>
-                <a:ea typeface="Microsoft YaHei" pitchFamily="34" charset="-122"/>
-                <a:cs typeface="Microsoft YaHei" pitchFamily="34" charset="-120"/>
+                <a:latin typeface="微软雅黑" pitchFamily="34" charset="0"/>
+                <a:ea typeface="微软雅黑" pitchFamily="34" charset="-122"/>
+                <a:cs typeface="微软雅黑" pitchFamily="34" charset="-120"/>
               </a:rPr>
               <a:t>成熟 IL-18 由 caspase 切割前体产生，pro/成熟之分属蛋白层面，转录层面无法区分。本分析为转录本丰度，不等价于前体蛋白储量。</a:t>
             </a:r>
@@ -1643,13 +1479,12 @@
             <a:avLst/>
           </a:prstGeom>
           <a:noFill/>
-          <a:ln/>
         </p:spPr>
         <p:txBody>
           <a:bodyPr wrap="square" rtlCol="0" anchor="ctr"/>
           <a:lstStyle/>
           <a:p>
-            <a:pPr indent="0" marL="0">
+            <a:pPr marL="0" indent="0">
               <a:buNone/>
             </a:pPr>
             <a:r>
@@ -1657,9 +1492,9 @@
                 <a:solidFill>
                   <a:srgbClr val="9AA0A6"/>
                 </a:solidFill>
-                <a:latin typeface="Microsoft YaHei" pitchFamily="34" charset="0"/>
-                <a:ea typeface="Microsoft YaHei" pitchFamily="34" charset="-122"/>
-                <a:cs typeface="Microsoft YaHei" pitchFamily="34" charset="-120"/>
+                <a:latin typeface="微软雅黑" pitchFamily="34" charset="0"/>
+                <a:ea typeface="微软雅黑" pitchFamily="34" charset="-122"/>
+                <a:cs typeface="微软雅黑" pitchFamily="34" charset="-120"/>
               </a:rPr>
               <a:t>24 个单细胞数据集（人 17 · 小鼠 7） · CELLxGENE Census LTS 2025-11-08 · 以供体为统计单位</a:t>
             </a:r>
@@ -1677,7 +1512,7 @@
 
 <file path=ppt/slides/slide2.xml><?xml version="1.0" encoding="utf-8"?>
 <p:sld xmlns:a="http://schemas.openxmlformats.org/drawingml/2006/main" xmlns:r="http://schemas.openxmlformats.org/officeDocument/2006/relationships" xmlns:p="http://schemas.openxmlformats.org/presentationml/2006/main">
-  <p:cSld name="Slide 2">
+  <p:cSld>
     <p:spTree>
       <p:nvGrpSpPr>
         <p:cNvPr id="1" name=""/>
@@ -1707,13 +1542,12 @@
             <a:avLst/>
           </a:prstGeom>
           <a:noFill/>
-          <a:ln/>
         </p:spPr>
         <p:txBody>
           <a:bodyPr wrap="square" rtlCol="0" anchor="ctr"/>
           <a:lstStyle/>
           <a:p>
-            <a:pPr indent="0" marL="0">
+            <a:pPr marL="0" indent="0">
               <a:buNone/>
             </a:pPr>
             <a:r>
@@ -1721,9 +1555,9 @@
                 <a:solidFill>
                   <a:srgbClr val="1A1A1A"/>
                 </a:solidFill>
-                <a:latin typeface="Microsoft YaHei" pitchFamily="34" charset="0"/>
-                <a:ea typeface="Microsoft YaHei" pitchFamily="34" charset="-122"/>
-                <a:cs typeface="Microsoft YaHei" pitchFamily="34" charset="-120"/>
+                <a:latin typeface="微软雅黑" pitchFamily="34" charset="0"/>
+                <a:ea typeface="微软雅黑" pitchFamily="34" charset="-122"/>
+                <a:cs typeface="微软雅黑" pitchFamily="34" charset="-120"/>
               </a:rPr>
               <a:t>结论：哪些细胞转录 IL18</a:t>
             </a:r>
@@ -1746,13 +1580,12 @@
             <a:avLst/>
           </a:prstGeom>
           <a:noFill/>
-          <a:ln/>
         </p:spPr>
         <p:txBody>
           <a:bodyPr wrap="square" rtlCol="0" anchor="t"/>
           <a:lstStyle/>
           <a:p>
-            <a:pPr indent="0" marL="0">
+            <a:pPr marL="0" indent="0">
               <a:buNone/>
             </a:pPr>
             <a:r>
@@ -1760,9 +1593,9 @@
                 <a:solidFill>
                   <a:srgbClr val="1A1A1A"/>
                 </a:solidFill>
-                <a:latin typeface="Microsoft YaHei" pitchFamily="34" charset="0"/>
-                <a:ea typeface="Microsoft YaHei" pitchFamily="34" charset="-122"/>
-                <a:cs typeface="Microsoft YaHei" pitchFamily="34" charset="-120"/>
+                <a:latin typeface="微软雅黑" pitchFamily="34" charset="0"/>
+                <a:ea typeface="微软雅黑" pitchFamily="34" charset="-122"/>
+                <a:cs typeface="微软雅黑" pitchFamily="34" charset="-120"/>
               </a:rPr>
               <a:t>髓系是主要来源</a:t>
             </a:r>
@@ -1785,13 +1618,12 @@
             <a:avLst/>
           </a:prstGeom>
           <a:noFill/>
-          <a:ln/>
         </p:spPr>
         <p:txBody>
           <a:bodyPr wrap="square" rtlCol="0" anchor="t"/>
           <a:lstStyle/>
           <a:p>
-            <a:pPr indent="0" marL="0">
+            <a:pPr marL="0" indent="0">
               <a:lnSpc>
                 <a:spcPct val="120000"/>
               </a:lnSpc>
@@ -1802,9 +1634,9 @@
                 <a:solidFill>
                   <a:srgbClr val="1A1A1A"/>
                 </a:solidFill>
-                <a:latin typeface="Microsoft YaHei" pitchFamily="34" charset="0"/>
-                <a:ea typeface="Microsoft YaHei" pitchFamily="34" charset="-122"/>
-                <a:cs typeface="Microsoft YaHei" pitchFamily="34" charset="-120"/>
+                <a:latin typeface="微软雅黑" pitchFamily="34" charset="0"/>
+                <a:ea typeface="微软雅黑" pitchFamily="34" charset="-122"/>
+                <a:cs typeface="微软雅黑" pitchFamily="34" charset="-120"/>
               </a:rPr>
               <a:t>树突状细胞、肺泡巨噬细胞、单核来源巨噬细胞在几乎所有数据集排名最前。小鼠肺泡巨噬细胞阳性率常 &gt;90%。静息与感染条件下一致。</a:t>
             </a:r>
@@ -1827,13 +1659,12 @@
             <a:avLst/>
           </a:prstGeom>
           <a:noFill/>
-          <a:ln/>
         </p:spPr>
         <p:txBody>
           <a:bodyPr wrap="square" rtlCol="0" anchor="t"/>
           <a:lstStyle/>
           <a:p>
-            <a:pPr indent="0" marL="0">
+            <a:pPr marL="0" indent="0">
               <a:buNone/>
             </a:pPr>
             <a:r>
@@ -1841,9 +1672,9 @@
                 <a:solidFill>
                   <a:srgbClr val="1A1A1A"/>
                 </a:solidFill>
-                <a:latin typeface="Microsoft YaHei" pitchFamily="34" charset="0"/>
-                <a:ea typeface="Microsoft YaHei" pitchFamily="34" charset="-122"/>
-                <a:cs typeface="Microsoft YaHei" pitchFamily="34" charset="-120"/>
+                <a:latin typeface="微软雅黑" pitchFamily="34" charset="0"/>
+                <a:ea typeface="微软雅黑" pitchFamily="34" charset="-122"/>
+                <a:cs typeface="微软雅黑" pitchFamily="34" charset="-120"/>
               </a:rPr>
               <a:t>上皮确有转录</a:t>
             </a:r>
@@ -1866,13 +1697,12 @@
             <a:avLst/>
           </a:prstGeom>
           <a:noFill/>
-          <a:ln/>
         </p:spPr>
         <p:txBody>
           <a:bodyPr wrap="square" rtlCol="0" anchor="t"/>
           <a:lstStyle/>
           <a:p>
-            <a:pPr indent="0" marL="0">
+            <a:pPr marL="0" indent="0">
               <a:lnSpc>
                 <a:spcPct val="120000"/>
               </a:lnSpc>
@@ -1883,9 +1713,9 @@
                 <a:solidFill>
                   <a:srgbClr val="1A1A1A"/>
                 </a:solidFill>
-                <a:latin typeface="Microsoft YaHei" pitchFamily="34" charset="0"/>
-                <a:ea typeface="Microsoft YaHei" pitchFamily="34" charset="-122"/>
-                <a:cs typeface="Microsoft YaHei" pitchFamily="34" charset="-120"/>
+                <a:latin typeface="微软雅黑" pitchFamily="34" charset="0"/>
+                <a:ea typeface="微软雅黑" pitchFamily="34" charset="-122"/>
+                <a:cs typeface="微软雅黑" pitchFamily="34" charset="-120"/>
               </a:rPr>
               <a:t>经环境 RNA 校正的 Tabula Sapiens 中 AT1 排名第一、气道上皮居前；校正几乎不改变上皮信号却清除内皮/淋巴信号，说明上皮 IL18 并非污染所致。</a:t>
             </a:r>
@@ -1908,13 +1738,12 @@
             <a:avLst/>
           </a:prstGeom>
           <a:noFill/>
-          <a:ln/>
         </p:spPr>
         <p:txBody>
           <a:bodyPr wrap="square" rtlCol="0" anchor="t"/>
           <a:lstStyle/>
           <a:p>
-            <a:pPr indent="0" marL="0">
+            <a:pPr marL="0" indent="0">
               <a:buNone/>
             </a:pPr>
             <a:r>
@@ -1922,9 +1751,9 @@
                 <a:solidFill>
                   <a:srgbClr val="1A1A1A"/>
                 </a:solidFill>
-                <a:latin typeface="Microsoft YaHei" pitchFamily="34" charset="0"/>
-                <a:ea typeface="Microsoft YaHei" pitchFamily="34" charset="-122"/>
-                <a:cs typeface="Microsoft YaHei" pitchFamily="34" charset="-120"/>
+                <a:latin typeface="微软雅黑" pitchFamily="34" charset="0"/>
+                <a:ea typeface="微软雅黑" pitchFamily="34" charset="-122"/>
+                <a:cs typeface="微软雅黑" pitchFamily="34" charset="-120"/>
               </a:rPr>
               <a:t>淋巴 · 内皮 · 成纤维接近零</a:t>
             </a:r>
@@ -1947,13 +1776,12 @@
             <a:avLst/>
           </a:prstGeom>
           <a:noFill/>
-          <a:ln/>
         </p:spPr>
         <p:txBody>
           <a:bodyPr wrap="square" rtlCol="0" anchor="t"/>
           <a:lstStyle/>
           <a:p>
-            <a:pPr indent="0" marL="0">
+            <a:pPr marL="0" indent="0">
               <a:lnSpc>
                 <a:spcPct val="120000"/>
               </a:lnSpc>
@@ -1964,9 +1792,9 @@
                 <a:solidFill>
                   <a:srgbClr val="1A1A1A"/>
                 </a:solidFill>
-                <a:latin typeface="Microsoft YaHei" pitchFamily="34" charset="0"/>
-                <a:ea typeface="Microsoft YaHei" pitchFamily="34" charset="-122"/>
-                <a:cs typeface="Microsoft YaHei" pitchFamily="34" charset="-120"/>
+                <a:latin typeface="微软雅黑" pitchFamily="34" charset="0"/>
+                <a:ea typeface="微软雅黑" pitchFamily="34" charset="-122"/>
+                <a:cs typeface="微软雅黑" pitchFamily="34" charset="-120"/>
               </a:rPr>
               <a:t>T/NK、B/浆细胞、内皮、成纤维阳性比例多 ≤5%。DICE（人）与 ImmGen（鼠）分选 bulk 证实 T/NK/B 的零为真零，非 dropout。</a:t>
             </a:r>
@@ -1989,13 +1817,12 @@
             <a:avLst/>
           </a:prstGeom>
           <a:noFill/>
-          <a:ln/>
         </p:spPr>
         <p:txBody>
           <a:bodyPr wrap="square" rtlCol="0" anchor="t"/>
           <a:lstStyle/>
           <a:p>
-            <a:pPr indent="0" marL="0">
+            <a:pPr marL="0" indent="0">
               <a:buNone/>
             </a:pPr>
             <a:r>
@@ -2003,9 +1830,9 @@
                 <a:solidFill>
                   <a:srgbClr val="1A1A1A"/>
                 </a:solidFill>
-                <a:latin typeface="Microsoft YaHei" pitchFamily="34" charset="0"/>
-                <a:ea typeface="Microsoft YaHei" pitchFamily="34" charset="-122"/>
-                <a:cs typeface="Microsoft YaHei" pitchFamily="34" charset="-120"/>
+                <a:latin typeface="微软雅黑" pitchFamily="34" charset="0"/>
+                <a:ea typeface="微软雅黑" pitchFamily="34" charset="-122"/>
+                <a:cs typeface="微软雅黑" pitchFamily="34" charset="-120"/>
               </a:rPr>
               <a:t>感染不改变表达谱</a:t>
             </a:r>
@@ -2028,13 +1855,12 @@
             <a:avLst/>
           </a:prstGeom>
           <a:noFill/>
-          <a:ln/>
         </p:spPr>
         <p:txBody>
           <a:bodyPr wrap="square" rtlCol="0" anchor="t"/>
           <a:lstStyle/>
           <a:p>
-            <a:pPr indent="0" marL="0">
+            <a:pPr marL="0" indent="0">
               <a:lnSpc>
                 <a:spcPct val="120000"/>
               </a:lnSpc>
@@ -2045,9 +1871,9 @@
                 <a:solidFill>
                   <a:srgbClr val="1A1A1A"/>
                 </a:solidFill>
-                <a:latin typeface="Microsoft YaHei" pitchFamily="34" charset="0"/>
-                <a:ea typeface="Microsoft YaHei" pitchFamily="34" charset="-122"/>
-                <a:cs typeface="Microsoft YaHei" pitchFamily="34" charset="-120"/>
+                <a:latin typeface="微软雅黑" pitchFamily="34" charset="0"/>
+                <a:ea typeface="微软雅黑" pitchFamily="34" charset="-122"/>
+                <a:cs typeface="微软雅黑" pitchFamily="34" charset="-120"/>
               </a:rPr>
               <a:t>SARS-CoV-2、流感、细菌、LPS 下主要来源仍是髓系；研究内比较显示感染主要改变各群细胞数量，而非“哪些细胞转录 IL18”。</a:t>
             </a:r>
@@ -2065,7 +1891,7 @@
 
 <file path=ppt/slides/slide3.xml><?xml version="1.0" encoding="utf-8"?>
 <p:sld xmlns:a="http://schemas.openxmlformats.org/drawingml/2006/main" xmlns:r="http://schemas.openxmlformats.org/officeDocument/2006/relationships" xmlns:p="http://schemas.openxmlformats.org/presentationml/2006/main">
-  <p:cSld name="Slide 3">
+  <p:cSld>
     <p:spTree>
       <p:nvGrpSpPr>
         <p:cNvPr id="1" name=""/>
@@ -2095,13 +1921,12 @@
             <a:avLst/>
           </a:prstGeom>
           <a:noFill/>
-          <a:ln/>
         </p:spPr>
         <p:txBody>
           <a:bodyPr wrap="square" rtlCol="0" anchor="ctr"/>
           <a:lstStyle/>
           <a:p>
-            <a:pPr indent="0" marL="0">
+            <a:pPr marL="0" indent="0">
               <a:buNone/>
             </a:pPr>
             <a:r>
@@ -2109,9 +1934,9 @@
                 <a:solidFill>
                   <a:srgbClr val="1A1A1A"/>
                 </a:solidFill>
-                <a:latin typeface="Microsoft YaHei" pitchFamily="34" charset="0"/>
-                <a:ea typeface="Microsoft YaHei" pitchFamily="34" charset="-122"/>
-                <a:cs typeface="Microsoft YaHei" pitchFamily="34" charset="-120"/>
+                <a:latin typeface="微软雅黑" pitchFamily="34" charset="0"/>
+                <a:ea typeface="微软雅黑" pitchFamily="34" charset="-122"/>
+                <a:cs typeface="微软雅黑" pitchFamily="34" charset="-120"/>
               </a:rPr>
               <a:t>数据、方法与来源</a:t>
             </a:r>
@@ -2134,13 +1959,12 @@
             <a:avLst/>
           </a:prstGeom>
           <a:noFill/>
-          <a:ln/>
         </p:spPr>
         <p:txBody>
           <a:bodyPr wrap="square" rtlCol="0" anchor="t"/>
           <a:lstStyle/>
           <a:p>
-            <a:pPr indent="0" marL="0">
+            <a:pPr marL="0" indent="0">
               <a:buNone/>
             </a:pPr>
             <a:r>
@@ -2148,9 +1972,9 @@
                 <a:solidFill>
                   <a:srgbClr val="1A1A1A"/>
                 </a:solidFill>
-                <a:latin typeface="Microsoft YaHei" pitchFamily="34" charset="0"/>
-                <a:ea typeface="Microsoft YaHei" pitchFamily="34" charset="-122"/>
-                <a:cs typeface="Microsoft YaHei" pitchFamily="34" charset="-120"/>
+                <a:latin typeface="微软雅黑" pitchFamily="34" charset="0"/>
+                <a:ea typeface="微软雅黑" pitchFamily="34" charset="-122"/>
+                <a:cs typeface="微软雅黑" pitchFamily="34" charset="-120"/>
               </a:rPr>
               <a:t>物种</a:t>
             </a:r>
@@ -2173,13 +1997,12 @@
             <a:avLst/>
           </a:prstGeom>
           <a:noFill/>
-          <a:ln/>
         </p:spPr>
         <p:txBody>
           <a:bodyPr wrap="square" rtlCol="0" anchor="t"/>
           <a:lstStyle/>
           <a:p>
-            <a:pPr indent="0" marL="0">
+            <a:pPr marL="0" indent="0">
               <a:buNone/>
             </a:pPr>
             <a:r>
@@ -2187,9 +2010,9 @@
                 <a:solidFill>
                   <a:srgbClr val="1A1A1A"/>
                 </a:solidFill>
-                <a:latin typeface="Microsoft YaHei" pitchFamily="34" charset="0"/>
-                <a:ea typeface="Microsoft YaHei" pitchFamily="34" charset="-122"/>
-                <a:cs typeface="Microsoft YaHei" pitchFamily="34" charset="-120"/>
+                <a:latin typeface="微软雅黑" pitchFamily="34" charset="0"/>
+                <a:ea typeface="微软雅黑" pitchFamily="34" charset="-122"/>
+                <a:cs typeface="微软雅黑" pitchFamily="34" charset="-120"/>
               </a:rPr>
               <a:t>人、小鼠全程分开，表与图均不合并</a:t>
             </a:r>
@@ -2212,13 +2035,12 @@
             <a:avLst/>
           </a:prstGeom>
           <a:noFill/>
-          <a:ln/>
         </p:spPr>
         <p:txBody>
           <a:bodyPr wrap="square" rtlCol="0" anchor="t"/>
           <a:lstStyle/>
           <a:p>
-            <a:pPr indent="0" marL="0">
+            <a:pPr marL="0" indent="0">
               <a:buNone/>
             </a:pPr>
             <a:r>
@@ -2226,9 +2048,9 @@
                 <a:solidFill>
                   <a:srgbClr val="1A1A1A"/>
                 </a:solidFill>
-                <a:latin typeface="Microsoft YaHei" pitchFamily="34" charset="0"/>
-                <a:ea typeface="Microsoft YaHei" pitchFamily="34" charset="-122"/>
-                <a:cs typeface="Microsoft YaHei" pitchFamily="34" charset="-120"/>
+                <a:latin typeface="微软雅黑" pitchFamily="34" charset="0"/>
+                <a:ea typeface="微软雅黑" pitchFamily="34" charset="-122"/>
+                <a:cs typeface="微软雅黑" pitchFamily="34" charset="-120"/>
               </a:rPr>
               <a:t>基因</a:t>
             </a:r>
@@ -2251,13 +2073,12 @@
             <a:avLst/>
           </a:prstGeom>
           <a:noFill/>
-          <a:ln/>
         </p:spPr>
         <p:txBody>
           <a:bodyPr wrap="square" rtlCol="0" anchor="t"/>
           <a:lstStyle/>
           <a:p>
-            <a:pPr indent="0" marL="0">
+            <a:pPr marL="0" indent="0">
               <a:buNone/>
             </a:pPr>
             <a:r>
@@ -2265,9 +2086,9 @@
                 <a:solidFill>
                   <a:srgbClr val="1A1A1A"/>
                 </a:solidFill>
-                <a:latin typeface="Microsoft YaHei" pitchFamily="34" charset="0"/>
-                <a:ea typeface="Microsoft YaHei" pitchFamily="34" charset="-122"/>
-                <a:cs typeface="Microsoft YaHei" pitchFamily="34" charset="-120"/>
+                <a:latin typeface="微软雅黑" pitchFamily="34" charset="0"/>
+                <a:ea typeface="微软雅黑" pitchFamily="34" charset="-122"/>
+                <a:cs typeface="微软雅黑" pitchFamily="34" charset="-120"/>
               </a:rPr>
               <a:t>以 Ensembl ID 取：人 ENSG00000150782 / 鼠 ENSMUSG00000039217</a:t>
             </a:r>
@@ -2290,13 +2111,12 @@
             <a:avLst/>
           </a:prstGeom>
           <a:noFill/>
-          <a:ln/>
         </p:spPr>
         <p:txBody>
           <a:bodyPr wrap="square" rtlCol="0" anchor="t"/>
           <a:lstStyle/>
           <a:p>
-            <a:pPr indent="0" marL="0">
+            <a:pPr marL="0" indent="0">
               <a:buNone/>
             </a:pPr>
             <a:r>
@@ -2304,9 +2124,9 @@
                 <a:solidFill>
                   <a:srgbClr val="1A1A1A"/>
                 </a:solidFill>
-                <a:latin typeface="Microsoft YaHei" pitchFamily="34" charset="0"/>
-                <a:ea typeface="Microsoft YaHei" pitchFamily="34" charset="-122"/>
-                <a:cs typeface="Microsoft YaHei" pitchFamily="34" charset="-120"/>
+                <a:latin typeface="微软雅黑" pitchFamily="34" charset="0"/>
+                <a:ea typeface="微软雅黑" pitchFamily="34" charset="-122"/>
+                <a:cs typeface="微软雅黑" pitchFamily="34" charset="-120"/>
               </a:rPr>
               <a:t>细胞类型</a:t>
             </a:r>
@@ -2329,13 +2149,12 @@
             <a:avLst/>
           </a:prstGeom>
           <a:noFill/>
-          <a:ln/>
         </p:spPr>
         <p:txBody>
           <a:bodyPr wrap="square" rtlCol="0" anchor="t"/>
           <a:lstStyle/>
           <a:p>
-            <a:pPr indent="0" marL="0">
+            <a:pPr marL="0" indent="0">
               <a:buNone/>
             </a:pPr>
             <a:r>
@@ -2343,9 +2162,9 @@
                 <a:solidFill>
                   <a:srgbClr val="1A1A1A"/>
                 </a:solidFill>
-                <a:latin typeface="Microsoft YaHei" pitchFamily="34" charset="0"/>
-                <a:ea typeface="Microsoft YaHei" pitchFamily="34" charset="-122"/>
-                <a:cs typeface="Microsoft YaHei" pitchFamily="34" charset="-120"/>
+                <a:latin typeface="微软雅黑" pitchFamily="34" charset="0"/>
+                <a:ea typeface="微软雅黑" pitchFamily="34" charset="-122"/>
+                <a:cs typeface="微软雅黑" pitchFamily="34" charset="-120"/>
               </a:rPr>
               <a:t>统一为 11 类；用作者注释，不重新聚类（小鼠 LPS 两套无作者注释，自行注释）</a:t>
             </a:r>
@@ -2368,13 +2187,12 @@
             <a:avLst/>
           </a:prstGeom>
           <a:noFill/>
-          <a:ln/>
         </p:spPr>
         <p:txBody>
           <a:bodyPr wrap="square" rtlCol="0" anchor="t"/>
           <a:lstStyle/>
           <a:p>
-            <a:pPr indent="0" marL="0">
+            <a:pPr marL="0" indent="0">
               <a:buNone/>
             </a:pPr>
             <a:r>
@@ -2382,9 +2200,9 @@
                 <a:solidFill>
                   <a:srgbClr val="1A1A1A"/>
                 </a:solidFill>
-                <a:latin typeface="Microsoft YaHei" pitchFamily="34" charset="0"/>
-                <a:ea typeface="Microsoft YaHei" pitchFamily="34" charset="-122"/>
-                <a:cs typeface="Microsoft YaHei" pitchFamily="34" charset="-120"/>
+                <a:latin typeface="微软雅黑" pitchFamily="34" charset="0"/>
+                <a:ea typeface="微软雅黑" pitchFamily="34" charset="-122"/>
+                <a:cs typeface="微软雅黑" pitchFamily="34" charset="-120"/>
               </a:rPr>
               <a:t>统计</a:t>
             </a:r>
@@ -2407,13 +2225,12 @@
             <a:avLst/>
           </a:prstGeom>
           <a:noFill/>
-          <a:ln/>
         </p:spPr>
         <p:txBody>
           <a:bodyPr wrap="square" rtlCol="0" anchor="t"/>
           <a:lstStyle/>
           <a:p>
-            <a:pPr indent="0" marL="0">
+            <a:pPr marL="0" indent="0">
               <a:buNone/>
             </a:pPr>
             <a:r>
@@ -2421,9 +2238,9 @@
                 <a:solidFill>
                   <a:srgbClr val="1A1A1A"/>
                 </a:solidFill>
-                <a:latin typeface="Microsoft YaHei" pitchFamily="34" charset="0"/>
-                <a:ea typeface="Microsoft YaHei" pitchFamily="34" charset="-122"/>
-                <a:cs typeface="Microsoft YaHei" pitchFamily="34" charset="-120"/>
+                <a:latin typeface="微软雅黑" pitchFamily="34" charset="0"/>
+                <a:ea typeface="微软雅黑" pitchFamily="34" charset="-122"/>
+                <a:cs typeface="微软雅黑" pitchFamily="34" charset="-120"/>
               </a:rPr>
               <a:t>以供体为单位；n_cells&lt;20 置 NA，n_donors&lt;3 仅描述统计；跨数据集只比数据集内排序</a:t>
             </a:r>
@@ -2446,13 +2263,12 @@
             <a:avLst/>
           </a:prstGeom>
           <a:noFill/>
-          <a:ln/>
         </p:spPr>
         <p:txBody>
           <a:bodyPr wrap="square" rtlCol="0" anchor="t"/>
           <a:lstStyle/>
           <a:p>
-            <a:pPr indent="0" marL="0">
+            <a:pPr marL="0" indent="0">
               <a:buNone/>
             </a:pPr>
             <a:r>
@@ -2460,9 +2276,9 @@
                 <a:solidFill>
                   <a:srgbClr val="1A1A1A"/>
                 </a:solidFill>
-                <a:latin typeface="Microsoft YaHei" pitchFamily="34" charset="0"/>
-                <a:ea typeface="Microsoft YaHei" pitchFamily="34" charset="-122"/>
-                <a:cs typeface="Microsoft YaHei" pitchFamily="34" charset="-120"/>
+                <a:latin typeface="微软雅黑" pitchFamily="34" charset="0"/>
+                <a:ea typeface="微软雅黑" pitchFamily="34" charset="-122"/>
+                <a:cs typeface="微软雅黑" pitchFamily="34" charset="-120"/>
               </a:rPr>
               <a:t>环境 RNA</a:t>
             </a:r>
@@ -2485,13 +2301,12 @@
             <a:avLst/>
           </a:prstGeom>
           <a:noFill/>
-          <a:ln/>
         </p:spPr>
         <p:txBody>
           <a:bodyPr wrap="square" rtlCol="0" anchor="t"/>
           <a:lstStyle/>
           <a:p>
-            <a:pPr indent="0" marL="0">
+            <a:pPr marL="0" indent="0">
               <a:buNone/>
             </a:pPr>
             <a:r>
@@ -2499,9 +2314,9 @@
                 <a:solidFill>
                   <a:srgbClr val="1A1A1A"/>
                 </a:solidFill>
-                <a:latin typeface="Microsoft YaHei" pitchFamily="34" charset="0"/>
-                <a:ea typeface="Microsoft YaHei" pitchFamily="34" charset="-122"/>
-                <a:cs typeface="Microsoft YaHei" pitchFamily="34" charset="-120"/>
+                <a:latin typeface="微软雅黑" pitchFamily="34" charset="0"/>
+                <a:ea typeface="微软雅黑" pitchFamily="34" charset="-122"/>
+                <a:cs typeface="微软雅黑" pitchFamily="34" charset="-120"/>
               </a:rPr>
               <a:t>无法校正的 10x 数据其上皮结果不进结论；Tabula Sapiens 用作者 decontX</a:t>
             </a:r>
@@ -2547,13 +2362,12 @@
             <a:avLst/>
           </a:prstGeom>
           <a:noFill/>
-          <a:ln/>
         </p:spPr>
         <p:txBody>
           <a:bodyPr wrap="square" rtlCol="0" anchor="ctr"/>
           <a:lstStyle/>
           <a:p>
-            <a:pPr indent="0" marL="0">
+            <a:pPr marL="0" indent="0">
               <a:buNone/>
             </a:pPr>
             <a:r>
@@ -2561,9 +2375,9 @@
                 <a:solidFill>
                   <a:srgbClr val="1A1A1A"/>
                 </a:solidFill>
-                <a:latin typeface="Microsoft YaHei" pitchFamily="34" charset="0"/>
-                <a:ea typeface="Microsoft YaHei" pitchFamily="34" charset="-122"/>
-                <a:cs typeface="Microsoft YaHei" pitchFamily="34" charset="-120"/>
+                <a:latin typeface="微软雅黑" pitchFamily="34" charset="0"/>
+                <a:ea typeface="微软雅黑" pitchFamily="34" charset="-122"/>
+                <a:cs typeface="微软雅黑" pitchFamily="34" charset="-120"/>
               </a:rPr>
               <a:t>数据库来源</a:t>
             </a:r>
@@ -2586,13 +2400,12 @@
             <a:avLst/>
           </a:prstGeom>
           <a:noFill/>
-          <a:ln/>
         </p:spPr>
         <p:txBody>
           <a:bodyPr wrap="square" rtlCol="0" anchor="t"/>
           <a:lstStyle/>
           <a:p>
-            <a:pPr indent="0" marL="0">
+            <a:pPr marL="0" indent="0">
               <a:buNone/>
             </a:pPr>
             <a:r>
@@ -2600,9 +2413,9 @@
                 <a:solidFill>
                   <a:srgbClr val="6B6B6B"/>
                 </a:solidFill>
-                <a:latin typeface="Microsoft YaHei" pitchFamily="34" charset="0"/>
-                <a:ea typeface="Microsoft YaHei" pitchFamily="34" charset="-122"/>
-                <a:cs typeface="Microsoft YaHei" pitchFamily="34" charset="-120"/>
+                <a:latin typeface="微软雅黑" pitchFamily="34" charset="0"/>
+                <a:ea typeface="微软雅黑" pitchFamily="34" charset="-122"/>
+                <a:cs typeface="微软雅黑" pitchFamily="34" charset="-120"/>
               </a:rPr>
               <a:t>CZ CELLxGENE Census（主入口，人/小鼠肺）</a:t>
             </a:r>
@@ -2625,13 +2438,12 @@
             <a:avLst/>
           </a:prstGeom>
           <a:noFill/>
-          <a:ln/>
         </p:spPr>
         <p:txBody>
           <a:bodyPr wrap="square" rtlCol="0" anchor="t"/>
           <a:lstStyle/>
           <a:p>
-            <a:pPr indent="0" marL="0">
+            <a:pPr marL="0" indent="0">
               <a:buNone/>
             </a:pPr>
             <a:r>
@@ -2639,9 +2451,9 @@
                 <a:solidFill>
                   <a:srgbClr val="6B6B6B"/>
                 </a:solidFill>
-                <a:latin typeface="Microsoft YaHei" pitchFamily="34" charset="0"/>
-                <a:ea typeface="Microsoft YaHei" pitchFamily="34" charset="-122"/>
-                <a:cs typeface="Microsoft YaHei" pitchFamily="34" charset="-120"/>
+                <a:latin typeface="微软雅黑" pitchFamily="34" charset="0"/>
+                <a:ea typeface="微软雅黑" pitchFamily="34" charset="-122"/>
+                <a:cs typeface="微软雅黑" pitchFamily="34" charset="-120"/>
               </a:rPr>
               <a:t>Human Lung Cell Atlas · Tabula Sapiens · Tabula Muris Senis · LungMAP/CellRef · Cross-tissue Immune · Travaglini</a:t>
             </a:r>
@@ -2664,13 +2476,12 @@
             <a:avLst/>
           </a:prstGeom>
           <a:noFill/>
-          <a:ln/>
         </p:spPr>
         <p:txBody>
           <a:bodyPr wrap="square" rtlCol="0" anchor="t"/>
           <a:lstStyle/>
           <a:p>
-            <a:pPr indent="0" marL="0">
+            <a:pPr marL="0" indent="0">
               <a:buNone/>
             </a:pPr>
             <a:r>
@@ -2678,9 +2489,9 @@
                 <a:solidFill>
                   <a:srgbClr val="6B6B6B"/>
                 </a:solidFill>
-                <a:latin typeface="Microsoft YaHei" pitchFamily="34" charset="0"/>
-                <a:ea typeface="Microsoft YaHei" pitchFamily="34" charset="-122"/>
-                <a:cs typeface="Microsoft YaHei" pitchFamily="34" charset="-120"/>
+                <a:latin typeface="微软雅黑" pitchFamily="34" charset="0"/>
+                <a:ea typeface="微软雅黑" pitchFamily="34" charset="-122"/>
+                <a:cs typeface="微软雅黑" pitchFamily="34" charset="-120"/>
               </a:rPr>
               <a:t>COVID-19 Cell Atlas：Melms / Delorey / Bharat 尸检 · Liao / Wauters / Grant BALF · Wu 离体肺</a:t>
             </a:r>
@@ -2703,13 +2514,12 @@
             <a:avLst/>
           </a:prstGeom>
           <a:noFill/>
-          <a:ln/>
         </p:spPr>
         <p:txBody>
           <a:bodyPr wrap="square" rtlCol="0" anchor="t"/>
           <a:lstStyle/>
           <a:p>
-            <a:pPr indent="0" marL="0">
+            <a:pPr marL="0" indent="0">
               <a:buNone/>
             </a:pPr>
             <a:r>
@@ -2717,9 +2527,9 @@
                 <a:solidFill>
                   <a:srgbClr val="6B6B6B"/>
                 </a:solidFill>
-                <a:latin typeface="Microsoft YaHei" pitchFamily="34" charset="0"/>
-                <a:ea typeface="Microsoft YaHei" pitchFamily="34" charset="-122"/>
-                <a:cs typeface="Microsoft YaHei" pitchFamily="34" charset="-120"/>
+                <a:latin typeface="微软雅黑" pitchFamily="34" charset="0"/>
+                <a:ea typeface="微软雅黑" pitchFamily="34" charset="-122"/>
+                <a:cs typeface="微软雅黑" pitchFamily="34" charset="-120"/>
               </a:rPr>
               <a:t>GEO 小鼠：S. pneumoniae GSE236342 · A. baumannii GSE313334 · LPS-ALI GSE280364 / GSE280611</a:t>
             </a:r>
@@ -2742,13 +2552,12 @@
             <a:avLst/>
           </a:prstGeom>
           <a:noFill/>
-          <a:ln/>
         </p:spPr>
         <p:txBody>
           <a:bodyPr wrap="square" rtlCol="0" anchor="t"/>
           <a:lstStyle/>
           <a:p>
-            <a:pPr indent="0" marL="0">
+            <a:pPr marL="0" indent="0">
               <a:buNone/>
             </a:pPr>
             <a:r>
@@ -2756,9 +2565,9 @@
                 <a:solidFill>
                   <a:srgbClr val="6B6B6B"/>
                 </a:solidFill>
-                <a:latin typeface="Microsoft YaHei" pitchFamily="34" charset="0"/>
-                <a:ea typeface="Microsoft YaHei" pitchFamily="34" charset="-122"/>
-                <a:cs typeface="Microsoft YaHei" pitchFamily="34" charset="-120"/>
+                <a:latin typeface="微软雅黑" pitchFamily="34" charset="0"/>
+                <a:ea typeface="微软雅黑" pitchFamily="34" charset="-122"/>
+                <a:cs typeface="微软雅黑" pitchFamily="34" charset="-120"/>
               </a:rPr>
               <a:t>零值参考（分选 bulk）：DICE（人）· ImmGen（鼠）</a:t>
             </a:r>
@@ -2776,7 +2585,7 @@
 
 <file path=ppt/slides/slide4.xml><?xml version="1.0" encoding="utf-8"?>
 <p:sld xmlns:a="http://schemas.openxmlformats.org/drawingml/2006/main" xmlns:r="http://schemas.openxmlformats.org/officeDocument/2006/relationships" xmlns:p="http://schemas.openxmlformats.org/presentationml/2006/main">
-  <p:cSld name="Slide 4">
+  <p:cSld>
     <p:spTree>
       <p:nvGrpSpPr>
         <p:cNvPr id="1" name=""/>
@@ -2806,13 +2615,12 @@
             <a:avLst/>
           </a:prstGeom>
           <a:noFill/>
-          <a:ln/>
         </p:spPr>
         <p:txBody>
           <a:bodyPr wrap="square" rtlCol="0" anchor="ctr"/>
           <a:lstStyle/>
           <a:p>
-            <a:pPr indent="0" marL="0">
+            <a:pPr marL="0" indent="0">
               <a:buNone/>
             </a:pPr>
             <a:r>
@@ -2820,9 +2628,9 @@
                 <a:solidFill>
                   <a:srgbClr val="1A1A1A"/>
                 </a:solidFill>
-                <a:latin typeface="Microsoft YaHei" pitchFamily="34" charset="0"/>
-                <a:ea typeface="Microsoft YaHei" pitchFamily="34" charset="-122"/>
-                <a:cs typeface="Microsoft YaHei" pitchFamily="34" charset="-120"/>
+                <a:latin typeface="微软雅黑" pitchFamily="34" charset="0"/>
+                <a:ea typeface="微软雅黑" pitchFamily="34" charset="-122"/>
+                <a:cs typeface="微软雅黑" pitchFamily="34" charset="-120"/>
               </a:rPr>
               <a:t>人 · 各单细胞数据集的 IL18 散点图</a:t>
             </a:r>
@@ -2832,7 +2640,7 @@
       </p:sp>
       <p:pic>
         <p:nvPicPr>
-          <p:cNvPr id="3" name="Image 0" descr="/home/user/aaa/il18_lung/figures/master_human.png">    </p:cNvPr>
+          <p:cNvPr id="3" name="Image 0" descr="/home/user/aaa/il18_lung/figures/master_human.png"/>
           <p:cNvPicPr>
             <a:picLocks noChangeAspect="1"/>
           </p:cNvPicPr>
@@ -2869,13 +2677,12 @@
             <a:avLst/>
           </a:prstGeom>
           <a:noFill/>
-          <a:ln/>
         </p:spPr>
         <p:txBody>
           <a:bodyPr wrap="square" rtlCol="0" anchor="ctr"/>
           <a:lstStyle/>
           <a:p>
-            <a:pPr indent="0" marL="0">
+            <a:pPr marL="0" indent="0">
               <a:buNone/>
             </a:pPr>
             <a:r>
@@ -2883,11 +2690,11 @@
                 <a:solidFill>
                   <a:srgbClr val="6B6B6B"/>
                 </a:solidFill>
-                <a:latin typeface="Microsoft YaHei" pitchFamily="34" charset="0"/>
-                <a:ea typeface="Microsoft YaHei" pitchFamily="34" charset="-122"/>
-                <a:cs typeface="Microsoft YaHei" pitchFamily="34" charset="-120"/>
-              </a:rPr>
-              <a:t>点大小=供体中位阳性比例；颜色=数据集内排序（1=最高）。空心点=环境 RNA 未校正的上皮类，不用于结论。</a:t>
+                <a:latin typeface="微软雅黑" pitchFamily="34" charset="0"/>
+                <a:ea typeface="微软雅黑" pitchFamily="34" charset="-122"/>
+                <a:cs typeface="微软雅黑" pitchFamily="34" charset="-120"/>
+              </a:rPr>
+              <a:t>点大小=供体中位阳性比例；颜色=数据集内排序（1=最高）。空心点=环境 RNA 未校正的上皮类。</a:t>
             </a:r>
             <a:endParaRPr lang="en-US" sz="1050" dirty="0"/>
           </a:p>
@@ -2903,7 +2710,7 @@
 
 <file path=ppt/slides/slide5.xml><?xml version="1.0" encoding="utf-8"?>
 <p:sld xmlns:a="http://schemas.openxmlformats.org/drawingml/2006/main" xmlns:r="http://schemas.openxmlformats.org/officeDocument/2006/relationships" xmlns:p="http://schemas.openxmlformats.org/presentationml/2006/main">
-  <p:cSld name="Slide 5">
+  <p:cSld>
     <p:spTree>
       <p:nvGrpSpPr>
         <p:cNvPr id="1" name=""/>
@@ -2933,13 +2740,12 @@
             <a:avLst/>
           </a:prstGeom>
           <a:noFill/>
-          <a:ln/>
         </p:spPr>
         <p:txBody>
           <a:bodyPr wrap="square" rtlCol="0" anchor="ctr"/>
           <a:lstStyle/>
           <a:p>
-            <a:pPr indent="0" marL="0">
+            <a:pPr marL="0" indent="0">
               <a:buNone/>
             </a:pPr>
             <a:r>
@@ -2947,9 +2753,9 @@
                 <a:solidFill>
                   <a:srgbClr val="1A1A1A"/>
                 </a:solidFill>
-                <a:latin typeface="Microsoft YaHei" pitchFamily="34" charset="0"/>
-                <a:ea typeface="Microsoft YaHei" pitchFamily="34" charset="-122"/>
-                <a:cs typeface="Microsoft YaHei" pitchFamily="34" charset="-120"/>
+                <a:latin typeface="微软雅黑" pitchFamily="34" charset="0"/>
+                <a:ea typeface="微软雅黑" pitchFamily="34" charset="-122"/>
+                <a:cs typeface="微软雅黑" pitchFamily="34" charset="-120"/>
               </a:rPr>
               <a:t>小鼠 · 各单细胞数据集的 IL18 散点图</a:t>
             </a:r>
@@ -2959,7 +2765,7 @@
       </p:sp>
       <p:pic>
         <p:nvPicPr>
-          <p:cNvPr id="3" name="Image 0" descr="/home/user/aaa/il18_lung/figures/master_mouse.png">    </p:cNvPr>
+          <p:cNvPr id="3" name="Image 0" descr="/home/user/aaa/il18_lung/figures/master_mouse.png"/>
           <p:cNvPicPr>
             <a:picLocks noChangeAspect="1"/>
           </p:cNvPicPr>
@@ -2996,13 +2802,12 @@
             <a:avLst/>
           </a:prstGeom>
           <a:noFill/>
-          <a:ln/>
         </p:spPr>
         <p:txBody>
           <a:bodyPr wrap="square" rtlCol="0" anchor="ctr"/>
           <a:lstStyle/>
           <a:p>
-            <a:pPr indent="0" marL="0">
+            <a:pPr marL="0" indent="0">
               <a:buNone/>
             </a:pPr>
             <a:r>
@@ -3010,9 +2815,9 @@
                 <a:solidFill>
                   <a:srgbClr val="6B6B6B"/>
                 </a:solidFill>
-                <a:latin typeface="Microsoft YaHei" pitchFamily="34" charset="0"/>
-                <a:ea typeface="Microsoft YaHei" pitchFamily="34" charset="-122"/>
-                <a:cs typeface="Microsoft YaHei" pitchFamily="34" charset="-120"/>
+                <a:latin typeface="微软雅黑" pitchFamily="34" charset="0"/>
+                <a:ea typeface="微软雅黑" pitchFamily="34" charset="-122"/>
+                <a:cs typeface="微软雅黑" pitchFamily="34" charset="-120"/>
               </a:rPr>
               <a:t>肺泡巨噬细胞在静息、流感、细菌、LPS 全部条件下排名第一。带 * 为自行注释的 LPS 数据集；流感仅示 d42。</a:t>
             </a:r>
@@ -3030,7 +2835,7 @@
 
 <file path=ppt/slides/slide6.xml><?xml version="1.0" encoding="utf-8"?>
 <p:sld xmlns:a="http://schemas.openxmlformats.org/drawingml/2006/main" xmlns:r="http://schemas.openxmlformats.org/officeDocument/2006/relationships" xmlns:p="http://schemas.openxmlformats.org/presentationml/2006/main">
-  <p:cSld name="Slide 6">
+  <p:cSld>
     <p:spTree>
       <p:nvGrpSpPr>
         <p:cNvPr id="1" name=""/>
@@ -3060,13 +2865,12 @@
             <a:avLst/>
           </a:prstGeom>
           <a:noFill/>
-          <a:ln/>
         </p:spPr>
         <p:txBody>
           <a:bodyPr wrap="square" rtlCol="0" anchor="ctr"/>
           <a:lstStyle/>
           <a:p>
-            <a:pPr indent="0" marL="0">
+            <a:pPr marL="0" indent="0">
               <a:buNone/>
             </a:pPr>
             <a:r>
@@ -3074,9 +2878,9 @@
                 <a:solidFill>
                   <a:srgbClr val="1A1A1A"/>
                 </a:solidFill>
-                <a:latin typeface="Microsoft YaHei" pitchFamily="34" charset="0"/>
-                <a:ea typeface="Microsoft YaHei" pitchFamily="34" charset="-122"/>
-                <a:cs typeface="Microsoft YaHei" pitchFamily="34" charset="-120"/>
+                <a:latin typeface="微软雅黑" pitchFamily="34" charset="0"/>
+                <a:ea typeface="微软雅黑" pitchFamily="34" charset="-122"/>
+                <a:cs typeface="微软雅黑" pitchFamily="34" charset="-120"/>
               </a:rPr>
               <a:t>上皮信号经环境 RNA 校正后依然存在</a:t>
             </a:r>
@@ -3086,7 +2890,7 @@
       </p:sp>
       <p:pic>
         <p:nvPicPr>
-          <p:cNvPr id="3" name="Image 0" descr="/home/user/aaa/il18_lung/figures/human/H03_TabulaSapiens_lung.png">    </p:cNvPr>
+          <p:cNvPr id="3" name="Image 0" descr="/home/user/aaa/il18_lung/figures/human/H03_TabulaSapiens_lung.png"/>
           <p:cNvPicPr>
             <a:picLocks noChangeAspect="1"/>
           </p:cNvPicPr>
@@ -3123,13 +2927,12 @@
             <a:avLst/>
           </a:prstGeom>
           <a:noFill/>
-          <a:ln/>
         </p:spPr>
         <p:txBody>
           <a:bodyPr wrap="square" lIns="0" tIns="0" rIns="0" bIns="0" rtlCol="0" anchor="ctr"/>
           <a:lstStyle/>
           <a:p>
-            <a:pPr indent="0" marL="0">
+            <a:pPr marL="0" indent="0">
               <a:buNone/>
             </a:pPr>
             <a:r>
@@ -3137,9 +2940,9 @@
                 <a:solidFill>
                   <a:srgbClr val="1A1A1A"/>
                 </a:solidFill>
-                <a:latin typeface="Microsoft YaHei" pitchFamily="34" charset="0"/>
-                <a:ea typeface="Microsoft YaHei" pitchFamily="34" charset="-122"/>
-                <a:cs typeface="Microsoft YaHei" pitchFamily="34" charset="-120"/>
+                <a:latin typeface="微软雅黑" pitchFamily="34" charset="0"/>
+                <a:ea typeface="微软雅黑" pitchFamily="34" charset="-122"/>
+                <a:cs typeface="微软雅黑" pitchFamily="34" charset="-120"/>
               </a:rPr>
               <a:t>decontX 校正几乎不改变上皮：AT1 阳性 72.8% → 72.5%，基底细胞 61% → 61%</a:t>
             </a:r>
@@ -3162,13 +2965,12 @@
             <a:avLst/>
           </a:prstGeom>
           <a:noFill/>
-          <a:ln/>
         </p:spPr>
         <p:txBody>
           <a:bodyPr wrap="square" lIns="0" tIns="0" rIns="0" bIns="0" rtlCol="0" anchor="ctr"/>
           <a:lstStyle/>
           <a:p>
-            <a:pPr indent="0" marL="0">
+            <a:pPr marL="0" indent="0">
               <a:buNone/>
             </a:pPr>
             <a:r>
@@ -3176,9 +2978,9 @@
                 <a:solidFill>
                   <a:srgbClr val="1A1A1A"/>
                 </a:solidFill>
-                <a:latin typeface="Microsoft YaHei" pitchFamily="34" charset="0"/>
-                <a:ea typeface="Microsoft YaHei" pitchFamily="34" charset="-122"/>
-                <a:cs typeface="Microsoft YaHei" pitchFamily="34" charset="-120"/>
+                <a:latin typeface="微软雅黑" pitchFamily="34" charset="0"/>
+                <a:ea typeface="微软雅黑" pitchFamily="34" charset="-122"/>
+                <a:cs typeface="微软雅黑" pitchFamily="34" charset="-120"/>
               </a:rPr>
               <a:t>却清除了内皮/淋巴信号：毛细血管内皮 3.1% → 0.7%，B 细胞 5.0% → 2.4%</a:t>
             </a:r>
@@ -3201,13 +3003,12 @@
             <a:avLst/>
           </a:prstGeom>
           <a:noFill/>
-          <a:ln/>
         </p:spPr>
         <p:txBody>
           <a:bodyPr wrap="square" lIns="0" tIns="0" rIns="0" bIns="0" rtlCol="0" anchor="ctr"/>
           <a:lstStyle/>
           <a:p>
-            <a:pPr indent="0" marL="0">
+            <a:pPr marL="0" indent="0">
               <a:buNone/>
             </a:pPr>
             <a:r>
@@ -3215,9 +3016,9 @@
                 <a:solidFill>
                   <a:srgbClr val="1A1A1A"/>
                 </a:solidFill>
-                <a:latin typeface="Microsoft YaHei" pitchFamily="34" charset="0"/>
-                <a:ea typeface="Microsoft YaHei" pitchFamily="34" charset="-122"/>
-                <a:cs typeface="Microsoft YaHei" pitchFamily="34" charset="-120"/>
+                <a:latin typeface="微软雅黑" pitchFamily="34" charset="0"/>
+                <a:ea typeface="微软雅黑" pitchFamily="34" charset="-122"/>
+                <a:cs typeface="微软雅黑" pitchFamily="34" charset="-120"/>
               </a:rPr>
               <a:t>故人肺泡及气道上皮的 IL18 并非肺泡巨噬细胞游离 RNA 污染所致</a:t>
             </a:r>
@@ -3235,7 +3036,7 @@
 
 <file path=ppt/slides/slide7.xml><?xml version="1.0" encoding="utf-8"?>
 <p:sld xmlns:a="http://schemas.openxmlformats.org/drawingml/2006/main" xmlns:r="http://schemas.openxmlformats.org/officeDocument/2006/relationships" xmlns:p="http://schemas.openxmlformats.org/presentationml/2006/main">
-  <p:cSld name="Slide 7">
+  <p:cSld>
     <p:spTree>
       <p:nvGrpSpPr>
         <p:cNvPr id="1" name=""/>
@@ -3265,13 +3066,12 @@
             <a:avLst/>
           </a:prstGeom>
           <a:noFill/>
-          <a:ln/>
         </p:spPr>
         <p:txBody>
           <a:bodyPr wrap="square" rtlCol="0" anchor="ctr"/>
           <a:lstStyle/>
           <a:p>
-            <a:pPr indent="0" marL="0">
+            <a:pPr marL="0" indent="0">
               <a:buNone/>
             </a:pPr>
             <a:r>
@@ -3279,108 +3079,459 @@
                 <a:solidFill>
                   <a:srgbClr val="1A1A1A"/>
                 </a:solidFill>
-                <a:latin typeface="Microsoft YaHei" pitchFamily="34" charset="0"/>
-                <a:ea typeface="Microsoft YaHei" pitchFamily="34" charset="-122"/>
-                <a:cs typeface="Microsoft YaHei" pitchFamily="34" charset="-120"/>
-              </a:rPr>
-              <a:t>零值判读：真零 vs 技术零（对照分选 bulk）</a:t>
+                <a:latin typeface="微软雅黑" pitchFamily="34" charset="0"/>
+                <a:ea typeface="微软雅黑" pitchFamily="34" charset="-122"/>
+                <a:cs typeface="微软雅黑" pitchFamily="34" charset="-120"/>
+              </a:rPr>
+              <a:t>数据缺口与偏离</a:t>
             </a:r>
             <a:endParaRPr lang="en-US" sz="2500" dirty="0"/>
+          </a:p>
+        </p:txBody>
+      </p:sp>
+      <p:sp>
+        <p:nvSpPr>
+          <p:cNvPr id="3" name="Text 1"/>
+          <p:cNvSpPr txBox="1"/>
+          <p:nvPr/>
+        </p:nvSpPr>
+        <p:spPr>
+          <a:xfrm>
+            <a:off x="640080" y="1417320"/>
+            <a:ext cx="2743200" cy="914400"/>
+          </a:xfrm>
+          <a:prstGeom prst="rect">
+            <a:avLst/>
+          </a:prstGeom>
+          <a:noFill/>
+        </p:spPr>
+        <p:txBody>
+          <a:bodyPr wrap="square" rtlCol="0" anchor="t"/>
+          <a:lstStyle/>
+          <a:p>
+            <a:pPr marL="0" indent="0">
+              <a:buNone/>
+            </a:pPr>
+            <a:r>
+              <a:rPr lang="en-US" sz="1350" b="1" dirty="0">
+                <a:solidFill>
+                  <a:srgbClr val="1A1A1A"/>
+                </a:solidFill>
+                <a:latin typeface="微软雅黑" pitchFamily="34" charset="0"/>
+                <a:ea typeface="微软雅黑" pitchFamily="34" charset="-122"/>
+                <a:cs typeface="微软雅黑" pitchFamily="34" charset="-120"/>
+              </a:rPr>
+              <a:t>人 · 甲型流感</a:t>
+            </a:r>
+            <a:endParaRPr lang="en-US" sz="1350" dirty="0"/>
+          </a:p>
+        </p:txBody>
+      </p:sp>
+      <p:sp>
+        <p:nvSpPr>
+          <p:cNvPr id="4" name="Text 2"/>
+          <p:cNvSpPr txBox="1"/>
+          <p:nvPr/>
+        </p:nvSpPr>
+        <p:spPr>
+          <a:xfrm>
+            <a:off x="3474720" y="1417320"/>
+            <a:ext cx="8046720" cy="914400"/>
+          </a:xfrm>
+          <a:prstGeom prst="rect">
+            <a:avLst/>
+          </a:prstGeom>
+          <a:noFill/>
+        </p:spPr>
+        <p:txBody>
+          <a:bodyPr wrap="square" rtlCol="0" anchor="t"/>
+          <a:lstStyle/>
+          <a:p>
+            <a:pPr marL="0" indent="0">
+              <a:lnSpc>
+                <a:spcPct val="118000"/>
+              </a:lnSpc>
+              <a:buNone/>
+            </a:pPr>
+            <a:r>
+              <a:rPr lang="en-US" sz="1300" dirty="0">
+                <a:solidFill>
+                  <a:srgbClr val="1A1A1A"/>
+                </a:solidFill>
+                <a:latin typeface="微软雅黑" pitchFamily="34" charset="0"/>
+                <a:ea typeface="微软雅黑" pitchFamily="34" charset="-122"/>
+                <a:cs typeface="微软雅黑" pitchFamily="34" charset="-120"/>
+              </a:rPr>
+              <a:t>数据缺口：人肺流感单细胞几乎不存在（唯一候选为单供体离体肺）；未用鼻腔/外周血填补。</a:t>
+            </a:r>
+            <a:endParaRPr lang="en-US" sz="1300" dirty="0"/>
+          </a:p>
+        </p:txBody>
+      </p:sp>
+      <p:sp>
+        <p:nvSpPr>
+          <p:cNvPr id="5" name="Text 3"/>
+          <p:cNvSpPr txBox="1"/>
+          <p:nvPr/>
+        </p:nvSpPr>
+        <p:spPr>
+          <a:xfrm>
+            <a:off x="640080" y="2514600"/>
+            <a:ext cx="2743200" cy="914400"/>
+          </a:xfrm>
+          <a:prstGeom prst="rect">
+            <a:avLst/>
+          </a:prstGeom>
+          <a:noFill/>
+        </p:spPr>
+        <p:txBody>
+          <a:bodyPr wrap="square" rtlCol="0" anchor="t"/>
+          <a:lstStyle/>
+          <a:p>
+            <a:pPr marL="0" indent="0">
+              <a:buNone/>
+            </a:pPr>
+            <a:r>
+              <a:rPr lang="en-US" sz="1350" b="1" dirty="0">
+                <a:solidFill>
+                  <a:srgbClr val="1A1A1A"/>
+                </a:solidFill>
+                <a:latin typeface="微软雅黑" pitchFamily="34" charset="0"/>
+                <a:ea typeface="微软雅黑" pitchFamily="34" charset="-122"/>
+                <a:cs typeface="微软雅黑" pitchFamily="34" charset="-120"/>
+              </a:rPr>
+              <a:t>人 · 细菌性肺炎</a:t>
+            </a:r>
+            <a:endParaRPr lang="en-US" sz="1350" dirty="0"/>
+          </a:p>
+        </p:txBody>
+      </p:sp>
+      <p:sp>
+        <p:nvSpPr>
+          <p:cNvPr id="6" name="Text 4"/>
+          <p:cNvSpPr txBox="1"/>
+          <p:nvPr/>
+        </p:nvSpPr>
+        <p:spPr>
+          <a:xfrm>
+            <a:off x="3474720" y="2514600"/>
+            <a:ext cx="8046720" cy="914400"/>
+          </a:xfrm>
+          <a:prstGeom prst="rect">
+            <a:avLst/>
+          </a:prstGeom>
+          <a:noFill/>
+        </p:spPr>
+        <p:txBody>
+          <a:bodyPr wrap="square" rtlCol="0" anchor="t"/>
+          <a:lstStyle/>
+          <a:p>
+            <a:pPr marL="0" indent="0">
+              <a:lnSpc>
+                <a:spcPct val="118000"/>
+              </a:lnSpc>
+              <a:buNone/>
+            </a:pPr>
+            <a:r>
+              <a:rPr lang="en-US" sz="1300" dirty="0">
+                <a:solidFill>
+                  <a:srgbClr val="1A1A1A"/>
+                </a:solidFill>
+                <a:latin typeface="微软雅黑" pitchFamily="34" charset="0"/>
+                <a:ea typeface="微软雅黑" pitchFamily="34" charset="-122"/>
+                <a:cs typeface="微软雅黑" pitchFamily="34" charset="-120"/>
+              </a:rPr>
+              <a:t>无病原逐例明确的数据；仅以非 COVID 肺炎 BALF 作替代。</a:t>
+            </a:r>
+            <a:endParaRPr lang="en-US" sz="1300" dirty="0"/>
+          </a:p>
+        </p:txBody>
+      </p:sp>
+      <p:sp>
+        <p:nvSpPr>
+          <p:cNvPr id="7" name="Text 5"/>
+          <p:cNvSpPr txBox="1"/>
+          <p:nvPr/>
+        </p:nvSpPr>
+        <p:spPr>
+          <a:xfrm>
+            <a:off x="640080" y="3611880"/>
+            <a:ext cx="2743200" cy="914400"/>
+          </a:xfrm>
+          <a:prstGeom prst="rect">
+            <a:avLst/>
+          </a:prstGeom>
+          <a:noFill/>
+        </p:spPr>
+        <p:txBody>
+          <a:bodyPr wrap="square" rtlCol="0" anchor="t"/>
+          <a:lstStyle/>
+          <a:p>
+            <a:pPr marL="0" indent="0">
+              <a:buNone/>
+            </a:pPr>
+            <a:r>
+              <a:rPr lang="en-US" sz="1350" b="1" dirty="0">
+                <a:solidFill>
+                  <a:srgbClr val="1A1A1A"/>
+                </a:solidFill>
+                <a:latin typeface="微软雅黑" pitchFamily="34" charset="0"/>
+                <a:ea typeface="微软雅黑" pitchFamily="34" charset="-122"/>
+                <a:cs typeface="微软雅黑" pitchFamily="34" charset="-120"/>
+              </a:rPr>
+              <a:t>人 · LPS 急性肺损伤</a:t>
+            </a:r>
+            <a:endParaRPr lang="en-US" sz="1350" dirty="0"/>
+          </a:p>
+        </p:txBody>
+      </p:sp>
+      <p:sp>
+        <p:nvSpPr>
+          <p:cNvPr id="8" name="Text 6"/>
+          <p:cNvSpPr txBox="1"/>
+          <p:nvPr/>
+        </p:nvSpPr>
+        <p:spPr>
+          <a:xfrm>
+            <a:off x="3474720" y="3611880"/>
+            <a:ext cx="8046720" cy="914400"/>
+          </a:xfrm>
+          <a:prstGeom prst="rect">
+            <a:avLst/>
+          </a:prstGeom>
+          <a:noFill/>
+        </p:spPr>
+        <p:txBody>
+          <a:bodyPr wrap="square" rtlCol="0" anchor="t"/>
+          <a:lstStyle/>
+          <a:p>
+            <a:pPr marL="0" indent="0">
+              <a:lnSpc>
+                <a:spcPct val="118000"/>
+              </a:lnSpc>
+              <a:buNone/>
+            </a:pPr>
+            <a:r>
+              <a:rPr lang="en-US" sz="1300" dirty="0">
+                <a:solidFill>
+                  <a:srgbClr val="1A1A1A"/>
+                </a:solidFill>
+                <a:latin typeface="微软雅黑" pitchFamily="34" charset="0"/>
+                <a:ea typeface="微软雅黑" pitchFamily="34" charset="-122"/>
+                <a:cs typeface="微软雅黑" pitchFamily="34" charset="-120"/>
+              </a:rPr>
+              <a:t>无合格单细胞数据（仅 BAL 刺激、无对照）。</a:t>
+            </a:r>
+            <a:endParaRPr lang="en-US" sz="1300" dirty="0"/>
+          </a:p>
+        </p:txBody>
+      </p:sp>
+      <p:sp>
+        <p:nvSpPr>
+          <p:cNvPr id="9" name="Text 7"/>
+          <p:cNvSpPr txBox="1"/>
+          <p:nvPr/>
+        </p:nvSpPr>
+        <p:spPr>
+          <a:xfrm>
+            <a:off x="640080" y="4709160"/>
+            <a:ext cx="2743200" cy="914400"/>
+          </a:xfrm>
+          <a:prstGeom prst="rect">
+            <a:avLst/>
+          </a:prstGeom>
+          <a:noFill/>
+        </p:spPr>
+        <p:txBody>
+          <a:bodyPr wrap="square" rtlCol="0" anchor="t"/>
+          <a:lstStyle/>
+          <a:p>
+            <a:pPr marL="0" indent="0">
+              <a:buNone/>
+            </a:pPr>
+            <a:r>
+              <a:rPr lang="en-US" sz="1350" b="1" dirty="0">
+                <a:solidFill>
+                  <a:srgbClr val="1A1A1A"/>
+                </a:solidFill>
+                <a:latin typeface="微软雅黑" pitchFamily="34" charset="0"/>
+                <a:ea typeface="微软雅黑" pitchFamily="34" charset="-122"/>
+                <a:cs typeface="微软雅黑" pitchFamily="34" charset="-120"/>
+              </a:rPr>
+              <a:t>小鼠 · LPS 急性肺损伤</a:t>
+            </a:r>
+            <a:endParaRPr lang="en-US" sz="1350" dirty="0"/>
+          </a:p>
+        </p:txBody>
+      </p:sp>
+      <p:sp>
+        <p:nvSpPr>
+          <p:cNvPr id="10" name="Text 8"/>
+          <p:cNvSpPr txBox="1"/>
+          <p:nvPr/>
+        </p:nvSpPr>
+        <p:spPr>
+          <a:xfrm>
+            <a:off x="3474720" y="4709160"/>
+            <a:ext cx="8046720" cy="914400"/>
+          </a:xfrm>
+          <a:prstGeom prst="rect">
+            <a:avLst/>
+          </a:prstGeom>
+          <a:noFill/>
+        </p:spPr>
+        <p:txBody>
+          <a:bodyPr wrap="square" rtlCol="0" anchor="t"/>
+          <a:lstStyle/>
+          <a:p>
+            <a:pPr marL="0" indent="0">
+              <a:lnSpc>
+                <a:spcPct val="118000"/>
+              </a:lnSpc>
+              <a:buNone/>
+            </a:pPr>
+            <a:r>
+              <a:rPr lang="en-US" sz="1300" dirty="0">
+                <a:solidFill>
+                  <a:srgbClr val="1A1A1A"/>
+                </a:solidFill>
+                <a:latin typeface="微软雅黑" pitchFamily="34" charset="0"/>
+                <a:ea typeface="微软雅黑" pitchFamily="34" charset="-122"/>
+                <a:cs typeface="微软雅黑" pitchFamily="34" charset="-120"/>
+              </a:rPr>
+              <a:t>已纳入 GSE280364、GSE280611（全肺、2 vs 2、含对照）。</a:t>
+            </a:r>
+            <a:endParaRPr lang="en-US" sz="1300" dirty="0"/>
+          </a:p>
+        </p:txBody>
+      </p:sp>
+    </p:spTree>
+  </p:cSld>
+  <p:clrMapOvr>
+    <a:masterClrMapping/>
+  </p:clrMapOvr>
+</p:sld>
+</file>
+
+<file path=ppt/slides/slide8.xml><?xml version="1.0" encoding="utf-8"?>
+<p:sld xmlns:a="http://schemas.openxmlformats.org/drawingml/2006/main" xmlns:p="http://schemas.openxmlformats.org/presentationml/2006/main" xmlns:r="http://schemas.openxmlformats.org/officeDocument/2006/relationships">
+  <p:cSld>
+    <p:spTree>
+      <p:nvGrpSpPr>
+        <p:cNvPr id="1" name=""/>
+        <p:cNvGrpSpPr/>
+        <p:nvPr/>
+      </p:nvGrpSpPr>
+      <p:grpSpPr/>
+      <p:sp>
+        <p:nvSpPr>
+          <p:cNvPr id="2" name="TextBox 1"/>
+          <p:cNvSpPr txBox="1"/>
+          <p:nvPr/>
+        </p:nvSpPr>
+        <p:spPr>
+          <a:xfrm>
+            <a:off x="640080" y="457200"/>
+            <a:ext cx="10972800" cy="640080"/>
+          </a:xfrm>
+          <a:prstGeom prst="rect">
+            <a:avLst/>
+          </a:prstGeom>
+          <a:noFill/>
+        </p:spPr>
+        <p:txBody>
+          <a:bodyPr wrap="square">
+            <a:spAutoFit/>
+          </a:bodyPr>
+          <a:lstStyle/>
+          <a:p>
+            <a:r>
+              <a:rPr sz="2500" b="1">
+                <a:solidFill>
+                  <a:srgbClr val="1A1A1A"/>
+                </a:solidFill>
+                <a:latin typeface="微软雅黑"/>
+              </a:rPr>
+              <a:t>结论：各条件下转录 IL18（pro-IL-18）的细胞</a:t>
+            </a:r>
+          </a:p>
+        </p:txBody>
+      </p:sp>
+      <p:sp>
+        <p:nvSpPr>
+          <p:cNvPr id="3" name="TextBox 2"/>
+          <p:cNvSpPr txBox="1"/>
+          <p:nvPr/>
+        </p:nvSpPr>
+        <p:spPr>
+          <a:xfrm>
+            <a:off x="640080" y="1143000"/>
+            <a:ext cx="10972800" cy="457200"/>
+          </a:xfrm>
+          <a:prstGeom prst="rect">
+            <a:avLst/>
+          </a:prstGeom>
+          <a:noFill/>
+        </p:spPr>
+        <p:txBody>
+          <a:bodyPr wrap="square">
+            <a:spAutoFit/>
+          </a:bodyPr>
+          <a:lstStyle/>
+          <a:p>
+            <a:r>
+              <a:rPr sz="1400" b="0">
+                <a:solidFill>
+                  <a:srgbClr val="6B6B6B"/>
+                </a:solidFill>
+                <a:latin typeface="微软雅黑"/>
+              </a:rPr>
+              <a:t>正面回答——人与小鼠肺，按条件列出转录 IL18 的细胞类型（数据集内排名靠前者）</a:t>
+            </a:r>
           </a:p>
         </p:txBody>
       </p:sp>
       <p:graphicFrame>
         <p:nvGraphicFramePr>
-          <p:cNvPr id="8" name="Table 0"/>
+          <p:cNvPr id="4" name="Table 3"/>
           <p:cNvGraphicFramePr>
             <a:graphicFrameLocks noGrp="1"/>
           </p:cNvGraphicFramePr>
-          <p:nvPr>
-            <p:extLst>
-              <p:ext uri="{D42A27DB-BD31-4B8C-83A1-F6EECF244321}">
-                <p14:modId xmlns:p14="http://schemas.microsoft.com/office/powerpoint/2010/main" val="1579011935"/>
-              </p:ext>
-            </p:extLst>
-          </p:nvPr>
+          <p:nvPr/>
         </p:nvGraphicFramePr>
         <p:xfrm>
-          <a:off x="640080" y="1463040"/>
-          <a:ext cx="10881360" cy="914400"/>
+          <a:off x="640080" y="1783080"/>
+          <a:ext cx="10908792" cy="3566160"/>
         </p:xfrm>
         <a:graphic>
           <a:graphicData uri="http://schemas.openxmlformats.org/drawingml/2006/table">
             <a:tbl>
-              <a:tblPr/>
+              <a:tblPr>
+                <a:tableStyleId>{5C22544A-7EE6-4342-B048-85BDC9FD1C3A}</a:tableStyleId>
+              </a:tblPr>
               <a:tblGrid>
-                <a:gridCol w="2286000"/>
-                <a:gridCol w="2011680"/>
-                <a:gridCol w="4389120"/>
-                <a:gridCol w="2194560"/>
+                <a:gridCol w="2103120"/>
+                <a:gridCol w="4846320"/>
+                <a:gridCol w="3959352"/>
               </a:tblGrid>
-              <a:tr h="548640">
+              <a:tr h="594360">
                 <a:tc>
                   <a:txBody>
                     <a:bodyPr/>
                     <a:lstStyle/>
                     <a:p>
-                      <a:pPr algn="l" indent="0" marL="0">
-                        <a:buNone/>
-                      </a:pPr>
                       <a:r>
-                        <a:rPr lang="en-US" sz="1250" b="1" dirty="0">
+                        <a:rPr sz="1250" b="1">
                           <a:solidFill>
                             <a:srgbClr val="1A1A1A"/>
                           </a:solidFill>
-                          <a:latin typeface="Microsoft YaHei" pitchFamily="34" charset="0"/>
-                          <a:ea typeface="Microsoft YaHei" pitchFamily="34" charset="-122"/>
-                          <a:cs typeface="Microsoft YaHei" pitchFamily="34" charset="-120"/>
+                          <a:latin typeface="微软雅黑"/>
                         </a:rPr>
-                        <a:t>细胞类型</a:t>
+                        <a:t>条件</a:t>
                       </a:r>
-                      <a:endParaRPr lang="en-US" sz="1250" dirty="0">
-                        <a:latin typeface="Microsoft YaHei" charset="0"/>
-                        <a:ea typeface="Microsoft YaHei" charset="0"/>
-                        <a:cs typeface="Microsoft YaHei" charset="0"/>
-                      </a:endParaRPr>
                     </a:p>
                   </a:txBody>
-                  <a:tcPr marL="76200" marR="76200" marT="50800" marB="50800" anchor="ctr">
-                    <a:lnL w="12700" cap="flat" cmpd="sng" algn="ctr">
-                      <a:solidFill>
-                        <a:srgbClr val="D8DBE0"/>
-                      </a:solidFill>
-                      <a:prstDash val="solid"/>
-                      <a:round/>
-                      <a:headEnd type="none" w="med" len="med"/>
-                      <a:tailEnd type="none" w="med" len="med"/>
-                    </a:lnL>
-                    <a:lnR w="12700" cap="flat" cmpd="sng" algn="ctr">
-                      <a:solidFill>
-                        <a:srgbClr val="D8DBE0"/>
-                      </a:solidFill>
-                      <a:prstDash val="solid"/>
-                      <a:round/>
-                      <a:headEnd type="none" w="med" len="med"/>
-                      <a:tailEnd type="none" w="med" len="med"/>
-                    </a:lnR>
-                    <a:lnT w="12700" cap="flat" cmpd="sng" algn="ctr">
-                      <a:solidFill>
-                        <a:srgbClr val="D8DBE0"/>
-                      </a:solidFill>
-                      <a:prstDash val="solid"/>
-                      <a:round/>
-                      <a:headEnd type="none" w="med" len="med"/>
-                      <a:tailEnd type="none" w="med" len="med"/>
-                    </a:lnT>
-                    <a:lnB w="12700" cap="flat" cmpd="sng" algn="ctr">
-                      <a:solidFill>
-                        <a:srgbClr val="D8DBE0"/>
-                      </a:solidFill>
-                      <a:prstDash val="solid"/>
-                      <a:round/>
-                      <a:headEnd type="none" w="med" len="med"/>
-                      <a:tailEnd type="none" w="med" len="med"/>
-                    </a:lnB>
+                  <a:tcPr marL="82296" marR="82296" marT="36576" marB="36576" anchor="ctr">
                     <a:solidFill>
                       <a:srgbClr val="EEF1F5"/>
                     </a:solidFill>
@@ -3391,64 +3542,18 @@
                     <a:bodyPr/>
                     <a:lstStyle/>
                     <a:p>
-                      <a:pPr algn="l" indent="0" marL="0">
-                        <a:buNone/>
-                      </a:pPr>
                       <a:r>
-                        <a:rPr lang="en-US" sz="1250" b="1" dirty="0">
+                        <a:rPr sz="1250" b="1">
                           <a:solidFill>
                             <a:srgbClr val="1A1A1A"/>
                           </a:solidFill>
-                          <a:latin typeface="Microsoft YaHei" pitchFamily="34" charset="0"/>
-                          <a:ea typeface="Microsoft YaHei" pitchFamily="34" charset="-122"/>
-                          <a:cs typeface="Microsoft YaHei" pitchFamily="34" charset="-120"/>
+                          <a:latin typeface="微软雅黑"/>
                         </a:rPr>
-                        <a:t>单细胞</a:t>
+                        <a:t>人（肺）</a:t>
                       </a:r>
-                      <a:endParaRPr lang="en-US" sz="1250" dirty="0">
-                        <a:latin typeface="Microsoft YaHei" charset="0"/>
-                        <a:ea typeface="Microsoft YaHei" charset="0"/>
-                        <a:cs typeface="Microsoft YaHei" charset="0"/>
-                      </a:endParaRPr>
                     </a:p>
                   </a:txBody>
-                  <a:tcPr marL="76200" marR="76200" marT="50800" marB="50800" anchor="ctr">
-                    <a:lnL w="12700" cap="flat" cmpd="sng" algn="ctr">
-                      <a:solidFill>
-                        <a:srgbClr val="D8DBE0"/>
-                      </a:solidFill>
-                      <a:prstDash val="solid"/>
-                      <a:round/>
-                      <a:headEnd type="none" w="med" len="med"/>
-                      <a:tailEnd type="none" w="med" len="med"/>
-                    </a:lnL>
-                    <a:lnR w="12700" cap="flat" cmpd="sng" algn="ctr">
-                      <a:solidFill>
-                        <a:srgbClr val="D8DBE0"/>
-                      </a:solidFill>
-                      <a:prstDash val="solid"/>
-                      <a:round/>
-                      <a:headEnd type="none" w="med" len="med"/>
-                      <a:tailEnd type="none" w="med" len="med"/>
-                    </a:lnR>
-                    <a:lnT w="12700" cap="flat" cmpd="sng" algn="ctr">
-                      <a:solidFill>
-                        <a:srgbClr val="D8DBE0"/>
-                      </a:solidFill>
-                      <a:prstDash val="solid"/>
-                      <a:round/>
-                      <a:headEnd type="none" w="med" len="med"/>
-                      <a:tailEnd type="none" w="med" len="med"/>
-                    </a:lnT>
-                    <a:lnB w="12700" cap="flat" cmpd="sng" algn="ctr">
-                      <a:solidFill>
-                        <a:srgbClr val="D8DBE0"/>
-                      </a:solidFill>
-                      <a:prstDash val="solid"/>
-                      <a:round/>
-                      <a:headEnd type="none" w="med" len="med"/>
-                      <a:tailEnd type="none" w="med" len="med"/>
-                    </a:lnB>
+                  <a:tcPr marL="82296" marR="82296" marT="36576" marB="36576" anchor="ctr">
                     <a:solidFill>
                       <a:srgbClr val="EEF1F5"/>
                     </a:solidFill>
@@ -3459,202 +3564,42 @@
                     <a:bodyPr/>
                     <a:lstStyle/>
                     <a:p>
-                      <a:pPr algn="l" indent="0" marL="0">
-                        <a:buNone/>
-                      </a:pPr>
                       <a:r>
-                        <a:rPr lang="en-US" sz="1250" b="1" dirty="0">
+                        <a:rPr sz="1250" b="1">
                           <a:solidFill>
                             <a:srgbClr val="1A1A1A"/>
                           </a:solidFill>
-                          <a:latin typeface="Microsoft YaHei" pitchFamily="34" charset="0"/>
-                          <a:ea typeface="Microsoft YaHei" pitchFamily="34" charset="-122"/>
-                          <a:cs typeface="Microsoft YaHei" pitchFamily="34" charset="-120"/>
+                          <a:latin typeface="微软雅黑"/>
                         </a:rPr>
-                        <a:t>分选 bulk 参考</a:t>
+                        <a:t>小鼠（肺）</a:t>
                       </a:r>
-                      <a:endParaRPr lang="en-US" sz="1250" dirty="0">
-                        <a:latin typeface="Microsoft YaHei" charset="0"/>
-                        <a:ea typeface="Microsoft YaHei" charset="0"/>
-                        <a:cs typeface="Microsoft YaHei" charset="0"/>
-                      </a:endParaRPr>
                     </a:p>
                   </a:txBody>
-                  <a:tcPr marL="76200" marR="76200" marT="50800" marB="50800" anchor="ctr">
-                    <a:lnL w="12700" cap="flat" cmpd="sng" algn="ctr">
-                      <a:solidFill>
-                        <a:srgbClr val="D8DBE0"/>
-                      </a:solidFill>
-                      <a:prstDash val="solid"/>
-                      <a:round/>
-                      <a:headEnd type="none" w="med" len="med"/>
-                      <a:tailEnd type="none" w="med" len="med"/>
-                    </a:lnL>
-                    <a:lnR w="12700" cap="flat" cmpd="sng" algn="ctr">
-                      <a:solidFill>
-                        <a:srgbClr val="D8DBE0"/>
-                      </a:solidFill>
-                      <a:prstDash val="solid"/>
-                      <a:round/>
-                      <a:headEnd type="none" w="med" len="med"/>
-                      <a:tailEnd type="none" w="med" len="med"/>
-                    </a:lnR>
-                    <a:lnT w="12700" cap="flat" cmpd="sng" algn="ctr">
-                      <a:solidFill>
-                        <a:srgbClr val="D8DBE0"/>
-                      </a:solidFill>
-                      <a:prstDash val="solid"/>
-                      <a:round/>
-                      <a:headEnd type="none" w="med" len="med"/>
-                      <a:tailEnd type="none" w="med" len="med"/>
-                    </a:lnT>
-                    <a:lnB w="12700" cap="flat" cmpd="sng" algn="ctr">
-                      <a:solidFill>
-                        <a:srgbClr val="D8DBE0"/>
-                      </a:solidFill>
-                      <a:prstDash val="solid"/>
-                      <a:round/>
-                      <a:headEnd type="none" w="med" len="med"/>
-                      <a:tailEnd type="none" w="med" len="med"/>
-                    </a:lnB>
-                    <a:solidFill>
-                      <a:srgbClr val="EEF1F5"/>
-                    </a:solidFill>
-                  </a:tcPr>
-                </a:tc>
-                <a:tc>
-                  <a:txBody>
-                    <a:bodyPr/>
-                    <a:lstStyle/>
-                    <a:p>
-                      <a:pPr algn="l" indent="0" marL="0">
-                        <a:buNone/>
-                      </a:pPr>
-                      <a:r>
-                        <a:rPr lang="en-US" sz="1250" b="1" dirty="0">
-                          <a:solidFill>
-                            <a:srgbClr val="1A1A1A"/>
-                          </a:solidFill>
-                          <a:latin typeface="Microsoft YaHei" pitchFamily="34" charset="0"/>
-                          <a:ea typeface="Microsoft YaHei" pitchFamily="34" charset="-122"/>
-                          <a:cs typeface="Microsoft YaHei" pitchFamily="34" charset="-120"/>
-                        </a:rPr>
-                        <a:t>判读</a:t>
-                      </a:r>
-                      <a:endParaRPr lang="en-US" sz="1250" dirty="0">
-                        <a:latin typeface="Microsoft YaHei" charset="0"/>
-                        <a:ea typeface="Microsoft YaHei" charset="0"/>
-                        <a:cs typeface="Microsoft YaHei" charset="0"/>
-                      </a:endParaRPr>
-                    </a:p>
-                  </a:txBody>
-                  <a:tcPr marL="76200" marR="76200" marT="50800" marB="50800" anchor="ctr">
-                    <a:lnL w="12700" cap="flat" cmpd="sng" algn="ctr">
-                      <a:solidFill>
-                        <a:srgbClr val="D8DBE0"/>
-                      </a:solidFill>
-                      <a:prstDash val="solid"/>
-                      <a:round/>
-                      <a:headEnd type="none" w="med" len="med"/>
-                      <a:tailEnd type="none" w="med" len="med"/>
-                    </a:lnL>
-                    <a:lnR w="12700" cap="flat" cmpd="sng" algn="ctr">
-                      <a:solidFill>
-                        <a:srgbClr val="D8DBE0"/>
-                      </a:solidFill>
-                      <a:prstDash val="solid"/>
-                      <a:round/>
-                      <a:headEnd type="none" w="med" len="med"/>
-                      <a:tailEnd type="none" w="med" len="med"/>
-                    </a:lnR>
-                    <a:lnT w="12700" cap="flat" cmpd="sng" algn="ctr">
-                      <a:solidFill>
-                        <a:srgbClr val="D8DBE0"/>
-                      </a:solidFill>
-                      <a:prstDash val="solid"/>
-                      <a:round/>
-                      <a:headEnd type="none" w="med" len="med"/>
-                      <a:tailEnd type="none" w="med" len="med"/>
-                    </a:lnT>
-                    <a:lnB w="12700" cap="flat" cmpd="sng" algn="ctr">
-                      <a:solidFill>
-                        <a:srgbClr val="D8DBE0"/>
-                      </a:solidFill>
-                      <a:prstDash val="solid"/>
-                      <a:round/>
-                      <a:headEnd type="none" w="med" len="med"/>
-                      <a:tailEnd type="none" w="med" len="med"/>
-                    </a:lnB>
+                  <a:tcPr marL="82296" marR="82296" marT="36576" marB="36576" anchor="ctr">
                     <a:solidFill>
                       <a:srgbClr val="EEF1F5"/>
                     </a:solidFill>
                   </a:tcPr>
                 </a:tc>
               </a:tr>
-              <a:tr h="548640">
+              <a:tr h="594360">
                 <a:tc>
                   <a:txBody>
                     <a:bodyPr/>
                     <a:lstStyle/>
                     <a:p>
-                      <a:pPr algn="l" indent="0" marL="0">
-                        <a:buNone/>
-                      </a:pPr>
                       <a:r>
-                        <a:rPr lang="en-US" sz="1200" dirty="0">
+                        <a:rPr sz="1200" b="1">
                           <a:solidFill>
                             <a:srgbClr val="1A1A1A"/>
                           </a:solidFill>
-                          <a:latin typeface="Microsoft YaHei" pitchFamily="34" charset="0"/>
-                          <a:ea typeface="Microsoft YaHei" pitchFamily="34" charset="-122"/>
-                          <a:cs typeface="Microsoft YaHei" pitchFamily="34" charset="-120"/>
+                          <a:latin typeface="微软雅黑"/>
                         </a:rPr>
-                        <a:t>T / NK</a:t>
+                        <a:t>静息</a:t>
                       </a:r>
-                      <a:endParaRPr lang="en-US" sz="1200" dirty="0">
-                        <a:latin typeface="Microsoft YaHei" charset="0"/>
-                        <a:ea typeface="Microsoft YaHei" charset="0"/>
-                        <a:cs typeface="Microsoft YaHei" charset="0"/>
-                      </a:endParaRPr>
                     </a:p>
                   </a:txBody>
-                  <a:tcPr marL="76200" marR="76200" marT="50800" marB="50800" anchor="ctr">
-                    <a:lnL w="12700" cap="flat" cmpd="sng" algn="ctr">
-                      <a:solidFill>
-                        <a:srgbClr val="D8DBE0"/>
-                      </a:solidFill>
-                      <a:prstDash val="solid"/>
-                      <a:round/>
-                      <a:headEnd type="none" w="med" len="med"/>
-                      <a:tailEnd type="none" w="med" len="med"/>
-                    </a:lnL>
-                    <a:lnR w="12700" cap="flat" cmpd="sng" algn="ctr">
-                      <a:solidFill>
-                        <a:srgbClr val="D8DBE0"/>
-                      </a:solidFill>
-                      <a:prstDash val="solid"/>
-                      <a:round/>
-                      <a:headEnd type="none" w="med" len="med"/>
-                      <a:tailEnd type="none" w="med" len="med"/>
-                    </a:lnR>
-                    <a:lnT w="12700" cap="flat" cmpd="sng" algn="ctr">
-                      <a:solidFill>
-                        <a:srgbClr val="D8DBE0"/>
-                      </a:solidFill>
-                      <a:prstDash val="solid"/>
-                      <a:round/>
-                      <a:headEnd type="none" w="med" len="med"/>
-                      <a:tailEnd type="none" w="med" len="med"/>
-                    </a:lnT>
-                    <a:lnB w="12700" cap="flat" cmpd="sng" algn="ctr">
-                      <a:solidFill>
-                        <a:srgbClr val="D8DBE0"/>
-                      </a:solidFill>
-                      <a:prstDash val="solid"/>
-                      <a:round/>
-                      <a:headEnd type="none" w="med" len="med"/>
-                      <a:tailEnd type="none" w="med" len="med"/>
-                    </a:lnB>
+                  <a:tcPr marL="82296" marR="82296" marT="36576" marB="36576" anchor="ctr">
                     <a:solidFill>
                       <a:srgbClr val="FFFFFF"/>
                     </a:solidFill>
@@ -3665,64 +3610,18 @@
                     <a:bodyPr/>
                     <a:lstStyle/>
                     <a:p>
-                      <a:pPr algn="l" indent="0" marL="0">
-                        <a:buNone/>
-                      </a:pPr>
                       <a:r>
-                        <a:rPr lang="en-US" sz="1200" dirty="0">
+                        <a:rPr sz="1200" b="0">
                           <a:solidFill>
                             <a:srgbClr val="1A1A1A"/>
                           </a:solidFill>
-                          <a:latin typeface="Microsoft YaHei" pitchFamily="34" charset="0"/>
-                          <a:ea typeface="Microsoft YaHei" pitchFamily="34" charset="-122"/>
-                          <a:cs typeface="Microsoft YaHei" pitchFamily="34" charset="-120"/>
+                          <a:latin typeface="微软雅黑"/>
                         </a:rPr>
-                        <a:t>阳性 ≤2%</a:t>
+                        <a:t>树突状细胞、肺泡巨噬细胞、单核来源巨噬细胞；上皮 AT1 / 气道（校正后确有）</a:t>
                       </a:r>
-                      <a:endParaRPr lang="en-US" sz="1200" dirty="0">
-                        <a:latin typeface="Microsoft YaHei" charset="0"/>
-                        <a:ea typeface="Microsoft YaHei" charset="0"/>
-                        <a:cs typeface="Microsoft YaHei" charset="0"/>
-                      </a:endParaRPr>
                     </a:p>
                   </a:txBody>
-                  <a:tcPr marL="76200" marR="76200" marT="50800" marB="50800" anchor="ctr">
-                    <a:lnL w="12700" cap="flat" cmpd="sng" algn="ctr">
-                      <a:solidFill>
-                        <a:srgbClr val="D8DBE0"/>
-                      </a:solidFill>
-                      <a:prstDash val="solid"/>
-                      <a:round/>
-                      <a:headEnd type="none" w="med" len="med"/>
-                      <a:tailEnd type="none" w="med" len="med"/>
-                    </a:lnL>
-                    <a:lnR w="12700" cap="flat" cmpd="sng" algn="ctr">
-                      <a:solidFill>
-                        <a:srgbClr val="D8DBE0"/>
-                      </a:solidFill>
-                      <a:prstDash val="solid"/>
-                      <a:round/>
-                      <a:headEnd type="none" w="med" len="med"/>
-                      <a:tailEnd type="none" w="med" len="med"/>
-                    </a:lnR>
-                    <a:lnT w="12700" cap="flat" cmpd="sng" algn="ctr">
-                      <a:solidFill>
-                        <a:srgbClr val="D8DBE0"/>
-                      </a:solidFill>
-                      <a:prstDash val="solid"/>
-                      <a:round/>
-                      <a:headEnd type="none" w="med" len="med"/>
-                      <a:tailEnd type="none" w="med" len="med"/>
-                    </a:lnT>
-                    <a:lnB w="12700" cap="flat" cmpd="sng" algn="ctr">
-                      <a:solidFill>
-                        <a:srgbClr val="D8DBE0"/>
-                      </a:solidFill>
-                      <a:prstDash val="solid"/>
-                      <a:round/>
-                      <a:headEnd type="none" w="med" len="med"/>
-                      <a:tailEnd type="none" w="med" len="med"/>
-                    </a:lnB>
+                  <a:tcPr marL="82296" marR="82296" marT="36576" marB="36576" anchor="ctr">
                     <a:solidFill>
                       <a:srgbClr val="FFFFFF"/>
                     </a:solidFill>
@@ -3733,64 +3632,42 @@
                     <a:bodyPr/>
                     <a:lstStyle/>
                     <a:p>
-                      <a:pPr algn="l" indent="0" marL="0">
-                        <a:buNone/>
-                      </a:pPr>
                       <a:r>
-                        <a:rPr lang="en-US" sz="1200" dirty="0">
+                        <a:rPr sz="1200" b="0">
                           <a:solidFill>
                             <a:srgbClr val="1A1A1A"/>
                           </a:solidFill>
-                          <a:latin typeface="Microsoft YaHei" pitchFamily="34" charset="0"/>
-                          <a:ea typeface="Microsoft YaHei" pitchFamily="34" charset="-122"/>
-                          <a:cs typeface="Microsoft YaHei" pitchFamily="34" charset="-120"/>
+                          <a:latin typeface="微软雅黑"/>
                         </a:rPr>
-                        <a:t>DICE 初始 T 0.1–0.35 TPM；ImmGen 脾 T/Treg = 0 reads</a:t>
+                        <a:t>肺泡巨噬细胞（最强，阳性 &gt;90%）、树突状细胞</a:t>
                       </a:r>
-                      <a:endParaRPr lang="en-US" sz="1200" dirty="0">
-                        <a:latin typeface="Microsoft YaHei" charset="0"/>
-                        <a:ea typeface="Microsoft YaHei" charset="0"/>
-                        <a:cs typeface="Microsoft YaHei" charset="0"/>
-                      </a:endParaRPr>
                     </a:p>
                   </a:txBody>
-                  <a:tcPr marL="76200" marR="76200" marT="50800" marB="50800" anchor="ctr">
-                    <a:lnL w="12700" cap="flat" cmpd="sng" algn="ctr">
-                      <a:solidFill>
-                        <a:srgbClr val="D8DBE0"/>
-                      </a:solidFill>
-                      <a:prstDash val="solid"/>
-                      <a:round/>
-                      <a:headEnd type="none" w="med" len="med"/>
-                      <a:tailEnd type="none" w="med" len="med"/>
-                    </a:lnL>
-                    <a:lnR w="12700" cap="flat" cmpd="sng" algn="ctr">
-                      <a:solidFill>
-                        <a:srgbClr val="D8DBE0"/>
-                      </a:solidFill>
-                      <a:prstDash val="solid"/>
-                      <a:round/>
-                      <a:headEnd type="none" w="med" len="med"/>
-                      <a:tailEnd type="none" w="med" len="med"/>
-                    </a:lnR>
-                    <a:lnT w="12700" cap="flat" cmpd="sng" algn="ctr">
-                      <a:solidFill>
-                        <a:srgbClr val="D8DBE0"/>
-                      </a:solidFill>
-                      <a:prstDash val="solid"/>
-                      <a:round/>
-                      <a:headEnd type="none" w="med" len="med"/>
-                      <a:tailEnd type="none" w="med" len="med"/>
-                    </a:lnT>
-                    <a:lnB w="12700" cap="flat" cmpd="sng" algn="ctr">
-                      <a:solidFill>
-                        <a:srgbClr val="D8DBE0"/>
-                      </a:solidFill>
-                      <a:prstDash val="solid"/>
-                      <a:round/>
-                      <a:headEnd type="none" w="med" len="med"/>
-                      <a:tailEnd type="none" w="med" len="med"/>
-                    </a:lnB>
+                  <a:tcPr marL="82296" marR="82296" marT="36576" marB="36576" anchor="ctr">
+                    <a:solidFill>
+                      <a:srgbClr val="FFFFFF"/>
+                    </a:solidFill>
+                  </a:tcPr>
+                </a:tc>
+              </a:tr>
+              <a:tr h="594360">
+                <a:tc>
+                  <a:txBody>
+                    <a:bodyPr/>
+                    <a:lstStyle/>
+                    <a:p>
+                      <a:r>
+                        <a:rPr sz="1200" b="1">
+                          <a:solidFill>
+                            <a:srgbClr val="1A1A1A"/>
+                          </a:solidFill>
+                          <a:latin typeface="微软雅黑"/>
+                        </a:rPr>
+                        <a:t>甲型流感</a:t>
+                      </a:r>
+                    </a:p>
+                  </a:txBody>
+                  <a:tcPr marL="82296" marR="82296" marT="36576" marB="36576" anchor="ctr">
                     <a:solidFill>
                       <a:srgbClr val="FFFFFF"/>
                     </a:solidFill>
@@ -3801,134 +3678,18 @@
                     <a:bodyPr/>
                     <a:lstStyle/>
                     <a:p>
-                      <a:pPr algn="l" indent="0" marL="0">
-                        <a:buNone/>
-                      </a:pPr>
                       <a:r>
-                        <a:rPr lang="en-US" sz="1200" dirty="0">
+                        <a:rPr sz="1200" b="0">
                           <a:solidFill>
                             <a:srgbClr val="1A1A1A"/>
                           </a:solidFill>
-                          <a:latin typeface="Microsoft YaHei" pitchFamily="34" charset="0"/>
-                          <a:ea typeface="Microsoft YaHei" pitchFamily="34" charset="-122"/>
-                          <a:cs typeface="Microsoft YaHei" pitchFamily="34" charset="-120"/>
+                          <a:latin typeface="微软雅黑"/>
                         </a:rPr>
-                        <a:t>真零</a:t>
+                        <a:t>无合格单细胞数据（数据缺口）</a:t>
                       </a:r>
-                      <a:endParaRPr lang="en-US" sz="1200" dirty="0">
-                        <a:latin typeface="Microsoft YaHei" charset="0"/>
-                        <a:ea typeface="Microsoft YaHei" charset="0"/>
-                        <a:cs typeface="Microsoft YaHei" charset="0"/>
-                      </a:endParaRPr>
                     </a:p>
                   </a:txBody>
-                  <a:tcPr marL="76200" marR="76200" marT="50800" marB="50800" anchor="ctr">
-                    <a:lnL w="12700" cap="flat" cmpd="sng" algn="ctr">
-                      <a:solidFill>
-                        <a:srgbClr val="D8DBE0"/>
-                      </a:solidFill>
-                      <a:prstDash val="solid"/>
-                      <a:round/>
-                      <a:headEnd type="none" w="med" len="med"/>
-                      <a:tailEnd type="none" w="med" len="med"/>
-                    </a:lnL>
-                    <a:lnR w="12700" cap="flat" cmpd="sng" algn="ctr">
-                      <a:solidFill>
-                        <a:srgbClr val="D8DBE0"/>
-                      </a:solidFill>
-                      <a:prstDash val="solid"/>
-                      <a:round/>
-                      <a:headEnd type="none" w="med" len="med"/>
-                      <a:tailEnd type="none" w="med" len="med"/>
-                    </a:lnR>
-                    <a:lnT w="12700" cap="flat" cmpd="sng" algn="ctr">
-                      <a:solidFill>
-                        <a:srgbClr val="D8DBE0"/>
-                      </a:solidFill>
-                      <a:prstDash val="solid"/>
-                      <a:round/>
-                      <a:headEnd type="none" w="med" len="med"/>
-                      <a:tailEnd type="none" w="med" len="med"/>
-                    </a:lnT>
-                    <a:lnB w="12700" cap="flat" cmpd="sng" algn="ctr">
-                      <a:solidFill>
-                        <a:srgbClr val="D8DBE0"/>
-                      </a:solidFill>
-                      <a:prstDash val="solid"/>
-                      <a:round/>
-                      <a:headEnd type="none" w="med" len="med"/>
-                      <a:tailEnd type="none" w="med" len="med"/>
-                    </a:lnB>
-                    <a:solidFill>
-                      <a:srgbClr val="FFFFFF"/>
-                    </a:solidFill>
-                  </a:tcPr>
-                </a:tc>
-              </a:tr>
-              <a:tr h="548640">
-                <a:tc>
-                  <a:txBody>
-                    <a:bodyPr/>
-                    <a:lstStyle/>
-                    <a:p>
-                      <a:pPr algn="l" indent="0" marL="0">
-                        <a:buNone/>
-                      </a:pPr>
-                      <a:r>
-                        <a:rPr lang="en-US" sz="1200" dirty="0">
-                          <a:solidFill>
-                            <a:srgbClr val="1A1A1A"/>
-                          </a:solidFill>
-                          <a:latin typeface="Microsoft YaHei" pitchFamily="34" charset="0"/>
-                          <a:ea typeface="Microsoft YaHei" pitchFamily="34" charset="-122"/>
-                          <a:cs typeface="Microsoft YaHei" pitchFamily="34" charset="-120"/>
-                        </a:rPr>
-                        <a:t>B / 浆细胞</a:t>
-                      </a:r>
-                      <a:endParaRPr lang="en-US" sz="1200" dirty="0">
-                        <a:latin typeface="Microsoft YaHei" charset="0"/>
-                        <a:ea typeface="Microsoft YaHei" charset="0"/>
-                        <a:cs typeface="Microsoft YaHei" charset="0"/>
-                      </a:endParaRPr>
-                    </a:p>
-                  </a:txBody>
-                  <a:tcPr marL="76200" marR="76200" marT="50800" marB="50800" anchor="ctr">
-                    <a:lnL w="12700" cap="flat" cmpd="sng" algn="ctr">
-                      <a:solidFill>
-                        <a:srgbClr val="D8DBE0"/>
-                      </a:solidFill>
-                      <a:prstDash val="solid"/>
-                      <a:round/>
-                      <a:headEnd type="none" w="med" len="med"/>
-                      <a:tailEnd type="none" w="med" len="med"/>
-                    </a:lnL>
-                    <a:lnR w="12700" cap="flat" cmpd="sng" algn="ctr">
-                      <a:solidFill>
-                        <a:srgbClr val="D8DBE0"/>
-                      </a:solidFill>
-                      <a:prstDash val="solid"/>
-                      <a:round/>
-                      <a:headEnd type="none" w="med" len="med"/>
-                      <a:tailEnd type="none" w="med" len="med"/>
-                    </a:lnR>
-                    <a:lnT w="12700" cap="flat" cmpd="sng" algn="ctr">
-                      <a:solidFill>
-                        <a:srgbClr val="D8DBE0"/>
-                      </a:solidFill>
-                      <a:prstDash val="solid"/>
-                      <a:round/>
-                      <a:headEnd type="none" w="med" len="med"/>
-                      <a:tailEnd type="none" w="med" len="med"/>
-                    </a:lnT>
-                    <a:lnB w="12700" cap="flat" cmpd="sng" algn="ctr">
-                      <a:solidFill>
-                        <a:srgbClr val="D8DBE0"/>
-                      </a:solidFill>
-                      <a:prstDash val="solid"/>
-                      <a:round/>
-                      <a:headEnd type="none" w="med" len="med"/>
-                      <a:tailEnd type="none" w="med" len="med"/>
-                    </a:lnB>
+                  <a:tcPr marL="82296" marR="82296" marT="36576" marB="36576" anchor="ctr">
                     <a:solidFill>
                       <a:srgbClr val="FFFFFF"/>
                     </a:solidFill>
@@ -3939,64 +3700,42 @@
                     <a:bodyPr/>
                     <a:lstStyle/>
                     <a:p>
-                      <a:pPr algn="l" indent="0" marL="0">
-                        <a:buNone/>
-                      </a:pPr>
                       <a:r>
-                        <a:rPr lang="en-US" sz="1200" dirty="0">
+                        <a:rPr sz="1200" b="0">
                           <a:solidFill>
                             <a:srgbClr val="1A1A1A"/>
                           </a:solidFill>
-                          <a:latin typeface="Microsoft YaHei" pitchFamily="34" charset="0"/>
-                          <a:ea typeface="Microsoft YaHei" pitchFamily="34" charset="-122"/>
-                          <a:cs typeface="Microsoft YaHei" pitchFamily="34" charset="-120"/>
+                          <a:latin typeface="微软雅黑"/>
                         </a:rPr>
-                        <a:t>阳性 ≤5%</a:t>
+                        <a:t>肺泡巨噬细胞（感染全程第一）、树突状细胞</a:t>
                       </a:r>
-                      <a:endParaRPr lang="en-US" sz="1200" dirty="0">
-                        <a:latin typeface="Microsoft YaHei" charset="0"/>
-                        <a:ea typeface="Microsoft YaHei" charset="0"/>
-                        <a:cs typeface="Microsoft YaHei" charset="0"/>
-                      </a:endParaRPr>
                     </a:p>
                   </a:txBody>
-                  <a:tcPr marL="76200" marR="76200" marT="50800" marB="50800" anchor="ctr">
-                    <a:lnL w="12700" cap="flat" cmpd="sng" algn="ctr">
-                      <a:solidFill>
-                        <a:srgbClr val="D8DBE0"/>
-                      </a:solidFill>
-                      <a:prstDash val="solid"/>
-                      <a:round/>
-                      <a:headEnd type="none" w="med" len="med"/>
-                      <a:tailEnd type="none" w="med" len="med"/>
-                    </a:lnL>
-                    <a:lnR w="12700" cap="flat" cmpd="sng" algn="ctr">
-                      <a:solidFill>
-                        <a:srgbClr val="D8DBE0"/>
-                      </a:solidFill>
-                      <a:prstDash val="solid"/>
-                      <a:round/>
-                      <a:headEnd type="none" w="med" len="med"/>
-                      <a:tailEnd type="none" w="med" len="med"/>
-                    </a:lnR>
-                    <a:lnT w="12700" cap="flat" cmpd="sng" algn="ctr">
-                      <a:solidFill>
-                        <a:srgbClr val="D8DBE0"/>
-                      </a:solidFill>
-                      <a:prstDash val="solid"/>
-                      <a:round/>
-                      <a:headEnd type="none" w="med" len="med"/>
-                      <a:tailEnd type="none" w="med" len="med"/>
-                    </a:lnT>
-                    <a:lnB w="12700" cap="flat" cmpd="sng" algn="ctr">
-                      <a:solidFill>
-                        <a:srgbClr val="D8DBE0"/>
-                      </a:solidFill>
-                      <a:prstDash val="solid"/>
-                      <a:round/>
-                      <a:headEnd type="none" w="med" len="med"/>
-                      <a:tailEnd type="none" w="med" len="med"/>
-                    </a:lnB>
+                  <a:tcPr marL="82296" marR="82296" marT="36576" marB="36576" anchor="ctr">
+                    <a:solidFill>
+                      <a:srgbClr val="FFFFFF"/>
+                    </a:solidFill>
+                  </a:tcPr>
+                </a:tc>
+              </a:tr>
+              <a:tr h="594360">
+                <a:tc>
+                  <a:txBody>
+                    <a:bodyPr/>
+                    <a:lstStyle/>
+                    <a:p>
+                      <a:r>
+                        <a:rPr sz="1200" b="1">
+                          <a:solidFill>
+                            <a:srgbClr val="1A1A1A"/>
+                          </a:solidFill>
+                          <a:latin typeface="微软雅黑"/>
+                        </a:rPr>
+                        <a:t>SARS-CoV-2（新冠）</a:t>
+                      </a:r>
+                    </a:p>
+                  </a:txBody>
+                  <a:tcPr marL="82296" marR="82296" marT="36576" marB="36576" anchor="ctr">
                     <a:solidFill>
                       <a:srgbClr val="FFFFFF"/>
                     </a:solidFill>
@@ -4007,64 +3746,18 @@
                     <a:bodyPr/>
                     <a:lstStyle/>
                     <a:p>
-                      <a:pPr algn="l" indent="0" marL="0">
-                        <a:buNone/>
-                      </a:pPr>
                       <a:r>
-                        <a:rPr lang="en-US" sz="1200" dirty="0">
+                        <a:rPr sz="1200" b="0">
                           <a:solidFill>
                             <a:srgbClr val="1A1A1A"/>
                           </a:solidFill>
-                          <a:latin typeface="Microsoft YaHei" pitchFamily="34" charset="0"/>
-                          <a:ea typeface="Microsoft YaHei" pitchFamily="34" charset="-122"/>
-                          <a:cs typeface="Microsoft YaHei" pitchFamily="34" charset="-120"/>
+                          <a:latin typeface="微软雅黑"/>
                         </a:rPr>
-                        <a:t>DICE 初始 B 1.68 TPM；ImmGen 脾 B 20–47</a:t>
+                        <a:t>肺泡巨噬细胞、单核来源巨噬细胞、树突状细胞（与静息一致）</a:t>
                       </a:r>
-                      <a:endParaRPr lang="en-US" sz="1200" dirty="0">
-                        <a:latin typeface="Microsoft YaHei" charset="0"/>
-                        <a:ea typeface="Microsoft YaHei" charset="0"/>
-                        <a:cs typeface="Microsoft YaHei" charset="0"/>
-                      </a:endParaRPr>
                     </a:p>
                   </a:txBody>
-                  <a:tcPr marL="76200" marR="76200" marT="50800" marB="50800" anchor="ctr">
-                    <a:lnL w="12700" cap="flat" cmpd="sng" algn="ctr">
-                      <a:solidFill>
-                        <a:srgbClr val="D8DBE0"/>
-                      </a:solidFill>
-                      <a:prstDash val="solid"/>
-                      <a:round/>
-                      <a:headEnd type="none" w="med" len="med"/>
-                      <a:tailEnd type="none" w="med" len="med"/>
-                    </a:lnL>
-                    <a:lnR w="12700" cap="flat" cmpd="sng" algn="ctr">
-                      <a:solidFill>
-                        <a:srgbClr val="D8DBE0"/>
-                      </a:solidFill>
-                      <a:prstDash val="solid"/>
-                      <a:round/>
-                      <a:headEnd type="none" w="med" len="med"/>
-                      <a:tailEnd type="none" w="med" len="med"/>
-                    </a:lnR>
-                    <a:lnT w="12700" cap="flat" cmpd="sng" algn="ctr">
-                      <a:solidFill>
-                        <a:srgbClr val="D8DBE0"/>
-                      </a:solidFill>
-                      <a:prstDash val="solid"/>
-                      <a:round/>
-                      <a:headEnd type="none" w="med" len="med"/>
-                      <a:tailEnd type="none" w="med" len="med"/>
-                    </a:lnT>
-                    <a:lnB w="12700" cap="flat" cmpd="sng" algn="ctr">
-                      <a:solidFill>
-                        <a:srgbClr val="D8DBE0"/>
-                      </a:solidFill>
-                      <a:prstDash val="solid"/>
-                      <a:round/>
-                      <a:headEnd type="none" w="med" len="med"/>
-                      <a:tailEnd type="none" w="med" len="med"/>
-                    </a:lnB>
+                  <a:tcPr marL="82296" marR="82296" marT="36576" marB="36576" anchor="ctr">
                     <a:solidFill>
                       <a:srgbClr val="FFFFFF"/>
                     </a:solidFill>
@@ -4075,134 +3768,42 @@
                     <a:bodyPr/>
                     <a:lstStyle/>
                     <a:p>
-                      <a:pPr algn="l" indent="0" marL="0">
-                        <a:buNone/>
-                      </a:pPr>
                       <a:r>
-                        <a:rPr lang="en-US" sz="1200" dirty="0">
+                        <a:rPr sz="1200" b="0">
                           <a:solidFill>
                             <a:srgbClr val="1A1A1A"/>
                           </a:solidFill>
-                          <a:latin typeface="Microsoft YaHei" pitchFamily="34" charset="0"/>
-                          <a:ea typeface="Microsoft YaHei" pitchFamily="34" charset="-122"/>
-                          <a:cs typeface="Microsoft YaHei" pitchFamily="34" charset="-120"/>
+                          <a:latin typeface="微软雅黑"/>
                         </a:rPr>
-                        <a:t>低但非零</a:t>
+                        <a:t>无小鼠肺数据</a:t>
                       </a:r>
-                      <a:endParaRPr lang="en-US" sz="1200" dirty="0">
-                        <a:latin typeface="Microsoft YaHei" charset="0"/>
-                        <a:ea typeface="Microsoft YaHei" charset="0"/>
-                        <a:cs typeface="Microsoft YaHei" charset="0"/>
-                      </a:endParaRPr>
                     </a:p>
                   </a:txBody>
-                  <a:tcPr marL="76200" marR="76200" marT="50800" marB="50800" anchor="ctr">
-                    <a:lnL w="12700" cap="flat" cmpd="sng" algn="ctr">
-                      <a:solidFill>
-                        <a:srgbClr val="D8DBE0"/>
-                      </a:solidFill>
-                      <a:prstDash val="solid"/>
-                      <a:round/>
-                      <a:headEnd type="none" w="med" len="med"/>
-                      <a:tailEnd type="none" w="med" len="med"/>
-                    </a:lnL>
-                    <a:lnR w="12700" cap="flat" cmpd="sng" algn="ctr">
-                      <a:solidFill>
-                        <a:srgbClr val="D8DBE0"/>
-                      </a:solidFill>
-                      <a:prstDash val="solid"/>
-                      <a:round/>
-                      <a:headEnd type="none" w="med" len="med"/>
-                      <a:tailEnd type="none" w="med" len="med"/>
-                    </a:lnR>
-                    <a:lnT w="12700" cap="flat" cmpd="sng" algn="ctr">
-                      <a:solidFill>
-                        <a:srgbClr val="D8DBE0"/>
-                      </a:solidFill>
-                      <a:prstDash val="solid"/>
-                      <a:round/>
-                      <a:headEnd type="none" w="med" len="med"/>
-                      <a:tailEnd type="none" w="med" len="med"/>
-                    </a:lnT>
-                    <a:lnB w="12700" cap="flat" cmpd="sng" algn="ctr">
-                      <a:solidFill>
-                        <a:srgbClr val="D8DBE0"/>
-                      </a:solidFill>
-                      <a:prstDash val="solid"/>
-                      <a:round/>
-                      <a:headEnd type="none" w="med" len="med"/>
-                      <a:tailEnd type="none" w="med" len="med"/>
-                    </a:lnB>
+                  <a:tcPr marL="82296" marR="82296" marT="36576" marB="36576" anchor="ctr">
                     <a:solidFill>
                       <a:srgbClr val="FFFFFF"/>
                     </a:solidFill>
                   </a:tcPr>
                 </a:tc>
               </a:tr>
-              <a:tr h="548640">
+              <a:tr h="594360">
                 <a:tc>
                   <a:txBody>
                     <a:bodyPr/>
                     <a:lstStyle/>
                     <a:p>
-                      <a:pPr algn="l" indent="0" marL="0">
-                        <a:buNone/>
-                      </a:pPr>
                       <a:r>
-                        <a:rPr lang="en-US" sz="1200" dirty="0">
+                        <a:rPr sz="1200" b="1">
                           <a:solidFill>
                             <a:srgbClr val="1A1A1A"/>
                           </a:solidFill>
-                          <a:latin typeface="Microsoft YaHei" pitchFamily="34" charset="0"/>
-                          <a:ea typeface="Microsoft YaHei" pitchFamily="34" charset="-122"/>
-                          <a:cs typeface="Microsoft YaHei" pitchFamily="34" charset="-120"/>
+                          <a:latin typeface="微软雅黑"/>
                         </a:rPr>
-                        <a:t>内皮 / 成纤维 / 上皮</a:t>
+                        <a:t>细菌性肺炎</a:t>
                       </a:r>
-                      <a:endParaRPr lang="en-US" sz="1200" dirty="0">
-                        <a:latin typeface="Microsoft YaHei" charset="0"/>
-                        <a:ea typeface="Microsoft YaHei" charset="0"/>
-                        <a:cs typeface="Microsoft YaHei" charset="0"/>
-                      </a:endParaRPr>
                     </a:p>
                   </a:txBody>
-                  <a:tcPr marL="76200" marR="76200" marT="50800" marB="50800" anchor="ctr">
-                    <a:lnL w="12700" cap="flat" cmpd="sng" algn="ctr">
-                      <a:solidFill>
-                        <a:srgbClr val="D8DBE0"/>
-                      </a:solidFill>
-                      <a:prstDash val="solid"/>
-                      <a:round/>
-                      <a:headEnd type="none" w="med" len="med"/>
-                      <a:tailEnd type="none" w="med" len="med"/>
-                    </a:lnL>
-                    <a:lnR w="12700" cap="flat" cmpd="sng" algn="ctr">
-                      <a:solidFill>
-                        <a:srgbClr val="D8DBE0"/>
-                      </a:solidFill>
-                      <a:prstDash val="solid"/>
-                      <a:round/>
-                      <a:headEnd type="none" w="med" len="med"/>
-                      <a:tailEnd type="none" w="med" len="med"/>
-                    </a:lnR>
-                    <a:lnT w="12700" cap="flat" cmpd="sng" algn="ctr">
-                      <a:solidFill>
-                        <a:srgbClr val="D8DBE0"/>
-                      </a:solidFill>
-                      <a:prstDash val="solid"/>
-                      <a:round/>
-                      <a:headEnd type="none" w="med" len="med"/>
-                      <a:tailEnd type="none" w="med" len="med"/>
-                    </a:lnT>
-                    <a:lnB w="12700" cap="flat" cmpd="sng" algn="ctr">
-                      <a:solidFill>
-                        <a:srgbClr val="D8DBE0"/>
-                      </a:solidFill>
-                      <a:prstDash val="solid"/>
-                      <a:round/>
-                      <a:headEnd type="none" w="med" len="med"/>
-                      <a:tailEnd type="none" w="med" len="med"/>
-                    </a:lnB>
+                  <a:tcPr marL="82296" marR="82296" marT="36576" marB="36576" anchor="ctr">
                     <a:solidFill>
                       <a:srgbClr val="FFFFFF"/>
                     </a:solidFill>
@@ -4213,64 +3814,18 @@
                     <a:bodyPr/>
                     <a:lstStyle/>
                     <a:p>
-                      <a:pPr algn="l" indent="0" marL="0">
-                        <a:buNone/>
-                      </a:pPr>
                       <a:r>
-                        <a:rPr lang="en-US" sz="1200" dirty="0">
+                        <a:rPr sz="1200" b="0">
                           <a:solidFill>
                             <a:srgbClr val="1A1A1A"/>
                           </a:solidFill>
-                          <a:latin typeface="Microsoft YaHei" pitchFamily="34" charset="0"/>
-                          <a:ea typeface="Microsoft YaHei" pitchFamily="34" charset="-122"/>
-                          <a:cs typeface="Microsoft YaHei" pitchFamily="34" charset="-120"/>
+                          <a:latin typeface="微软雅黑"/>
                         </a:rPr>
-                        <a:t>阳性 ≤5%（上皮除外）</a:t>
+                        <a:t>无病原明确数据（非 COVID 肺炎 BALF：髓系居前）</a:t>
                       </a:r>
-                      <a:endParaRPr lang="en-US" sz="1200" dirty="0">
-                        <a:latin typeface="Microsoft YaHei" charset="0"/>
-                        <a:ea typeface="Microsoft YaHei" charset="0"/>
-                        <a:cs typeface="Microsoft YaHei" charset="0"/>
-                      </a:endParaRPr>
                     </a:p>
                   </a:txBody>
-                  <a:tcPr marL="76200" marR="76200" marT="50800" marB="50800" anchor="ctr">
-                    <a:lnL w="12700" cap="flat" cmpd="sng" algn="ctr">
-                      <a:solidFill>
-                        <a:srgbClr val="D8DBE0"/>
-                      </a:solidFill>
-                      <a:prstDash val="solid"/>
-                      <a:round/>
-                      <a:headEnd type="none" w="med" len="med"/>
-                      <a:tailEnd type="none" w="med" len="med"/>
-                    </a:lnL>
-                    <a:lnR w="12700" cap="flat" cmpd="sng" algn="ctr">
-                      <a:solidFill>
-                        <a:srgbClr val="D8DBE0"/>
-                      </a:solidFill>
-                      <a:prstDash val="solid"/>
-                      <a:round/>
-                      <a:headEnd type="none" w="med" len="med"/>
-                      <a:tailEnd type="none" w="med" len="med"/>
-                    </a:lnR>
-                    <a:lnT w="12700" cap="flat" cmpd="sng" algn="ctr">
-                      <a:solidFill>
-                        <a:srgbClr val="D8DBE0"/>
-                      </a:solidFill>
-                      <a:prstDash val="solid"/>
-                      <a:round/>
-                      <a:headEnd type="none" w="med" len="med"/>
-                      <a:tailEnd type="none" w="med" len="med"/>
-                    </a:lnT>
-                    <a:lnB w="12700" cap="flat" cmpd="sng" algn="ctr">
-                      <a:solidFill>
-                        <a:srgbClr val="D8DBE0"/>
-                      </a:solidFill>
-                      <a:prstDash val="solid"/>
-                      <a:round/>
-                      <a:headEnd type="none" w="med" len="med"/>
-                      <a:tailEnd type="none" w="med" len="med"/>
-                    </a:lnB>
+                  <a:tcPr marL="82296" marR="82296" marT="36576" marB="36576" anchor="ctr">
                     <a:solidFill>
                       <a:srgbClr val="FFFFFF"/>
                     </a:solidFill>
@@ -4281,64 +3836,42 @@
                     <a:bodyPr/>
                     <a:lstStyle/>
                     <a:p>
-                      <a:pPr algn="l" indent="0" marL="0">
-                        <a:buNone/>
-                      </a:pPr>
                       <a:r>
-                        <a:rPr lang="en-US" sz="1200" dirty="0">
+                        <a:rPr sz="1200" b="0">
                           <a:solidFill>
                             <a:srgbClr val="1A1A1A"/>
                           </a:solidFill>
-                          <a:latin typeface="Microsoft YaHei" pitchFamily="34" charset="0"/>
-                          <a:ea typeface="Microsoft YaHei" pitchFamily="34" charset="-122"/>
-                          <a:cs typeface="Microsoft YaHei" pitchFamily="34" charset="-120"/>
+                          <a:latin typeface="微软雅黑"/>
                         </a:rPr>
-                        <a:t>DICE/ImmGen 无对应分选群体</a:t>
+                        <a:t>肺泡巨噬细胞、树突状细胞（肺炎链球菌 / 鲍曼不动杆菌）</a:t>
                       </a:r>
-                      <a:endParaRPr lang="en-US" sz="1200" dirty="0">
-                        <a:latin typeface="Microsoft YaHei" charset="0"/>
-                        <a:ea typeface="Microsoft YaHei" charset="0"/>
-                        <a:cs typeface="Microsoft YaHei" charset="0"/>
-                      </a:endParaRPr>
                     </a:p>
                   </a:txBody>
-                  <a:tcPr marL="76200" marR="76200" marT="50800" marB="50800" anchor="ctr">
-                    <a:lnL w="12700" cap="flat" cmpd="sng" algn="ctr">
-                      <a:solidFill>
-                        <a:srgbClr val="D8DBE0"/>
-                      </a:solidFill>
-                      <a:prstDash val="solid"/>
-                      <a:round/>
-                      <a:headEnd type="none" w="med" len="med"/>
-                      <a:tailEnd type="none" w="med" len="med"/>
-                    </a:lnL>
-                    <a:lnR w="12700" cap="flat" cmpd="sng" algn="ctr">
-                      <a:solidFill>
-                        <a:srgbClr val="D8DBE0"/>
-                      </a:solidFill>
-                      <a:prstDash val="solid"/>
-                      <a:round/>
-                      <a:headEnd type="none" w="med" len="med"/>
-                      <a:tailEnd type="none" w="med" len="med"/>
-                    </a:lnR>
-                    <a:lnT w="12700" cap="flat" cmpd="sng" algn="ctr">
-                      <a:solidFill>
-                        <a:srgbClr val="D8DBE0"/>
-                      </a:solidFill>
-                      <a:prstDash val="solid"/>
-                      <a:round/>
-                      <a:headEnd type="none" w="med" len="med"/>
-                      <a:tailEnd type="none" w="med" len="med"/>
-                    </a:lnT>
-                    <a:lnB w="12700" cap="flat" cmpd="sng" algn="ctr">
-                      <a:solidFill>
-                        <a:srgbClr val="D8DBE0"/>
-                      </a:solidFill>
-                      <a:prstDash val="solid"/>
-                      <a:round/>
-                      <a:headEnd type="none" w="med" len="med"/>
-                      <a:tailEnd type="none" w="med" len="med"/>
-                    </a:lnB>
+                  <a:tcPr marL="82296" marR="82296" marT="36576" marB="36576" anchor="ctr">
+                    <a:solidFill>
+                      <a:srgbClr val="FFFFFF"/>
+                    </a:solidFill>
+                  </a:tcPr>
+                </a:tc>
+              </a:tr>
+              <a:tr h="594360">
+                <a:tc>
+                  <a:txBody>
+                    <a:bodyPr/>
+                    <a:lstStyle/>
+                    <a:p>
+                      <a:r>
+                        <a:rPr sz="1200" b="1">
+                          <a:solidFill>
+                            <a:srgbClr val="1A1A1A"/>
+                          </a:solidFill>
+                          <a:latin typeface="微软雅黑"/>
+                        </a:rPr>
+                        <a:t>LPS 急性肺损伤</a:t>
+                      </a:r>
+                    </a:p>
+                  </a:txBody>
+                  <a:tcPr marL="82296" marR="82296" marT="36576" marB="36576" anchor="ctr">
                     <a:solidFill>
                       <a:srgbClr val="FFFFFF"/>
                     </a:solidFill>
@@ -4349,134 +3882,18 @@
                     <a:bodyPr/>
                     <a:lstStyle/>
                     <a:p>
-                      <a:pPr algn="l" indent="0" marL="0">
-                        <a:buNone/>
-                      </a:pPr>
                       <a:r>
-                        <a:rPr lang="en-US" sz="1200" dirty="0">
+                        <a:rPr sz="1200" b="0">
                           <a:solidFill>
                             <a:srgbClr val="1A1A1A"/>
                           </a:solidFill>
-                          <a:latin typeface="Microsoft YaHei" pitchFamily="34" charset="0"/>
-                          <a:ea typeface="Microsoft YaHei" pitchFamily="34" charset="-122"/>
-                          <a:cs typeface="Microsoft YaHei" pitchFamily="34" charset="-120"/>
+                          <a:latin typeface="微软雅黑"/>
                         </a:rPr>
-                        <a:t>无 bulk 可判（上皮由 decontX 判定）</a:t>
+                        <a:t>无合格单细胞数据</a:t>
                       </a:r>
-                      <a:endParaRPr lang="en-US" sz="1200" dirty="0">
-                        <a:latin typeface="Microsoft YaHei" charset="0"/>
-                        <a:ea typeface="Microsoft YaHei" charset="0"/>
-                        <a:cs typeface="Microsoft YaHei" charset="0"/>
-                      </a:endParaRPr>
                     </a:p>
                   </a:txBody>
-                  <a:tcPr marL="76200" marR="76200" marT="50800" marB="50800" anchor="ctr">
-                    <a:lnL w="12700" cap="flat" cmpd="sng" algn="ctr">
-                      <a:solidFill>
-                        <a:srgbClr val="D8DBE0"/>
-                      </a:solidFill>
-                      <a:prstDash val="solid"/>
-                      <a:round/>
-                      <a:headEnd type="none" w="med" len="med"/>
-                      <a:tailEnd type="none" w="med" len="med"/>
-                    </a:lnL>
-                    <a:lnR w="12700" cap="flat" cmpd="sng" algn="ctr">
-                      <a:solidFill>
-                        <a:srgbClr val="D8DBE0"/>
-                      </a:solidFill>
-                      <a:prstDash val="solid"/>
-                      <a:round/>
-                      <a:headEnd type="none" w="med" len="med"/>
-                      <a:tailEnd type="none" w="med" len="med"/>
-                    </a:lnR>
-                    <a:lnT w="12700" cap="flat" cmpd="sng" algn="ctr">
-                      <a:solidFill>
-                        <a:srgbClr val="D8DBE0"/>
-                      </a:solidFill>
-                      <a:prstDash val="solid"/>
-                      <a:round/>
-                      <a:headEnd type="none" w="med" len="med"/>
-                      <a:tailEnd type="none" w="med" len="med"/>
-                    </a:lnT>
-                    <a:lnB w="12700" cap="flat" cmpd="sng" algn="ctr">
-                      <a:solidFill>
-                        <a:srgbClr val="D8DBE0"/>
-                      </a:solidFill>
-                      <a:prstDash val="solid"/>
-                      <a:round/>
-                      <a:headEnd type="none" w="med" len="med"/>
-                      <a:tailEnd type="none" w="med" len="med"/>
-                    </a:lnB>
-                    <a:solidFill>
-                      <a:srgbClr val="FFFFFF"/>
-                    </a:solidFill>
-                  </a:tcPr>
-                </a:tc>
-              </a:tr>
-              <a:tr h="548640">
-                <a:tc>
-                  <a:txBody>
-                    <a:bodyPr/>
-                    <a:lstStyle/>
-                    <a:p>
-                      <a:pPr algn="l" indent="0" marL="0">
-                        <a:buNone/>
-                      </a:pPr>
-                      <a:r>
-                        <a:rPr lang="en-US" sz="1200" dirty="0">
-                          <a:solidFill>
-                            <a:srgbClr val="1A1A1A"/>
-                          </a:solidFill>
-                          <a:latin typeface="Microsoft YaHei" pitchFamily="34" charset="0"/>
-                          <a:ea typeface="Microsoft YaHei" pitchFamily="34" charset="-122"/>
-                          <a:cs typeface="Microsoft YaHei" pitchFamily="34" charset="-120"/>
-                        </a:rPr>
-                        <a:t>髓系（巨噬/DC/单核）</a:t>
-                      </a:r>
-                      <a:endParaRPr lang="en-US" sz="1200" dirty="0">
-                        <a:latin typeface="Microsoft YaHei" charset="0"/>
-                        <a:ea typeface="Microsoft YaHei" charset="0"/>
-                        <a:cs typeface="Microsoft YaHei" charset="0"/>
-                      </a:endParaRPr>
-                    </a:p>
-                  </a:txBody>
-                  <a:tcPr marL="76200" marR="76200" marT="50800" marB="50800" anchor="ctr">
-                    <a:lnL w="12700" cap="flat" cmpd="sng" algn="ctr">
-                      <a:solidFill>
-                        <a:srgbClr val="D8DBE0"/>
-                      </a:solidFill>
-                      <a:prstDash val="solid"/>
-                      <a:round/>
-                      <a:headEnd type="none" w="med" len="med"/>
-                      <a:tailEnd type="none" w="med" len="med"/>
-                    </a:lnL>
-                    <a:lnR w="12700" cap="flat" cmpd="sng" algn="ctr">
-                      <a:solidFill>
-                        <a:srgbClr val="D8DBE0"/>
-                      </a:solidFill>
-                      <a:prstDash val="solid"/>
-                      <a:round/>
-                      <a:headEnd type="none" w="med" len="med"/>
-                      <a:tailEnd type="none" w="med" len="med"/>
-                    </a:lnR>
-                    <a:lnT w="12700" cap="flat" cmpd="sng" algn="ctr">
-                      <a:solidFill>
-                        <a:srgbClr val="D8DBE0"/>
-                      </a:solidFill>
-                      <a:prstDash val="solid"/>
-                      <a:round/>
-                      <a:headEnd type="none" w="med" len="med"/>
-                      <a:tailEnd type="none" w="med" len="med"/>
-                    </a:lnT>
-                    <a:lnB w="12700" cap="flat" cmpd="sng" algn="ctr">
-                      <a:solidFill>
-                        <a:srgbClr val="D8DBE0"/>
-                      </a:solidFill>
-                      <a:prstDash val="solid"/>
-                      <a:round/>
-                      <a:headEnd type="none" w="med" len="med"/>
-                      <a:tailEnd type="none" w="med" len="med"/>
-                    </a:lnB>
+                  <a:tcPr marL="82296" marR="82296" marT="36576" marB="36576" anchor="ctr">
                     <a:solidFill>
                       <a:srgbClr val="FFFFFF"/>
                     </a:solidFill>
@@ -4487,200 +3904,18 @@
                     <a:bodyPr/>
                     <a:lstStyle/>
                     <a:p>
-                      <a:pPr algn="l" indent="0" marL="0">
-                        <a:buNone/>
-                      </a:pPr>
                       <a:r>
-                        <a:rPr lang="en-US" sz="1200" dirty="0">
+                        <a:rPr sz="1200" b="0">
                           <a:solidFill>
                             <a:srgbClr val="1A1A1A"/>
                           </a:solidFill>
-                          <a:latin typeface="Microsoft YaHei" pitchFamily="34" charset="0"/>
-                          <a:ea typeface="Microsoft YaHei" pitchFamily="34" charset="-122"/>
-                          <a:cs typeface="Microsoft YaHei" pitchFamily="34" charset="-120"/>
+                          <a:latin typeface="微软雅黑"/>
                         </a:rPr>
-                        <a:t>阳性高</a:t>
+                        <a:t>肺泡巨噬细胞（对照与 LPS 均第一）、单核来源巨噬细胞、树突状细胞</a:t>
                       </a:r>
-                      <a:endParaRPr lang="en-US" sz="1200" dirty="0">
-                        <a:latin typeface="Microsoft YaHei" charset="0"/>
-                        <a:ea typeface="Microsoft YaHei" charset="0"/>
-                        <a:cs typeface="Microsoft YaHei" charset="0"/>
-                      </a:endParaRPr>
                     </a:p>
                   </a:txBody>
-                  <a:tcPr marL="76200" marR="76200" marT="50800" marB="50800" anchor="ctr">
-                    <a:lnL w="12700" cap="flat" cmpd="sng" algn="ctr">
-                      <a:solidFill>
-                        <a:srgbClr val="D8DBE0"/>
-                      </a:solidFill>
-                      <a:prstDash val="solid"/>
-                      <a:round/>
-                      <a:headEnd type="none" w="med" len="med"/>
-                      <a:tailEnd type="none" w="med" len="med"/>
-                    </a:lnL>
-                    <a:lnR w="12700" cap="flat" cmpd="sng" algn="ctr">
-                      <a:solidFill>
-                        <a:srgbClr val="D8DBE0"/>
-                      </a:solidFill>
-                      <a:prstDash val="solid"/>
-                      <a:round/>
-                      <a:headEnd type="none" w="med" len="med"/>
-                      <a:tailEnd type="none" w="med" len="med"/>
-                    </a:lnR>
-                    <a:lnT w="12700" cap="flat" cmpd="sng" algn="ctr">
-                      <a:solidFill>
-                        <a:srgbClr val="D8DBE0"/>
-                      </a:solidFill>
-                      <a:prstDash val="solid"/>
-                      <a:round/>
-                      <a:headEnd type="none" w="med" len="med"/>
-                      <a:tailEnd type="none" w="med" len="med"/>
-                    </a:lnT>
-                    <a:lnB w="12700" cap="flat" cmpd="sng" algn="ctr">
-                      <a:solidFill>
-                        <a:srgbClr val="D8DBE0"/>
-                      </a:solidFill>
-                      <a:prstDash val="solid"/>
-                      <a:round/>
-                      <a:headEnd type="none" w="med" len="med"/>
-                      <a:tailEnd type="none" w="med" len="med"/>
-                    </a:lnB>
-                    <a:solidFill>
-                      <a:srgbClr val="FFFFFF"/>
-                    </a:solidFill>
-                  </a:tcPr>
-                </a:tc>
-                <a:tc>
-                  <a:txBody>
-                    <a:bodyPr/>
-                    <a:lstStyle/>
-                    <a:p>
-                      <a:pPr algn="l" indent="0" marL="0">
-                        <a:buNone/>
-                      </a:pPr>
-                      <a:r>
-                        <a:rPr lang="en-US" sz="1200" dirty="0">
-                          <a:solidFill>
-                            <a:srgbClr val="1A1A1A"/>
-                          </a:solidFill>
-                          <a:latin typeface="Microsoft YaHei" pitchFamily="34" charset="0"/>
-                          <a:ea typeface="Microsoft YaHei" pitchFamily="34" charset="-122"/>
-                          <a:cs typeface="Microsoft YaHei" pitchFamily="34" charset="-120"/>
-                        </a:rPr>
-                        <a:t>DICE 单核 13–30 TPM；ImmGen 肺泡巨噬 &gt;2000</a:t>
-                      </a:r>
-                      <a:endParaRPr lang="en-US" sz="1200" dirty="0">
-                        <a:latin typeface="Microsoft YaHei" charset="0"/>
-                        <a:ea typeface="Microsoft YaHei" charset="0"/>
-                        <a:cs typeface="Microsoft YaHei" charset="0"/>
-                      </a:endParaRPr>
-                    </a:p>
-                  </a:txBody>
-                  <a:tcPr marL="76200" marR="76200" marT="50800" marB="50800" anchor="ctr">
-                    <a:lnL w="12700" cap="flat" cmpd="sng" algn="ctr">
-                      <a:solidFill>
-                        <a:srgbClr val="D8DBE0"/>
-                      </a:solidFill>
-                      <a:prstDash val="solid"/>
-                      <a:round/>
-                      <a:headEnd type="none" w="med" len="med"/>
-                      <a:tailEnd type="none" w="med" len="med"/>
-                    </a:lnL>
-                    <a:lnR w="12700" cap="flat" cmpd="sng" algn="ctr">
-                      <a:solidFill>
-                        <a:srgbClr val="D8DBE0"/>
-                      </a:solidFill>
-                      <a:prstDash val="solid"/>
-                      <a:round/>
-                      <a:headEnd type="none" w="med" len="med"/>
-                      <a:tailEnd type="none" w="med" len="med"/>
-                    </a:lnR>
-                    <a:lnT w="12700" cap="flat" cmpd="sng" algn="ctr">
-                      <a:solidFill>
-                        <a:srgbClr val="D8DBE0"/>
-                      </a:solidFill>
-                      <a:prstDash val="solid"/>
-                      <a:round/>
-                      <a:headEnd type="none" w="med" len="med"/>
-                      <a:tailEnd type="none" w="med" len="med"/>
-                    </a:lnT>
-                    <a:lnB w="12700" cap="flat" cmpd="sng" algn="ctr">
-                      <a:solidFill>
-                        <a:srgbClr val="D8DBE0"/>
-                      </a:solidFill>
-                      <a:prstDash val="solid"/>
-                      <a:round/>
-                      <a:headEnd type="none" w="med" len="med"/>
-                      <a:tailEnd type="none" w="med" len="med"/>
-                    </a:lnB>
-                    <a:solidFill>
-                      <a:srgbClr val="FFFFFF"/>
-                    </a:solidFill>
-                  </a:tcPr>
-                </a:tc>
-                <a:tc>
-                  <a:txBody>
-                    <a:bodyPr/>
-                    <a:lstStyle/>
-                    <a:p>
-                      <a:pPr algn="l" indent="0" marL="0">
-                        <a:buNone/>
-                      </a:pPr>
-                      <a:r>
-                        <a:rPr lang="en-US" sz="1200" dirty="0">
-                          <a:solidFill>
-                            <a:srgbClr val="1A1A1A"/>
-                          </a:solidFill>
-                          <a:latin typeface="Microsoft YaHei" pitchFamily="34" charset="0"/>
-                          <a:ea typeface="Microsoft YaHei" pitchFamily="34" charset="-122"/>
-                          <a:cs typeface="Microsoft YaHei" pitchFamily="34" charset="-120"/>
-                        </a:rPr>
-                        <a:t>一致的真表达</a:t>
-                      </a:r>
-                      <a:endParaRPr lang="en-US" sz="1200" dirty="0">
-                        <a:latin typeface="Microsoft YaHei" charset="0"/>
-                        <a:ea typeface="Microsoft YaHei" charset="0"/>
-                        <a:cs typeface="Microsoft YaHei" charset="0"/>
-                      </a:endParaRPr>
-                    </a:p>
-                  </a:txBody>
-                  <a:tcPr marL="76200" marR="76200" marT="50800" marB="50800" anchor="ctr">
-                    <a:lnL w="12700" cap="flat" cmpd="sng" algn="ctr">
-                      <a:solidFill>
-                        <a:srgbClr val="D8DBE0"/>
-                      </a:solidFill>
-                      <a:prstDash val="solid"/>
-                      <a:round/>
-                      <a:headEnd type="none" w="med" len="med"/>
-                      <a:tailEnd type="none" w="med" len="med"/>
-                    </a:lnL>
-                    <a:lnR w="12700" cap="flat" cmpd="sng" algn="ctr">
-                      <a:solidFill>
-                        <a:srgbClr val="D8DBE0"/>
-                      </a:solidFill>
-                      <a:prstDash val="solid"/>
-                      <a:round/>
-                      <a:headEnd type="none" w="med" len="med"/>
-                      <a:tailEnd type="none" w="med" len="med"/>
-                    </a:lnR>
-                    <a:lnT w="12700" cap="flat" cmpd="sng" algn="ctr">
-                      <a:solidFill>
-                        <a:srgbClr val="D8DBE0"/>
-                      </a:solidFill>
-                      <a:prstDash val="solid"/>
-                      <a:round/>
-                      <a:headEnd type="none" w="med" len="med"/>
-                      <a:tailEnd type="none" w="med" len="med"/>
-                    </a:lnT>
-                    <a:lnB w="12700" cap="flat" cmpd="sng" algn="ctr">
-                      <a:solidFill>
-                        <a:srgbClr val="D8DBE0"/>
-                      </a:solidFill>
-                      <a:prstDash val="solid"/>
-                      <a:round/>
-                      <a:headEnd type="none" w="med" len="med"/>
-                      <a:tailEnd type="none" w="med" len="med"/>
-                    </a:lnB>
+                  <a:tcPr marL="82296" marR="82296" marT="36576" marB="36576" anchor="ctr">
                     <a:solidFill>
                       <a:srgbClr val="FFFFFF"/>
                     </a:solidFill>
@@ -4693,428 +3928,49 @@
       </p:graphicFrame>
       <p:sp>
         <p:nvSpPr>
-          <p:cNvPr id="4" name="Text 1"/>
-          <p:cNvSpPr txBox="1"/>
-          <p:nvPr/>
-        </p:nvSpPr>
-        <p:spPr>
-          <a:xfrm>
-            <a:off x="640080" y="6327648"/>
-            <a:ext cx="10972800" cy="347472"/>
-          </a:xfrm>
-          <a:prstGeom prst="rect">
-            <a:avLst/>
-          </a:prstGeom>
-          <a:noFill/>
-          <a:ln/>
-        </p:spPr>
-        <p:txBody>
-          <a:bodyPr wrap="square" rtlCol="0" anchor="ctr"/>
-          <a:lstStyle/>
-          <a:p>
-            <a:pPr indent="0" marL="0">
-              <a:buNone/>
-            </a:pPr>
-            <a:r>
-              <a:rPr lang="en-US" sz="1050" dirty="0">
-                <a:solidFill>
-                  <a:srgbClr val="6B6B6B"/>
-                </a:solidFill>
-                <a:latin typeface="Microsoft YaHei" pitchFamily="34" charset="0"/>
-                <a:ea typeface="Microsoft YaHei" pitchFamily="34" charset="-122"/>
-                <a:cs typeface="Microsoft YaHei" pitchFamily="34" charset="-120"/>
-              </a:rPr>
-              <a:t>仅并列呈现，不做统计检验。完整表：results/il18_zero_check.tsv</a:t>
-            </a:r>
-            <a:endParaRPr lang="en-US" sz="1050" dirty="0"/>
-          </a:p>
-        </p:txBody>
-      </p:sp>
-    </p:spTree>
-  </p:cSld>
-  <p:clrMapOvr>
-    <a:masterClrMapping/>
-  </p:clrMapOvr>
-</p:sld>
-</file>
-
-<file path=ppt/slides/slide8.xml><?xml version="1.0" encoding="utf-8"?>
-<p:sld xmlns:a="http://schemas.openxmlformats.org/drawingml/2006/main" xmlns:r="http://schemas.openxmlformats.org/officeDocument/2006/relationships" xmlns:p="http://schemas.openxmlformats.org/presentationml/2006/main">
-  <p:cSld name="Slide 8">
-    <p:spTree>
-      <p:nvGrpSpPr>
-        <p:cNvPr id="1" name=""/>
-        <p:cNvGrpSpPr/>
-        <p:nvPr/>
-      </p:nvGrpSpPr>
-      <p:grpSpPr>
-        <a:xfrm>
-          <a:off x="0" y="0"/>
-          <a:ext cx="0" cy="0"/>
-          <a:chOff x="0" y="0"/>
-          <a:chExt cx="0" cy="0"/>
-        </a:xfrm>
-      </p:grpSpPr>
-      <p:sp>
-        <p:nvSpPr>
-          <p:cNvPr id="2" name="Text 0"/>
-          <p:cNvSpPr txBox="1"/>
-          <p:nvPr/>
-        </p:nvSpPr>
-        <p:spPr>
-          <a:xfrm>
-            <a:off x="640080" y="457200"/>
-            <a:ext cx="10972800" cy="640080"/>
-          </a:xfrm>
-          <a:prstGeom prst="rect">
-            <a:avLst/>
-          </a:prstGeom>
-          <a:noFill/>
-          <a:ln/>
-        </p:spPr>
-        <p:txBody>
-          <a:bodyPr wrap="square" rtlCol="0" anchor="ctr"/>
-          <a:lstStyle/>
-          <a:p>
-            <a:pPr indent="0" marL="0">
-              <a:buNone/>
-            </a:pPr>
-            <a:r>
-              <a:rPr lang="en-US" sz="2500" b="1" dirty="0">
+          <p:cNvPr id="5" name="TextBox 4"/>
+          <p:cNvSpPr txBox="1"/>
+          <p:nvPr/>
+        </p:nvSpPr>
+        <p:spPr>
+          <a:xfrm>
+            <a:off x="640080" y="5623560"/>
+            <a:ext cx="10972800" cy="1005840"/>
+          </a:xfrm>
+          <a:prstGeom prst="rect">
+            <a:avLst/>
+          </a:prstGeom>
+          <a:noFill/>
+        </p:spPr>
+        <p:txBody>
+          <a:bodyPr wrap="square">
+            <a:spAutoFit/>
+          </a:bodyPr>
+          <a:lstStyle/>
+          <a:p>
+            <a:pPr>
+              <a:lnSpc>
+                <a:spcPct val="120000"/>
+              </a:lnSpc>
+            </a:pPr>
+            <a:r>
+              <a:rPr sz="1350" b="1">
                 <a:solidFill>
                   <a:srgbClr val="1A1A1A"/>
                 </a:solidFill>
-                <a:latin typeface="Microsoft YaHei" pitchFamily="34" charset="0"/>
-                <a:ea typeface="Microsoft YaHei" pitchFamily="34" charset="-122"/>
-                <a:cs typeface="Microsoft YaHei" pitchFamily="34" charset="-120"/>
-              </a:rPr>
-              <a:t>数据缺口与偏离</a:t>
-            </a:r>
-            <a:endParaRPr lang="en-US" sz="2500" dirty="0"/>
-          </a:p>
-        </p:txBody>
-      </p:sp>
-      <p:sp>
-        <p:nvSpPr>
-          <p:cNvPr id="3" name="Text 1"/>
-          <p:cNvSpPr txBox="1"/>
-          <p:nvPr/>
-        </p:nvSpPr>
-        <p:spPr>
-          <a:xfrm>
-            <a:off x="640080" y="1417320"/>
-            <a:ext cx="2743200" cy="914400"/>
-          </a:xfrm>
-          <a:prstGeom prst="rect">
-            <a:avLst/>
-          </a:prstGeom>
-          <a:noFill/>
-          <a:ln/>
-        </p:spPr>
-        <p:txBody>
-          <a:bodyPr wrap="square" rtlCol="0" anchor="t"/>
-          <a:lstStyle/>
-          <a:p>
-            <a:pPr indent="0" marL="0">
-              <a:buNone/>
-            </a:pPr>
-            <a:r>
-              <a:rPr lang="en-US" sz="1350" b="1" dirty="0">
+                <a:latin typeface="微软雅黑"/>
+              </a:rPr>
+              <a:t>共同答案：</a:t>
+            </a:r>
+            <a:r>
+              <a:rPr sz="1350" b="0">
                 <a:solidFill>
                   <a:srgbClr val="1A1A1A"/>
                 </a:solidFill>
-                <a:latin typeface="Microsoft YaHei" pitchFamily="34" charset="0"/>
-                <a:ea typeface="Microsoft YaHei" pitchFamily="34" charset="-122"/>
-                <a:cs typeface="Microsoft YaHei" pitchFamily="34" charset="-120"/>
-              </a:rPr>
-              <a:t>人 · 甲型流感</a:t>
-            </a:r>
-            <a:endParaRPr lang="en-US" sz="1350" dirty="0"/>
-          </a:p>
-        </p:txBody>
-      </p:sp>
-      <p:sp>
-        <p:nvSpPr>
-          <p:cNvPr id="4" name="Text 2"/>
-          <p:cNvSpPr txBox="1"/>
-          <p:nvPr/>
-        </p:nvSpPr>
-        <p:spPr>
-          <a:xfrm>
-            <a:off x="3474720" y="1417320"/>
-            <a:ext cx="8046720" cy="914400"/>
-          </a:xfrm>
-          <a:prstGeom prst="rect">
-            <a:avLst/>
-          </a:prstGeom>
-          <a:noFill/>
-          <a:ln/>
-        </p:spPr>
-        <p:txBody>
-          <a:bodyPr wrap="square" rtlCol="0" anchor="t"/>
-          <a:lstStyle/>
-          <a:p>
-            <a:pPr indent="0" marL="0">
-              <a:lnSpc>
-                <a:spcPct val="118000"/>
-              </a:lnSpc>
-              <a:buNone/>
-            </a:pPr>
-            <a:r>
-              <a:rPr lang="en-US" sz="1300" dirty="0">
-                <a:solidFill>
-                  <a:srgbClr val="1A1A1A"/>
-                </a:solidFill>
-                <a:latin typeface="Microsoft YaHei" pitchFamily="34" charset="0"/>
-                <a:ea typeface="Microsoft YaHei" pitchFamily="34" charset="-122"/>
-                <a:cs typeface="Microsoft YaHei" pitchFamily="34" charset="-120"/>
-              </a:rPr>
-              <a:t>数据缺口：人肺流感单细胞几乎不存在（唯一候选为单供体离体肺）；未用鼻腔/外周血填补。</a:t>
-            </a:r>
-            <a:endParaRPr lang="en-US" sz="1300" dirty="0"/>
-          </a:p>
-        </p:txBody>
-      </p:sp>
-      <p:sp>
-        <p:nvSpPr>
-          <p:cNvPr id="5" name="Text 3"/>
-          <p:cNvSpPr txBox="1"/>
-          <p:nvPr/>
-        </p:nvSpPr>
-        <p:spPr>
-          <a:xfrm>
-            <a:off x="640080" y="2514600"/>
-            <a:ext cx="2743200" cy="914400"/>
-          </a:xfrm>
-          <a:prstGeom prst="rect">
-            <a:avLst/>
-          </a:prstGeom>
-          <a:noFill/>
-          <a:ln/>
-        </p:spPr>
-        <p:txBody>
-          <a:bodyPr wrap="square" rtlCol="0" anchor="t"/>
-          <a:lstStyle/>
-          <a:p>
-            <a:pPr indent="0" marL="0">
-              <a:buNone/>
-            </a:pPr>
-            <a:r>
-              <a:rPr lang="en-US" sz="1350" b="1" dirty="0">
-                <a:solidFill>
-                  <a:srgbClr val="1A1A1A"/>
-                </a:solidFill>
-                <a:latin typeface="Microsoft YaHei" pitchFamily="34" charset="0"/>
-                <a:ea typeface="Microsoft YaHei" pitchFamily="34" charset="-122"/>
-                <a:cs typeface="Microsoft YaHei" pitchFamily="34" charset="-120"/>
-              </a:rPr>
-              <a:t>人 · 细菌性肺炎</a:t>
-            </a:r>
-            <a:endParaRPr lang="en-US" sz="1350" dirty="0"/>
-          </a:p>
-        </p:txBody>
-      </p:sp>
-      <p:sp>
-        <p:nvSpPr>
-          <p:cNvPr id="6" name="Text 4"/>
-          <p:cNvSpPr txBox="1"/>
-          <p:nvPr/>
-        </p:nvSpPr>
-        <p:spPr>
-          <a:xfrm>
-            <a:off x="3474720" y="2514600"/>
-            <a:ext cx="8046720" cy="914400"/>
-          </a:xfrm>
-          <a:prstGeom prst="rect">
-            <a:avLst/>
-          </a:prstGeom>
-          <a:noFill/>
-          <a:ln/>
-        </p:spPr>
-        <p:txBody>
-          <a:bodyPr wrap="square" rtlCol="0" anchor="t"/>
-          <a:lstStyle/>
-          <a:p>
-            <a:pPr indent="0" marL="0">
-              <a:lnSpc>
-                <a:spcPct val="118000"/>
-              </a:lnSpc>
-              <a:buNone/>
-            </a:pPr>
-            <a:r>
-              <a:rPr lang="en-US" sz="1300" dirty="0">
-                <a:solidFill>
-                  <a:srgbClr val="1A1A1A"/>
-                </a:solidFill>
-                <a:latin typeface="Microsoft YaHei" pitchFamily="34" charset="0"/>
-                <a:ea typeface="Microsoft YaHei" pitchFamily="34" charset="-122"/>
-                <a:cs typeface="Microsoft YaHei" pitchFamily="34" charset="-120"/>
-              </a:rPr>
-              <a:t>无病原逐例明确的数据；仅以非 COVID 肺炎 BALF 作替代。</a:t>
-            </a:r>
-            <a:endParaRPr lang="en-US" sz="1300" dirty="0"/>
-          </a:p>
-        </p:txBody>
-      </p:sp>
-      <p:sp>
-        <p:nvSpPr>
-          <p:cNvPr id="7" name="Text 5"/>
-          <p:cNvSpPr txBox="1"/>
-          <p:nvPr/>
-        </p:nvSpPr>
-        <p:spPr>
-          <a:xfrm>
-            <a:off x="640080" y="3611880"/>
-            <a:ext cx="2743200" cy="914400"/>
-          </a:xfrm>
-          <a:prstGeom prst="rect">
-            <a:avLst/>
-          </a:prstGeom>
-          <a:noFill/>
-          <a:ln/>
-        </p:spPr>
-        <p:txBody>
-          <a:bodyPr wrap="square" rtlCol="0" anchor="t"/>
-          <a:lstStyle/>
-          <a:p>
-            <a:pPr indent="0" marL="0">
-              <a:buNone/>
-            </a:pPr>
-            <a:r>
-              <a:rPr lang="en-US" sz="1350" b="1" dirty="0">
-                <a:solidFill>
-                  <a:srgbClr val="1A1A1A"/>
-                </a:solidFill>
-                <a:latin typeface="Microsoft YaHei" pitchFamily="34" charset="0"/>
-                <a:ea typeface="Microsoft YaHei" pitchFamily="34" charset="-122"/>
-                <a:cs typeface="Microsoft YaHei" pitchFamily="34" charset="-120"/>
-              </a:rPr>
-              <a:t>人 · LPS 急性肺损伤</a:t>
-            </a:r>
-            <a:endParaRPr lang="en-US" sz="1350" dirty="0"/>
-          </a:p>
-        </p:txBody>
-      </p:sp>
-      <p:sp>
-        <p:nvSpPr>
-          <p:cNvPr id="8" name="Text 6"/>
-          <p:cNvSpPr txBox="1"/>
-          <p:nvPr/>
-        </p:nvSpPr>
-        <p:spPr>
-          <a:xfrm>
-            <a:off x="3474720" y="3611880"/>
-            <a:ext cx="8046720" cy="914400"/>
-          </a:xfrm>
-          <a:prstGeom prst="rect">
-            <a:avLst/>
-          </a:prstGeom>
-          <a:noFill/>
-          <a:ln/>
-        </p:spPr>
-        <p:txBody>
-          <a:bodyPr wrap="square" rtlCol="0" anchor="t"/>
-          <a:lstStyle/>
-          <a:p>
-            <a:pPr indent="0" marL="0">
-              <a:lnSpc>
-                <a:spcPct val="118000"/>
-              </a:lnSpc>
-              <a:buNone/>
-            </a:pPr>
-            <a:r>
-              <a:rPr lang="en-US" sz="1300" dirty="0">
-                <a:solidFill>
-                  <a:srgbClr val="1A1A1A"/>
-                </a:solidFill>
-                <a:latin typeface="Microsoft YaHei" pitchFamily="34" charset="0"/>
-                <a:ea typeface="Microsoft YaHei" pitchFamily="34" charset="-122"/>
-                <a:cs typeface="Microsoft YaHei" pitchFamily="34" charset="-120"/>
-              </a:rPr>
-              <a:t>无合格单细胞数据（仅 BAL 刺激、无对照）。</a:t>
-            </a:r>
-            <a:endParaRPr lang="en-US" sz="1300" dirty="0"/>
-          </a:p>
-        </p:txBody>
-      </p:sp>
-      <p:sp>
-        <p:nvSpPr>
-          <p:cNvPr id="9" name="Text 7"/>
-          <p:cNvSpPr txBox="1"/>
-          <p:nvPr/>
-        </p:nvSpPr>
-        <p:spPr>
-          <a:xfrm>
-            <a:off x="640080" y="4709160"/>
-            <a:ext cx="2743200" cy="914400"/>
-          </a:xfrm>
-          <a:prstGeom prst="rect">
-            <a:avLst/>
-          </a:prstGeom>
-          <a:noFill/>
-          <a:ln/>
-        </p:spPr>
-        <p:txBody>
-          <a:bodyPr wrap="square" rtlCol="0" anchor="t"/>
-          <a:lstStyle/>
-          <a:p>
-            <a:pPr indent="0" marL="0">
-              <a:buNone/>
-            </a:pPr>
-            <a:r>
-              <a:rPr lang="en-US" sz="1350" b="1" dirty="0">
-                <a:solidFill>
-                  <a:srgbClr val="1A1A1A"/>
-                </a:solidFill>
-                <a:latin typeface="Microsoft YaHei" pitchFamily="34" charset="0"/>
-                <a:ea typeface="Microsoft YaHei" pitchFamily="34" charset="-122"/>
-                <a:cs typeface="Microsoft YaHei" pitchFamily="34" charset="-120"/>
-              </a:rPr>
-              <a:t>小鼠 · LPS 急性肺损伤</a:t>
-            </a:r>
-            <a:endParaRPr lang="en-US" sz="1350" dirty="0"/>
-          </a:p>
-        </p:txBody>
-      </p:sp>
-      <p:sp>
-        <p:nvSpPr>
-          <p:cNvPr id="10" name="Text 8"/>
-          <p:cNvSpPr txBox="1"/>
-          <p:nvPr/>
-        </p:nvSpPr>
-        <p:spPr>
-          <a:xfrm>
-            <a:off x="3474720" y="4709160"/>
-            <a:ext cx="8046720" cy="914400"/>
-          </a:xfrm>
-          <a:prstGeom prst="rect">
-            <a:avLst/>
-          </a:prstGeom>
-          <a:noFill/>
-          <a:ln/>
-        </p:spPr>
-        <p:txBody>
-          <a:bodyPr wrap="square" rtlCol="0" anchor="t"/>
-          <a:lstStyle/>
-          <a:p>
-            <a:pPr indent="0" marL="0">
-              <a:lnSpc>
-                <a:spcPct val="118000"/>
-              </a:lnSpc>
-              <a:buNone/>
-            </a:pPr>
-            <a:r>
-              <a:rPr lang="en-US" sz="1300" dirty="0">
-                <a:solidFill>
-                  <a:srgbClr val="1A1A1A"/>
-                </a:solidFill>
-                <a:latin typeface="Microsoft YaHei" pitchFamily="34" charset="0"/>
-                <a:ea typeface="Microsoft YaHei" pitchFamily="34" charset="-122"/>
-                <a:cs typeface="Microsoft YaHei" pitchFamily="34" charset="-120"/>
-              </a:rPr>
-              <a:t>已纳入 GSE280364、GSE280611（全肺、2 vs 2、含对照）。因无作者注释，经授权采用自行注释（scanpy Leiden + marker），结果与其余数据一致（肺泡巨噬细胞排名第一）。</a:t>
-            </a:r>
-            <a:endParaRPr lang="en-US" sz="1300" dirty="0"/>
+                <a:latin typeface="微软雅黑"/>
+              </a:rPr>
+              <a:t>肺内 IL18（pro-IL-18）主要由髓系细胞转录——肺泡巨噬细胞、树突状细胞、单核来源巨噬细胞；人肺泡及气道上皮（AT1、气道）确有转录；T/NK、B、内皮、成纤维接近零。感染改变各群的细胞数量，不改变“哪些细胞转录 IL18”。</a:t>
+            </a:r>
           </a:p>
         </p:txBody>
       </p:sp>
@@ -5169,7 +4025,7 @@
     </a:clrScheme>
     <a:fontScheme name="Office">
       <a:majorFont>
-        <a:latin typeface="Calibri Light" panose="020F0302020204030204"/>
+        <a:latin typeface="Calibri Light"/>
         <a:ea typeface=""/>
         <a:cs typeface=""/>
         <a:font script="Jpan" typeface="游ゴシック Light"/>
@@ -5202,26 +4058,9 @@
         <a:font script="Viet" typeface="Times New Roman"/>
         <a:font script="Uigh" typeface="Microsoft Uighur"/>
         <a:font script="Geor" typeface="Sylfaen"/>
-        <a:font script="Armn" typeface="Arial"/>
-        <a:font script="Bugi" typeface="Leelawadee UI"/>
-        <a:font script="Bopo" typeface="Microsoft JhengHei"/>
-        <a:font script="Java" typeface="Javanese Text"/>
-        <a:font script="Lisu" typeface="Segoe UI"/>
-        <a:font script="Mymr" typeface="Myanmar Text"/>
-        <a:font script="Nkoo" typeface="Ebrima"/>
-        <a:font script="Olck" typeface="Nirmala UI"/>
-        <a:font script="Osma" typeface="Ebrima"/>
-        <a:font script="Phag" typeface="Phagspa"/>
-        <a:font script="Syrn" typeface="Estrangelo Edessa"/>
-        <a:font script="Syrj" typeface="Estrangelo Edessa"/>
-        <a:font script="Syre" typeface="Estrangelo Edessa"/>
-        <a:font script="Sora" typeface="Nirmala UI"/>
-        <a:font script="Tale" typeface="Microsoft Tai Le"/>
-        <a:font script="Talu" typeface="Microsoft New Tai Lue"/>
-        <a:font script="Tfng" typeface="Ebrima"/>
       </a:majorFont>
       <a:minorFont>
-        <a:latin typeface="Calibri" panose="020F0502020204030204"/>
+        <a:latin typeface="Calibri"/>
         <a:ea typeface=""/>
         <a:cs typeface=""/>
         <a:font script="Jpan" typeface="游ゴシック"/>
@@ -5254,23 +4093,6 @@
         <a:font script="Viet" typeface="Arial"/>
         <a:font script="Uigh" typeface="Microsoft Uighur"/>
         <a:font script="Geor" typeface="Sylfaen"/>
-        <a:font script="Armn" typeface="Arial"/>
-        <a:font script="Bugi" typeface="Leelawadee UI"/>
-        <a:font script="Bopo" typeface="Microsoft JhengHei"/>
-        <a:font script="Java" typeface="Javanese Text"/>
-        <a:font script="Lisu" typeface="Segoe UI"/>
-        <a:font script="Mymr" typeface="Myanmar Text"/>
-        <a:font script="Nkoo" typeface="Ebrima"/>
-        <a:font script="Olck" typeface="Nirmala UI"/>
-        <a:font script="Osma" typeface="Ebrima"/>
-        <a:font script="Phag" typeface="Phagspa"/>
-        <a:font script="Syrn" typeface="Estrangelo Edessa"/>
-        <a:font script="Syrj" typeface="Estrangelo Edessa"/>
-        <a:font script="Syre" typeface="Estrangelo Edessa"/>
-        <a:font script="Sora" typeface="Nirmala UI"/>
-        <a:font script="Tale" typeface="Microsoft Tai Le"/>
-        <a:font script="Talu" typeface="Microsoft New Tai Lue"/>
-        <a:font script="Tfng" typeface="Ebrima"/>
       </a:minorFont>
     </a:fontScheme>
     <a:fmtScheme name="Office">
@@ -5411,8 +4233,265 @@
       </a:bgFillStyleLst>
     </a:fmtScheme>
   </a:themeElements>
-  <a:objectDefaults/>
-  <a:extraClrSchemeLst/>
+  <a:extLst>
+    <a:ext uri="{05A4C25C-085E-4340-85A3-A5531E510DB2}">
+      <thm15:themeFamily xmlns:thm15="http://schemas.microsoft.com/office/thememl/2012/main" name="Office Theme" id="{62F939B6-93AF-4DB8-9C6B-D6C7DFDC589F}" vid="{4A3C46E8-61CC-4603-A589-7422A47A8E4A}"/>
+    </a:ext>
+  </a:extLst>
+</a:theme>
+</file>
+
+<file path=ppt/theme/theme2.xml><?xml version="1.0" encoding="utf-8"?>
+<a:theme xmlns:a="http://schemas.openxmlformats.org/drawingml/2006/main" name="Office Theme">
+  <a:themeElements>
+    <a:clrScheme name="Office">
+      <a:dk1>
+        <a:sysClr val="windowText" lastClr="000000"/>
+      </a:dk1>
+      <a:lt1>
+        <a:sysClr val="window" lastClr="FFFFFF"/>
+      </a:lt1>
+      <a:dk2>
+        <a:srgbClr val="44546A"/>
+      </a:dk2>
+      <a:lt2>
+        <a:srgbClr val="E7E6E6"/>
+      </a:lt2>
+      <a:accent1>
+        <a:srgbClr val="4472C4"/>
+      </a:accent1>
+      <a:accent2>
+        <a:srgbClr val="ED7D31"/>
+      </a:accent2>
+      <a:accent3>
+        <a:srgbClr val="A5A5A5"/>
+      </a:accent3>
+      <a:accent4>
+        <a:srgbClr val="FFC000"/>
+      </a:accent4>
+      <a:accent5>
+        <a:srgbClr val="5B9BD5"/>
+      </a:accent5>
+      <a:accent6>
+        <a:srgbClr val="70AD47"/>
+      </a:accent6>
+      <a:hlink>
+        <a:srgbClr val="0563C1"/>
+      </a:hlink>
+      <a:folHlink>
+        <a:srgbClr val="954F72"/>
+      </a:folHlink>
+    </a:clrScheme>
+    <a:fontScheme name="Office">
+      <a:majorFont>
+        <a:latin typeface="Calibri Light"/>
+        <a:ea typeface=""/>
+        <a:cs typeface=""/>
+        <a:font script="Jpan" typeface="游ゴシック Light"/>
+        <a:font script="Hang" typeface="맑은 고딕"/>
+        <a:font script="Hans" typeface="等线 Light"/>
+        <a:font script="Hant" typeface="新細明體"/>
+        <a:font script="Arab" typeface="Times New Roman"/>
+        <a:font script="Hebr" typeface="Times New Roman"/>
+        <a:font script="Thai" typeface="Angsana New"/>
+        <a:font script="Ethi" typeface="Nyala"/>
+        <a:font script="Beng" typeface="Vrinda"/>
+        <a:font script="Gujr" typeface="Shruti"/>
+        <a:font script="Khmr" typeface="MoolBoran"/>
+        <a:font script="Knda" typeface="Tunga"/>
+        <a:font script="Guru" typeface="Raavi"/>
+        <a:font script="Cans" typeface="Euphemia"/>
+        <a:font script="Cher" typeface="Plantagenet Cherokee"/>
+        <a:font script="Yiii" typeface="Microsoft Yi Baiti"/>
+        <a:font script="Tibt" typeface="Microsoft Himalaya"/>
+        <a:font script="Thaa" typeface="MV Boli"/>
+        <a:font script="Deva" typeface="Mangal"/>
+        <a:font script="Telu" typeface="Gautami"/>
+        <a:font script="Taml" typeface="Latha"/>
+        <a:font script="Syrc" typeface="Estrangelo Edessa"/>
+        <a:font script="Orya" typeface="Kalinga"/>
+        <a:font script="Mlym" typeface="Kartika"/>
+        <a:font script="Laoo" typeface="DokChampa"/>
+        <a:font script="Sinh" typeface="Iskoola Pota"/>
+        <a:font script="Mong" typeface="Mongolian Baiti"/>
+        <a:font script="Viet" typeface="Times New Roman"/>
+        <a:font script="Uigh" typeface="Microsoft Uighur"/>
+        <a:font script="Geor" typeface="Sylfaen"/>
+      </a:majorFont>
+      <a:minorFont>
+        <a:latin typeface="Calibri"/>
+        <a:ea typeface=""/>
+        <a:cs typeface=""/>
+        <a:font script="Jpan" typeface="游ゴシック"/>
+        <a:font script="Hang" typeface="맑은 고딕"/>
+        <a:font script="Hans" typeface="等线"/>
+        <a:font script="Hant" typeface="新細明體"/>
+        <a:font script="Arab" typeface="Arial"/>
+        <a:font script="Hebr" typeface="Arial"/>
+        <a:font script="Thai" typeface="Cordia New"/>
+        <a:font script="Ethi" typeface="Nyala"/>
+        <a:font script="Beng" typeface="Vrinda"/>
+        <a:font script="Gujr" typeface="Shruti"/>
+        <a:font script="Khmr" typeface="DaunPenh"/>
+        <a:font script="Knda" typeface="Tunga"/>
+        <a:font script="Guru" typeface="Raavi"/>
+        <a:font script="Cans" typeface="Euphemia"/>
+        <a:font script="Cher" typeface="Plantagenet Cherokee"/>
+        <a:font script="Yiii" typeface="Microsoft Yi Baiti"/>
+        <a:font script="Tibt" typeface="Microsoft Himalaya"/>
+        <a:font script="Thaa" typeface="MV Boli"/>
+        <a:font script="Deva" typeface="Mangal"/>
+        <a:font script="Telu" typeface="Gautami"/>
+        <a:font script="Taml" typeface="Latha"/>
+        <a:font script="Syrc" typeface="Estrangelo Edessa"/>
+        <a:font script="Orya" typeface="Kalinga"/>
+        <a:font script="Mlym" typeface="Kartika"/>
+        <a:font script="Laoo" typeface="DokChampa"/>
+        <a:font script="Sinh" typeface="Iskoola Pota"/>
+        <a:font script="Mong" typeface="Mongolian Baiti"/>
+        <a:font script="Viet" typeface="Arial"/>
+        <a:font script="Uigh" typeface="Microsoft Uighur"/>
+        <a:font script="Geor" typeface="Sylfaen"/>
+      </a:minorFont>
+    </a:fontScheme>
+    <a:fmtScheme name="Office">
+      <a:fillStyleLst>
+        <a:solidFill>
+          <a:schemeClr val="phClr"/>
+        </a:solidFill>
+        <a:gradFill rotWithShape="1">
+          <a:gsLst>
+            <a:gs pos="0">
+              <a:schemeClr val="phClr">
+                <a:lumMod val="110000"/>
+                <a:satMod val="105000"/>
+                <a:tint val="67000"/>
+              </a:schemeClr>
+            </a:gs>
+            <a:gs pos="50000">
+              <a:schemeClr val="phClr">
+                <a:lumMod val="105000"/>
+                <a:satMod val="103000"/>
+                <a:tint val="73000"/>
+              </a:schemeClr>
+            </a:gs>
+            <a:gs pos="100000">
+              <a:schemeClr val="phClr">
+                <a:lumMod val="105000"/>
+                <a:satMod val="109000"/>
+                <a:tint val="81000"/>
+              </a:schemeClr>
+            </a:gs>
+          </a:gsLst>
+          <a:lin ang="5400000" scaled="0"/>
+        </a:gradFill>
+        <a:gradFill rotWithShape="1">
+          <a:gsLst>
+            <a:gs pos="0">
+              <a:schemeClr val="phClr">
+                <a:satMod val="103000"/>
+                <a:lumMod val="102000"/>
+                <a:tint val="94000"/>
+              </a:schemeClr>
+            </a:gs>
+            <a:gs pos="50000">
+              <a:schemeClr val="phClr">
+                <a:satMod val="110000"/>
+                <a:lumMod val="100000"/>
+                <a:shade val="100000"/>
+              </a:schemeClr>
+            </a:gs>
+            <a:gs pos="100000">
+              <a:schemeClr val="phClr">
+                <a:lumMod val="99000"/>
+                <a:satMod val="120000"/>
+                <a:shade val="78000"/>
+              </a:schemeClr>
+            </a:gs>
+          </a:gsLst>
+          <a:lin ang="5400000" scaled="0"/>
+        </a:gradFill>
+      </a:fillStyleLst>
+      <a:lnStyleLst>
+        <a:ln w="6350" cap="flat" cmpd="sng" algn="ctr">
+          <a:solidFill>
+            <a:schemeClr val="phClr"/>
+          </a:solidFill>
+          <a:prstDash val="solid"/>
+          <a:miter lim="800000"/>
+        </a:ln>
+        <a:ln w="12700" cap="flat" cmpd="sng" algn="ctr">
+          <a:solidFill>
+            <a:schemeClr val="phClr"/>
+          </a:solidFill>
+          <a:prstDash val="solid"/>
+          <a:miter lim="800000"/>
+        </a:ln>
+        <a:ln w="19050" cap="flat" cmpd="sng" algn="ctr">
+          <a:solidFill>
+            <a:schemeClr val="phClr"/>
+          </a:solidFill>
+          <a:prstDash val="solid"/>
+          <a:miter lim="800000"/>
+        </a:ln>
+      </a:lnStyleLst>
+      <a:effectStyleLst>
+        <a:effectStyle>
+          <a:effectLst/>
+        </a:effectStyle>
+        <a:effectStyle>
+          <a:effectLst/>
+        </a:effectStyle>
+        <a:effectStyle>
+          <a:effectLst>
+            <a:outerShdw blurRad="57150" dist="19050" dir="5400000" algn="ctr" rotWithShape="0">
+              <a:srgbClr val="000000">
+                <a:alpha val="63000"/>
+              </a:srgbClr>
+            </a:outerShdw>
+          </a:effectLst>
+        </a:effectStyle>
+      </a:effectStyleLst>
+      <a:bgFillStyleLst>
+        <a:solidFill>
+          <a:schemeClr val="phClr"/>
+        </a:solidFill>
+        <a:solidFill>
+          <a:schemeClr val="phClr">
+            <a:tint val="95000"/>
+            <a:satMod val="170000"/>
+          </a:schemeClr>
+        </a:solidFill>
+        <a:gradFill rotWithShape="1">
+          <a:gsLst>
+            <a:gs pos="0">
+              <a:schemeClr val="phClr">
+                <a:tint val="93000"/>
+                <a:satMod val="150000"/>
+                <a:shade val="98000"/>
+                <a:lumMod val="102000"/>
+              </a:schemeClr>
+            </a:gs>
+            <a:gs pos="50000">
+              <a:schemeClr val="phClr">
+                <a:tint val="98000"/>
+                <a:satMod val="130000"/>
+                <a:shade val="90000"/>
+                <a:lumMod val="103000"/>
+              </a:schemeClr>
+            </a:gs>
+            <a:gs pos="100000">
+              <a:schemeClr val="phClr">
+                <a:shade val="63000"/>
+                <a:satMod val="120000"/>
+              </a:schemeClr>
+            </a:gs>
+          </a:gsLst>
+          <a:lin ang="5400000" scaled="0"/>
+        </a:gradFill>
+      </a:bgFillStyleLst>
+    </a:fmtScheme>
+  </a:themeElements>
   <a:extLst>
     <a:ext uri="{05A4C25C-085E-4340-85A3-A5531E510DB2}">
       <thm15:themeFamily xmlns:thm15="http://schemas.microsoft.com/office/thememl/2012/main" name="Office Theme" id="{62F939B6-93AF-4DB8-9C6B-D6C7DFDC589F}" vid="{4A3C46E8-61CC-4603-A589-7422A47A8E4A}"/>

</xml_diff>